<commit_message>
enrich poster content, adjust font sizes
</commit_message>
<xml_diff>
--- a/report/pitta_poster.pptx
+++ b/report/pitta_poster.pptx
@@ -18159,62 +18159,62 @@
               <a:defRPr/>
             </a:pPr>
             <a:r>
-              <a:rPr sz="1000"/>
-              <a:t>本作品基于 AMD PYNQ-Z2 (XC7Z020)，实现国家二级保护动物</a:t>
-            </a:r>
-          </a:p>
-          <a:p>
-            <a:r>
-              <a:rPr sz="1000"/>
-              <a:t>仙八色鸫的自动化声视协同监测。PL 侧 I2S 采集麦克风数据</a:t>
-            </a:r>
-          </a:p>
-          <a:p>
-            <a:r>
-              <a:rPr sz="1000"/>
-              <a:t>并集成 HLS GEMM 硬件加速核；PS 侧运行鸟鸣检测与 YOLOv8n</a:t>
-            </a:r>
-          </a:p>
-          <a:p>
-            <a:r>
-              <a:rPr sz="1000"/>
-              <a:t>视觉检测，实现鸣声触发→视觉确认→自动录像闭环。</a:t>
-            </a:r>
-          </a:p>
-          <a:p>
-            <a:r>
-              <a:rPr sz="1000"/>
+              <a:rPr sz="1000" b="1"/>
+              <a:t>背景：</a:t>
+            </a:r>
+          </a:p>
+          <a:p>
+            <a:r>
+              <a:rPr sz="1000" b="0"/>
+              <a:t>仙八色鸫是国家二级保护动物、IUCN 易危物种，野外监测需长时间蹲守。</a:t>
+            </a:r>
+          </a:p>
+          <a:p>
+            <a:r>
+              <a:rPr sz="1000" b="0"/>
+              <a:t>本系统在 PYNQ-Z2 上实现'鸣声检测-视觉确认-自动录像'全自动闭环。</a:t>
+            </a:r>
+          </a:p>
+          <a:p>
+            <a:r>
+              <a:rPr sz="1000" b="0"/>
               <a:t/>
             </a:r>
           </a:p>
           <a:p>
             <a:r>
-              <a:rPr sz="1000"/>
-              <a:t>关键技术点：</a:t>
-            </a:r>
-          </a:p>
-          <a:p>
-            <a:r>
-              <a:rPr sz="1000"/>
-              <a:t>1. 音频采集：PL 侧 I2S+AXI DMA，32kHz 实时流</a:t>
-            </a:r>
-          </a:p>
-          <a:p>
-            <a:r>
-              <a:rPr sz="1000"/>
-              <a:t>2. 硬件加速：HLS 定点 GEMM 核，纯核 4.64x 加速</a:t>
-            </a:r>
-          </a:p>
-          <a:p>
-            <a:r>
-              <a:rPr sz="1000"/>
-              <a:t>3. 声视协同：鸟鸣触发图像识别，减少空转</a:t>
-            </a:r>
-          </a:p>
-          <a:p>
-            <a:r>
-              <a:rPr sz="1000"/>
-              <a:t>4. 存在性录像：存储效率提升 5-10 倍</a:t>
+              <a:rPr sz="1000" b="1"/>
+              <a:t>技术方案：</a:t>
+            </a:r>
+          </a:p>
+          <a:p>
+            <a:r>
+              <a:rPr sz="1000" b="0"/>
+              <a:t>1. PL 侧 I2S+AXI DMA 采集 INMP441 麦克风，32kHz 实时流不占 CPU</a:t>
+            </a:r>
+          </a:p>
+          <a:p>
+            <a:r>
+              <a:rPr sz="1000" b="0"/>
+              <a:t>2. PS 侧 3 层 CNN 鸟鸣检测，阈值 0.985 触发视觉端</a:t>
+            </a:r>
+          </a:p>
+          <a:p>
+            <a:r>
+              <a:rPr sz="1000" b="0"/>
+              <a:t>3. USB 摄像头 + YOLOv8n(NCNN) 确认目标，自动抓拍录像</a:t>
+            </a:r>
+          </a:p>
+          <a:p>
+            <a:r>
+              <a:rPr sz="1000" b="0"/>
+              <a:t>4. Vitis HLS 定点 GEMM 核验证 conv1 硬件加速（纯核 4.64x）</a:t>
+            </a:r>
+          </a:p>
+          <a:p>
+            <a:r>
+              <a:rPr sz="1000" b="0"/>
+              <a:t>5. 目标存在性录像：misses=3 后结束，存储效率提升 5-10 倍</a:t>
             </a:r>
           </a:p>
         </p:txBody>
@@ -18259,7 +18259,7 @@
               </a:spcBef>
             </a:pPr>
             <a:r>
-              <a:rPr lang="en-US" sz="1800" b="1" dirty="0">
+              <a:rPr lang="en-US" sz="1600" b="1" dirty="0">
                 <a:solidFill>
                   <a:schemeClr val="bg1"/>
                 </a:solidFill>
@@ -18317,7 +18317,7 @@
               <a:defRPr/>
             </a:pPr>
             <a:r>
-              <a:rPr kumimoji="0" lang="en-US" sz="2400" b="1" i="0" u="none" strike="noStrike" kern="1200" cap="none" spc="0" normalizeH="0" baseline="0" noProof="0" dirty="0">
+              <a:rPr kumimoji="0" lang="en-US" sz="2800" b="1" i="0" u="none" strike="noStrike" kern="1200" cap="none" spc="0" normalizeH="0" baseline="0" noProof="0" dirty="0">
                 <a:ln>
                   <a:noFill/>
                 </a:ln>
@@ -18356,7 +18356,7 @@
               <a:t>：</a:t>
             </a:r>
             <a:r>
-              <a:rPr kumimoji="0" lang="en-US" altLang="zh-CN" sz="2400" b="1" i="0" u="none" strike="noStrike" kern="1200" cap="none" spc="0" normalizeH="0" baseline="0" noProof="0" dirty="0">
+              <a:rPr kumimoji="0" lang="en-US" altLang="zh-CN" sz="2800" b="1" i="0" u="none" strike="noStrike" kern="1200" cap="none" spc="0" normalizeH="0" baseline="0" noProof="0" dirty="0">
                 <a:ln>
                   <a:noFill/>
                 </a:ln>
@@ -19933,7 +19933,7 @@
               <a:defRPr/>
             </a:pPr>
             <a:r>
-              <a:rPr kumimoji="0" lang="en-US" altLang="zh-CN" sz="1000" b="1" i="1" u="none" strike="noStrike" kern="1200" cap="none" spc="0" normalizeH="0" baseline="0" noProof="0" dirty="0">
+              <a:rPr kumimoji="0" lang="en-US" altLang="zh-CN" sz="1100" b="1" i="1" u="none" strike="noStrike" kern="1200" cap="none" spc="0" normalizeH="0" baseline="0" noProof="0" dirty="0">
                 <a:ln>
                   <a:noFill/>
                 </a:ln>
@@ -19947,7 +19947,7 @@
                 <a:ea typeface="等线" panose="02010600030101010101" pitchFamily="2" charset="-122"/>
                 <a:cs typeface="Times New Roman" panose="02020603050405020304" pitchFamily="18" charset="0"/>
               </a:rPr>
-              <a:t>板端实测：PYNQ-Z2</a:t>
+              <a:t>板端实测：AMD PYNQ-Z2 (XC7Z020)</a:t>
             </a:r>
           </a:p>
         </p:txBody>
@@ -19998,7 +19998,7 @@
               <a:defRPr/>
             </a:pPr>
             <a:r>
-              <a:rPr sz="1200"/>
+              <a:rPr sz="1400" b="1"/>
               <a:t>武汉大学</a:t>
             </a:r>
           </a:p>
@@ -20609,8 +20609,8 @@
               <a:defRPr/>
             </a:pPr>
             <a:r>
-              <a:rPr sz="1000"/>
-              <a:t>音频事件级召回 97.4%</a:t>
+              <a:rPr sz="1000" b="1"/>
+              <a:t>实测性能</a:t>
             </a:r>
             <a:endParaRPr kumimoji="0" lang="en-US" altLang="zh-CN" sz="1100" b="0" i="0" u="none" strike="noStrike" kern="1200" cap="none" spc="0" normalizeH="0" baseline="0" noProof="0" dirty="0">
               <a:ln>
@@ -20629,26 +20629,44 @@
           </a:p>
           <a:p>
             <a:r>
-              <a:rPr sz="1000"/>
-              <a:t>图像独立测试召回 96.2%</a:t>
-            </a:r>
-          </a:p>
-          <a:p>
-            <a:r>
-              <a:rPr sz="1000"/>
-              <a:t>端到端触发延迟约 10.5s</a:t>
-            </a:r>
-          </a:p>
-          <a:p>
-            <a:r>
-              <a:rPr sz="1000"/>
-              <a:t>GEMM 纯核加速 4.64x</a:t>
-            </a:r>
-          </a:p>
-          <a:p>
-            <a:r>
-              <a:rPr sz="1000"/>
-              <a:t>音频 overlay LUT 仅占 3.15%</a:t>
+              <a:rPr sz="1000" b="0"/>
+              <a:t>• 音频事件级召回 97.4%（155 事件）</a:t>
+            </a:r>
+          </a:p>
+          <a:p>
+            <a:r>
+              <a:rPr sz="1000" b="0"/>
+              <a:t>• 图像独立测试召回 96.2%（266 图）</a:t>
+            </a:r>
+          </a:p>
+          <a:p>
+            <a:r>
+              <a:rPr sz="1000" b="0"/>
+              <a:t>• 音频窗口特异性 100%（2063 负样本）</a:t>
+            </a:r>
+          </a:p>
+          <a:p>
+            <a:r>
+              <a:rPr sz="1000" b="0"/>
+              <a:t>• 端到端触发延迟约 10.5s</a:t>
+            </a:r>
+          </a:p>
+          <a:p>
+            <a:r>
+              <a:rPr sz="1000" b="0"/>
+              <a:t>• GEMM 纯核加速 4.64x（端到端 0.59x）</a:t>
+            </a:r>
+          </a:p>
+          <a:p>
+            <a:r>
+              <a:rPr sz="1000" b="0"/>
+              <a:t>• 音频 overlay LUT 仅占 3.15%</a:t>
+            </a:r>
+          </a:p>
+          <a:p>
+            <a:r>
+              <a:rPr sz="1000" b="0"/>
+              <a:t>• 录像 37.4s / 187 帧 H.264</a:t>
             </a:r>
           </a:p>
         </p:txBody>
@@ -20826,7 +20844,7 @@
               <a:defRPr/>
             </a:pPr>
             <a:r>
-              <a:rPr kumimoji="0" lang="en-US" altLang="zh-CN" sz="1100" b="1" i="0" u="none" strike="noStrike" kern="1200" cap="none" spc="0" normalizeH="0" baseline="0" noProof="0" dirty="0">
+              <a:rPr kumimoji="0" lang="en-US" altLang="zh-CN" sz="1200" b="1" i="0" u="none" strike="noStrike" kern="1200" cap="none" spc="0" normalizeH="0" baseline="0" noProof="0" dirty="0">
                 <a:ln>
                   <a:noFill/>
                 </a:ln>
@@ -21057,26 +21075,38 @@
               <a:defRPr/>
             </a:pPr>
             <a:r>
-              <a:rPr sz="1000"/>
-              <a:t>音频采集与检测模块：</a:t>
-            </a:r>
-          </a:p>
-          <a:p>
-            <a:r>
-              <a:rPr sz="1000"/>
-              <a:t>1. INMP441 I2S 数字麦克风；</a:t>
-            </a:r>
-          </a:p>
-          <a:p>
-            <a:r>
-              <a:rPr sz="1000"/>
-              <a:t>2. STFT/Mel + 3 层 CNN 鸟鸣检测；</a:t>
-            </a:r>
-          </a:p>
-          <a:p>
-            <a:r>
-              <a:rPr sz="1000"/>
-              <a:t>3. 阈值 0.985 触发视觉端；</a:t>
+              <a:rPr sz="1000" b="1"/>
+              <a:t>音频采集与检测模块</a:t>
+            </a:r>
+          </a:p>
+          <a:p>
+            <a:r>
+              <a:rPr sz="1000" b="0"/>
+              <a:t>• INMP441 I2S 数字 MEMS 麦克风</a:t>
+            </a:r>
+          </a:p>
+          <a:p>
+            <a:r>
+              <a:rPr sz="1000" b="0"/>
+              <a:t>• 2s 窗口 → STFT/Mel [64,201]</a:t>
+            </a:r>
+          </a:p>
+          <a:p>
+            <a:r>
+              <a:rPr sz="1000" b="0"/>
+              <a:t>• 3 层 CNN + Sigmoid 输出鸟鸣概率</a:t>
+            </a:r>
+          </a:p>
+          <a:p>
+            <a:r>
+              <a:rPr sz="1000" b="0"/>
+              <a:t>• score ≥ 0.985 写触发文件</a:t>
+            </a:r>
+          </a:p>
+          <a:p>
+            <a:r>
+              <a:rPr sz="1000" b="0"/>
+              <a:t>• 录像期间自动暂停让出 CPU</a:t>
             </a:r>
           </a:p>
         </p:txBody>
@@ -21262,32 +21292,50 @@
               <a:defRPr/>
             </a:pPr>
             <a:r>
-              <a:rPr sz="1000"/>
-              <a:t>音频事件级召回 97.4%</a:t>
-            </a:r>
-          </a:p>
-          <a:p>
-            <a:r>
-              <a:rPr sz="1000"/>
-              <a:t>图像独立测试召回 96.2%</a:t>
-            </a:r>
-          </a:p>
-          <a:p>
-            <a:r>
-              <a:rPr sz="1000"/>
-              <a:t>端到端触发延迟约 10.5s</a:t>
-            </a:r>
-          </a:p>
-          <a:p>
-            <a:r>
-              <a:rPr sz="1000"/>
-              <a:t>GEMM 纯核加速 4.64x</a:t>
-            </a:r>
-          </a:p>
-          <a:p>
-            <a:r>
-              <a:rPr sz="1000"/>
-              <a:t>音频 overlay LUT 仅占 3.15%</a:t>
+              <a:rPr sz="1000" b="1"/>
+              <a:t>实测性能</a:t>
+            </a:r>
+          </a:p>
+          <a:p>
+            <a:r>
+              <a:rPr sz="1000" b="0"/>
+              <a:t>• 音频事件级召回 97.4%（155 事件）</a:t>
+            </a:r>
+          </a:p>
+          <a:p>
+            <a:r>
+              <a:rPr sz="1000" b="0"/>
+              <a:t>• 图像独立测试召回 96.2%（266 图）</a:t>
+            </a:r>
+          </a:p>
+          <a:p>
+            <a:r>
+              <a:rPr sz="1000" b="0"/>
+              <a:t>• 音频窗口特异性 100%（2063 负样本）</a:t>
+            </a:r>
+          </a:p>
+          <a:p>
+            <a:r>
+              <a:rPr sz="1000" b="0"/>
+              <a:t>• 端到端触发延迟约 10.5s</a:t>
+            </a:r>
+          </a:p>
+          <a:p>
+            <a:r>
+              <a:rPr sz="1000" b="0"/>
+              <a:t>• GEMM 纯核加速 4.64x（端到端 0.59x）</a:t>
+            </a:r>
+          </a:p>
+          <a:p>
+            <a:r>
+              <a:rPr sz="1000" b="0"/>
+              <a:t>• 音频 overlay LUT 仅占 3.15%</a:t>
+            </a:r>
+          </a:p>
+          <a:p>
+            <a:r>
+              <a:rPr sz="1000" b="0"/>
+              <a:t>• 录像 37.4s / 187 帧 H.264</a:t>
             </a:r>
           </a:p>
         </p:txBody>
@@ -23857,62 +23905,74 @@
               <a:defRPr/>
             </a:pPr>
             <a:r>
-              <a:rPr sz="1000"/>
-              <a:t>This project implements automated acoustic-visual monitoring</a:t>
-            </a:r>
-          </a:p>
-          <a:p>
-            <a:r>
-              <a:rPr sz="1000"/>
-              <a:t>for the Fairy Pitta (Pitta nympha), a national protected bird,</a:t>
-            </a:r>
-          </a:p>
-          <a:p>
-            <a:r>
-              <a:rPr sz="1000"/>
-              <a:t>on AMD PYNQ-Z2 (XC7Z020). PL-side I2S acquires mic data with</a:t>
-            </a:r>
-          </a:p>
-          <a:p>
-            <a:r>
-              <a:rPr sz="1000"/>
-              <a:t>HLS GEMM acceleration; PS runs bird call detection and YOLOv8n.</a:t>
-            </a:r>
-          </a:p>
-          <a:p>
-            <a:r>
-              <a:rPr sz="1000"/>
+              <a:rPr sz="1000" b="1"/>
+              <a:t>Background:</a:t>
+            </a:r>
+          </a:p>
+          <a:p>
+            <a:r>
+              <a:rPr sz="1000" b="0"/>
+              <a:t>Fairy Pitta (Pitta nympha) is a national protected species</a:t>
+            </a:r>
+          </a:p>
+          <a:p>
+            <a:r>
+              <a:rPr sz="1000" b="0"/>
+              <a:t>in China. Field monitoring requires long observation hours.</a:t>
+            </a:r>
+          </a:p>
+          <a:p>
+            <a:r>
+              <a:rPr sz="1000" b="0"/>
+              <a:t>This system achieves 'call detection-visual confirm-auto record'</a:t>
+            </a:r>
+          </a:p>
+          <a:p>
+            <a:r>
+              <a:rPr sz="1000" b="0"/>
+              <a:t>fully automated on a single PYNQ-Z2 board.</a:t>
+            </a:r>
+          </a:p>
+          <a:p>
+            <a:r>
+              <a:rPr sz="1000" b="0"/>
               <a:t/>
             </a:r>
           </a:p>
           <a:p>
             <a:r>
-              <a:rPr sz="1000"/>
-              <a:t>Key features:</a:t>
-            </a:r>
-          </a:p>
-          <a:p>
-            <a:r>
-              <a:rPr sz="1000"/>
-              <a:t>1. Audio: PL I2S+AXI DMA, 32kHz real-time stream</a:t>
-            </a:r>
-          </a:p>
-          <a:p>
-            <a:r>
-              <a:rPr sz="1000"/>
-              <a:t>2. Hardware: HLS fixed-point GEMM, 4.64x core speedup</a:t>
-            </a:r>
-          </a:p>
-          <a:p>
-            <a:r>
-              <a:rPr sz="1000"/>
-              <a:t>3. Fusion: bird call triggers camera, reduces idle inference</a:t>
-            </a:r>
-          </a:p>
-          <a:p>
-            <a:r>
-              <a:rPr sz="1000"/>
-              <a:t>4. Recording: storage efficiency improved 5-10x</a:t>
+              <a:rPr sz="1000" b="1"/>
+              <a:t>Approach:</a:t>
+            </a:r>
+          </a:p>
+          <a:p>
+            <a:r>
+              <a:rPr sz="1000" b="0"/>
+              <a:t>1. PL I2S+AXI DMA: 32kHz mic stream, zero CPU overhead</a:t>
+            </a:r>
+          </a:p>
+          <a:p>
+            <a:r>
+              <a:rPr sz="1000" b="0"/>
+              <a:t>2. PS 3-layer CNN bird call detection, trigger at 0.985</a:t>
+            </a:r>
+          </a:p>
+          <a:p>
+            <a:r>
+              <a:rPr sz="1000" b="0"/>
+              <a:t>3. USB camera + YOLOv8n (NCNN) confirmation + recording</a:t>
+            </a:r>
+          </a:p>
+          <a:p>
+            <a:r>
+              <a:rPr sz="1000" b="0"/>
+              <a:t>4. Vitis HLS GEMM IP for conv1 (4.64x core speedup)</a:t>
+            </a:r>
+          </a:p>
+          <a:p>
+            <a:r>
+              <a:rPr sz="1000" b="0"/>
+              <a:t>5. Presence-based recording: 5-10x storage efficiency</a:t>
             </a:r>
           </a:p>
         </p:txBody>
@@ -23957,7 +24017,7 @@
               </a:spcBef>
             </a:pPr>
             <a:r>
-              <a:rPr lang="en-US" sz="1800" b="1" dirty="0">
+              <a:rPr lang="en-US" sz="1600" b="1" dirty="0">
                 <a:solidFill>
                   <a:schemeClr val="bg1"/>
                 </a:solidFill>
@@ -24015,7 +24075,7 @@
               <a:defRPr/>
             </a:pPr>
             <a:r>
-              <a:rPr kumimoji="0" lang="en-US" sz="2400" b="1" i="0" u="none" strike="noStrike" kern="1200" cap="none" spc="0" normalizeH="0" baseline="0" noProof="0" dirty="0">
+              <a:rPr kumimoji="0" lang="en-US" sz="2800" b="1" i="0" u="none" strike="noStrike" kern="1200" cap="none" spc="0" normalizeH="0" baseline="0" noProof="0" dirty="0">
                 <a:ln>
                   <a:noFill/>
                 </a:ln>
@@ -24030,7 +24090,7 @@
                 <a:cs typeface="Times New Roman" panose="02020603050405020304" pitchFamily="18" charset="0"/>
                 <a:sym typeface="+mn-ea"/>
               </a:rPr>
-              <a:t>Acoustic-Visual Monitoring System for Fairy Pitta</a:t>
+              <a:t>Acoustic-Visual Collaborative Monitoring for Fairy Pitta</a:t>
             </a:r>
             <a:r>
               <a:rPr kumimoji="0" lang="zh-CN" altLang="en-US" sz="2400" b="1" i="0" u="none" strike="noStrike" kern="1200" cap="none" spc="0" normalizeH="0" baseline="0" noProof="0" dirty="0">
@@ -24054,7 +24114,7 @@
               <a:t>：</a:t>
             </a:r>
             <a:r>
-              <a:rPr kumimoji="0" lang="en-US" altLang="zh-CN" sz="2400" b="1" i="0" u="none" strike="noStrike" kern="1200" cap="none" spc="0" normalizeH="0" baseline="0" noProof="0" dirty="0">
+              <a:rPr kumimoji="0" lang="en-US" altLang="zh-CN" sz="2800" b="1" i="0" u="none" strike="noStrike" kern="1200" cap="none" spc="0" normalizeH="0" baseline="0" noProof="0" dirty="0">
                 <a:ln>
                   <a:noFill/>
                 </a:ln>
@@ -24072,7 +24132,7 @@
                 <a:cs typeface="Times New Roman" panose="02020603050405020304" pitchFamily="18" charset="0"/>
                 <a:sym typeface="+mn-ea"/>
               </a:rPr>
-              <a:t>Acoustic-Visual Monitoring System for Fairy Pitta</a:t>
+              <a:t>Acoustic-Visual Collaborative Monitoring for Fairy Pitta</a:t>
             </a:r>
             <a:r>
               <a:rPr kumimoji="0" lang="zh-CN" altLang="en-US" sz="2400" b="1" i="0" u="none" strike="noStrike" kern="1200" cap="none" spc="0" normalizeH="0" baseline="0" noProof="0" dirty="0">
@@ -25631,7 +25691,7 @@
               <a:defRPr/>
             </a:pPr>
             <a:r>
-              <a:rPr kumimoji="0" lang="en-US" altLang="zh-CN" sz="1000" b="1" i="1" u="none" strike="noStrike" kern="1200" cap="none" spc="0" normalizeH="0" baseline="0" noProof="0" dirty="0">
+              <a:rPr kumimoji="0" lang="en-US" altLang="zh-CN" sz="1100" b="1" i="1" u="none" strike="noStrike" kern="1200" cap="none" spc="0" normalizeH="0" baseline="0" noProof="0" dirty="0">
                 <a:ln>
                   <a:noFill/>
                 </a:ln>
@@ -25645,7 +25705,7 @@
                 <a:ea typeface="等线" panose="02010600030101010101" pitchFamily="2" charset="-122"/>
                 <a:cs typeface="Times New Roman" panose="02020603050405020304" pitchFamily="18" charset="0"/>
               </a:rPr>
-              <a:t>On-board test: AMD PYNQ-Z2</a:t>
+              <a:t>On-board: AMD PYNQ-Z2 (XC7Z020)</a:t>
             </a:r>
           </a:p>
         </p:txBody>
@@ -25696,8 +25756,8 @@
               <a:defRPr/>
             </a:pPr>
             <a:r>
-              <a:rPr sz="1200"/>
-              <a:t>Wuhan University,</a:t>
+              <a:rPr sz="1400" b="1"/>
+              <a:t>Wuhan University</a:t>
             </a:r>
           </a:p>
           <a:p>
@@ -26307,8 +26367,8 @@
               <a:defRPr/>
             </a:pPr>
             <a:r>
-              <a:rPr sz="1000"/>
-              <a:t>Audio event recall: 97.4%</a:t>
+              <a:rPr sz="1000" b="1"/>
+              <a:t>Performance Results</a:t>
             </a:r>
             <a:endParaRPr kumimoji="0" lang="en-US" altLang="zh-CN" sz="1100" b="0" i="0" u="none" strike="noStrike" kern="1200" cap="none" spc="0" normalizeH="0" baseline="0" noProof="0" dirty="0">
               <a:ln>
@@ -26327,26 +26387,44 @@
           </a:p>
           <a:p>
             <a:r>
-              <a:rPr sz="1000"/>
-              <a:t>Image recall: 96.2%</a:t>
-            </a:r>
-          </a:p>
-          <a:p>
-            <a:r>
-              <a:rPr sz="1000"/>
-              <a:t>End-to-end latency: ~10.5s</a:t>
-            </a:r>
-          </a:p>
-          <a:p>
-            <a:r>
-              <a:rPr sz="1000"/>
-              <a:t>GEMM core speedup: 4.64x</a:t>
-            </a:r>
-          </a:p>
-          <a:p>
-            <a:r>
-              <a:rPr sz="1000"/>
-              <a:t>Audio overlay LUT: only 3.15%</a:t>
+              <a:rPr sz="1000" b="0"/>
+              <a:t>- Audio event recall: 97.4% (155 events)</a:t>
+            </a:r>
+          </a:p>
+          <a:p>
+            <a:r>
+              <a:rPr sz="1000" b="0"/>
+              <a:t>- Image recall: 96.2% (266 independent images)</a:t>
+            </a:r>
+          </a:p>
+          <a:p>
+            <a:r>
+              <a:rPr sz="1000" b="0"/>
+              <a:t>- Audio specificity: 100% (2063 negatives)</a:t>
+            </a:r>
+          </a:p>
+          <a:p>
+            <a:r>
+              <a:rPr sz="1000" b="0"/>
+              <a:t>- End-to-end trigger latency: ~10.5s</a:t>
+            </a:r>
+          </a:p>
+          <a:p>
+            <a:r>
+              <a:rPr sz="1000" b="0"/>
+              <a:t>- GEMM core speedup: 4.64x (0.59x end-to-end)</a:t>
+            </a:r>
+          </a:p>
+          <a:p>
+            <a:r>
+              <a:rPr sz="1000" b="0"/>
+              <a:t>- Audio overlay LUT: only 3.15%</a:t>
+            </a:r>
+          </a:p>
+          <a:p>
+            <a:r>
+              <a:rPr sz="1000" b="0"/>
+              <a:t>- Recording: 37.4s / 187 frames H.264</a:t>
             </a:r>
           </a:p>
         </p:txBody>
@@ -26524,7 +26602,7 @@
               <a:defRPr/>
             </a:pPr>
             <a:r>
-              <a:rPr kumimoji="0" lang="en-US" altLang="zh-CN" sz="1100" b="1" i="0" u="none" strike="noStrike" kern="1200" cap="none" spc="0" normalizeH="0" baseline="0" noProof="0" dirty="0">
+              <a:rPr kumimoji="0" lang="en-US" altLang="zh-CN" sz="1200" b="1" i="0" u="none" strike="noStrike" kern="1200" cap="none" spc="0" normalizeH="0" baseline="0" noProof="0" dirty="0">
                 <a:ln>
                   <a:noFill/>
                 </a:ln>
@@ -26755,26 +26833,38 @@
               <a:defRPr/>
             </a:pPr>
             <a:r>
-              <a:rPr sz="1000"/>
-              <a:t>Audio Acquisition &amp; Detection:</a:t>
-            </a:r>
-          </a:p>
-          <a:p>
-            <a:r>
-              <a:rPr sz="1000"/>
-              <a:t>1. INMP441 I2S digital MEMS microphone;</a:t>
-            </a:r>
-          </a:p>
-          <a:p>
-            <a:r>
-              <a:rPr sz="1000"/>
-              <a:t>2. STFT/Mel + 3-layer CNN bird call detection;</a:t>
-            </a:r>
-          </a:p>
-          <a:p>
-            <a:r>
-              <a:rPr sz="1000"/>
-              <a:t>3. Trigger visual when score &gt; 0.985;</a:t>
+              <a:rPr sz="1000" b="1"/>
+              <a:t>Audio Acquisition &amp; Detection</a:t>
+            </a:r>
+          </a:p>
+          <a:p>
+            <a:r>
+              <a:rPr sz="1000" b="0"/>
+              <a:t>- INMP441 I2S digital MEMS microphone</a:t>
+            </a:r>
+          </a:p>
+          <a:p>
+            <a:r>
+              <a:rPr sz="1000" b="0"/>
+              <a:t>- 2s window to STFT/Mel [64,201]</a:t>
+            </a:r>
+          </a:p>
+          <a:p>
+            <a:r>
+              <a:rPr sz="1000" b="0"/>
+              <a:t>- 3-layer CNN + Sigmoid call probability</a:t>
+            </a:r>
+          </a:p>
+          <a:p>
+            <a:r>
+              <a:rPr sz="1000" b="0"/>
+              <a:t>- score &gt;= 0.985 triggers visual module</a:t>
+            </a:r>
+          </a:p>
+          <a:p>
+            <a:r>
+              <a:rPr sz="1000" b="0"/>
+              <a:t>- Pauses during recording to yield CPU</a:t>
             </a:r>
           </a:p>
         </p:txBody>
@@ -26960,32 +27050,50 @@
               <a:defRPr/>
             </a:pPr>
             <a:r>
-              <a:rPr sz="1000"/>
-              <a:t>Audio event recall: 97.4%</a:t>
-            </a:r>
-          </a:p>
-          <a:p>
-            <a:r>
-              <a:rPr sz="1000"/>
-              <a:t>Image recall: 96.2%</a:t>
-            </a:r>
-          </a:p>
-          <a:p>
-            <a:r>
-              <a:rPr sz="1000"/>
-              <a:t>End-to-end latency: ~10.5s</a:t>
-            </a:r>
-          </a:p>
-          <a:p>
-            <a:r>
-              <a:rPr sz="1000"/>
-              <a:t>GEMM core speedup: 4.64x</a:t>
-            </a:r>
-          </a:p>
-          <a:p>
-            <a:r>
-              <a:rPr sz="1000"/>
-              <a:t>Audio overlay LUT: only 3.15%</a:t>
+              <a:rPr sz="1000" b="1"/>
+              <a:t>Performance Results</a:t>
+            </a:r>
+          </a:p>
+          <a:p>
+            <a:r>
+              <a:rPr sz="1000" b="0"/>
+              <a:t>- Audio event recall: 97.4% (155 events)</a:t>
+            </a:r>
+          </a:p>
+          <a:p>
+            <a:r>
+              <a:rPr sz="1000" b="0"/>
+              <a:t>- Image recall: 96.2% (266 independent images)</a:t>
+            </a:r>
+          </a:p>
+          <a:p>
+            <a:r>
+              <a:rPr sz="1000" b="0"/>
+              <a:t>- Audio specificity: 100% (2063 negatives)</a:t>
+            </a:r>
+          </a:p>
+          <a:p>
+            <a:r>
+              <a:rPr sz="1000" b="0"/>
+              <a:t>- End-to-end trigger latency: ~10.5s</a:t>
+            </a:r>
+          </a:p>
+          <a:p>
+            <a:r>
+              <a:rPr sz="1000" b="0"/>
+              <a:t>- GEMM core speedup: 4.64x (0.59x end-to-end)</a:t>
+            </a:r>
+          </a:p>
+          <a:p>
+            <a:r>
+              <a:rPr sz="1000" b="0"/>
+              <a:t>- Audio overlay LUT: only 3.15%</a:t>
+            </a:r>
+          </a:p>
+          <a:p>
+            <a:r>
+              <a:rPr sz="1000" b="0"/>
+              <a:t>- Recording: 37.4s / 187 frames H.264</a:t>
             </a:r>
           </a:p>
         </p:txBody>
@@ -29263,24 +29371,8 @@
               <a:defRPr/>
             </a:pPr>
             <a:r>
-              <a:rPr kumimoji="0" lang="zh-CN" altLang="en-US" sz="1100" b="0" i="0" u="none" strike="noStrike" kern="1200" cap="none" spc="0" normalizeH="0" baseline="0" noProof="0" dirty="0">
-                <a:ln>
-                  <a:noFill/>
-                </a:ln>
-                <a:solidFill>
-                  <a:prstClr val="black"/>
-                </a:solidFill>
-                <a:effectLst/>
-                <a:highlight>
-                  <a:srgbClr val="FFFF00"/>
-                </a:highlight>
-                <a:uLnTx/>
-                <a:uFillTx/>
-                <a:latin typeface="Calibri" panose="020F0502020204030204"/>
-                <a:ea typeface="等线" panose="02010600030101010101" pitchFamily="2" charset="-122"/>
-                <a:cs typeface="+mn-cs"/>
-              </a:rPr>
-              <a:t>背景，关键信息摘要</a:t>
+              <a:rPr sz="1000" b="1"/>
+              <a:t>Background:</a:t>
             </a:r>
             <a:endParaRPr kumimoji="0" lang="en-US" sz="1100" b="0" i="0" u="none" strike="noStrike" kern="1200" cap="none" spc="0" normalizeH="0" baseline="0" noProof="0" dirty="0">
               <a:ln>
@@ -29299,6 +29391,72 @@
               <a:ea typeface="+mn-ea"/>
               <a:cs typeface="+mn-cs"/>
             </a:endParaRPr>
+          </a:p>
+          <a:p>
+            <a:r>
+              <a:rPr sz="1000" b="0"/>
+              <a:t>Fairy Pitta (Pitta nympha) is a national protected species</a:t>
+            </a:r>
+          </a:p>
+          <a:p>
+            <a:r>
+              <a:rPr sz="1000" b="0"/>
+              <a:t>in China. Field monitoring requires long observation hours.</a:t>
+            </a:r>
+          </a:p>
+          <a:p>
+            <a:r>
+              <a:rPr sz="1000" b="0"/>
+              <a:t>This system achieves 'call detection-visual confirm-auto record'</a:t>
+            </a:r>
+          </a:p>
+          <a:p>
+            <a:r>
+              <a:rPr sz="1000" b="0"/>
+              <a:t>fully automated on a single PYNQ-Z2 board.</a:t>
+            </a:r>
+          </a:p>
+          <a:p>
+            <a:r>
+              <a:rPr sz="1000" b="0"/>
+              <a:t/>
+            </a:r>
+          </a:p>
+          <a:p>
+            <a:r>
+              <a:rPr sz="1000" b="1"/>
+              <a:t>Approach:</a:t>
+            </a:r>
+          </a:p>
+          <a:p>
+            <a:r>
+              <a:rPr sz="1000" b="0"/>
+              <a:t>1. PL I2S+AXI DMA: 32kHz mic stream, zero CPU overhead</a:t>
+            </a:r>
+          </a:p>
+          <a:p>
+            <a:r>
+              <a:rPr sz="1000" b="0"/>
+              <a:t>2. PS 3-layer CNN bird call detection, trigger at 0.985</a:t>
+            </a:r>
+          </a:p>
+          <a:p>
+            <a:r>
+              <a:rPr sz="1000" b="0"/>
+              <a:t>3. USB camera + YOLOv8n (NCNN) confirmation + recording</a:t>
+            </a:r>
+          </a:p>
+          <a:p>
+            <a:r>
+              <a:rPr sz="1000" b="0"/>
+              <a:t>4. Vitis HLS GEMM IP for conv1 (4.64x core speedup)</a:t>
+            </a:r>
+          </a:p>
+          <a:p>
+            <a:r>
+              <a:rPr sz="1000" b="0"/>
+              <a:t>5. Presence-based recording: 5-10x storage efficiency</a:t>
+            </a:r>
           </a:p>
         </p:txBody>
       </p:sp>

</xml_diff>

<commit_message>
add WHU school logo to poster
</commit_message>
<xml_diff>
--- a/report/pitta_poster.pptx
+++ b/report/pitta_poster.pptx
@@ -20512,57 +20512,6 @@
           </a:prstGeom>
         </p:spPr>
       </p:pic>
-      <p:pic>
-        <p:nvPicPr>
-          <p:cNvPr id="40" name="Picture 11">
-            <a:extLst>
-              <a:ext uri="{FF2B5EF4-FFF2-40B4-BE49-F238E27FC236}">
-                <a16:creationId xmlns:a16="http://schemas.microsoft.com/office/drawing/2014/main" id="{E0DB31F2-788A-25AC-03C5-494E517C5C76}"/>
-              </a:ext>
-            </a:extLst>
-          </p:cNvPr>
-          <p:cNvPicPr>
-            <a:picLocks noChangeAspect="1" noChangeArrowheads="1"/>
-          </p:cNvPicPr>
-          <p:nvPr>
-            <p:custDataLst>
-              <p:tags r:id="rId1"/>
-            </p:custDataLst>
-          </p:nvPr>
-        </p:nvPicPr>
-        <p:blipFill rotWithShape="1">
-          <a:blip r:embed="rId5">
-            <a:extLst>
-              <a:ext uri="{28A0092B-C50C-407E-A947-70E740481C1C}">
-                <a14:useLocalDpi xmlns:a14="http://schemas.microsoft.com/office/drawing/2010/main" val="0"/>
-              </a:ext>
-            </a:extLst>
-          </a:blip>
-          <a:srcRect r="68900"/>
-          <a:stretch>
-            <a:fillRect/>
-          </a:stretch>
-        </p:blipFill>
-        <p:spPr bwMode="auto">
-          <a:xfrm>
-            <a:off x="9272973" y="163913"/>
-            <a:ext cx="728636" cy="721875"/>
-          </a:xfrm>
-          <a:prstGeom prst="rect">
-            <a:avLst/>
-          </a:prstGeom>
-          <a:noFill/>
-          <a:extLst>
-            <a:ext uri="{909E8E84-426E-40DD-AFC4-6F175D3DCCD1}">
-              <a14:hiddenFill xmlns:a14="http://schemas.microsoft.com/office/drawing/2010/main">
-                <a:solidFill>
-                  <a:srgbClr val="FFFFFF"/>
-                </a:solidFill>
-              </a14:hiddenFill>
-            </a:ext>
-          </a:extLst>
-        </p:spPr>
-      </p:pic>
       <p:sp>
         <p:nvSpPr>
           <p:cNvPr id="41" name="文本框 3">
@@ -23652,6 +23601,30 @@
           </a:p>
         </p:txBody>
       </p:sp>
+      <p:pic>
+        <p:nvPicPr>
+          <p:cNvPr id="58" name="Picture 57" descr="1.1-标准校徽.png"/>
+          <p:cNvPicPr>
+            <a:picLocks noChangeAspect="1"/>
+          </p:cNvPicPr>
+          <p:nvPr/>
+        </p:nvPicPr>
+        <p:blipFill>
+          <a:blip r:embed="rId9"/>
+          <a:stretch>
+            <a:fillRect/>
+          </a:stretch>
+        </p:blipFill>
+        <p:spPr>
+          <a:xfrm>
+            <a:off x="9272973" y="163913"/>
+            <a:ext cx="728636" cy="721875"/>
+          </a:xfrm>
+          <a:prstGeom prst="rect">
+            <a:avLst/>
+          </a:prstGeom>
+        </p:spPr>
+      </p:pic>
     </p:spTree>
     <p:extLst>
       <p:ext uri="{BB962C8B-B14F-4D97-AF65-F5344CB8AC3E}">
@@ -26270,57 +26243,6 @@
           </a:prstGeom>
         </p:spPr>
       </p:pic>
-      <p:pic>
-        <p:nvPicPr>
-          <p:cNvPr id="40" name="Picture 11">
-            <a:extLst>
-              <a:ext uri="{FF2B5EF4-FFF2-40B4-BE49-F238E27FC236}">
-                <a16:creationId xmlns:a16="http://schemas.microsoft.com/office/drawing/2014/main" id="{E0DB31F2-788A-25AC-03C5-494E517C5C76}"/>
-              </a:ext>
-            </a:extLst>
-          </p:cNvPr>
-          <p:cNvPicPr>
-            <a:picLocks noChangeAspect="1" noChangeArrowheads="1"/>
-          </p:cNvPicPr>
-          <p:nvPr>
-            <p:custDataLst>
-              <p:tags r:id="rId1"/>
-            </p:custDataLst>
-          </p:nvPr>
-        </p:nvPicPr>
-        <p:blipFill rotWithShape="1">
-          <a:blip r:embed="rId5">
-            <a:extLst>
-              <a:ext uri="{28A0092B-C50C-407E-A947-70E740481C1C}">
-                <a14:useLocalDpi xmlns:a14="http://schemas.microsoft.com/office/drawing/2010/main" val="0"/>
-              </a:ext>
-            </a:extLst>
-          </a:blip>
-          <a:srcRect r="68900"/>
-          <a:stretch>
-            <a:fillRect/>
-          </a:stretch>
-        </p:blipFill>
-        <p:spPr bwMode="auto">
-          <a:xfrm>
-            <a:off x="9272973" y="163913"/>
-            <a:ext cx="728636" cy="721875"/>
-          </a:xfrm>
-          <a:prstGeom prst="rect">
-            <a:avLst/>
-          </a:prstGeom>
-          <a:noFill/>
-          <a:extLst>
-            <a:ext uri="{909E8E84-426E-40DD-AFC4-6F175D3DCCD1}">
-              <a14:hiddenFill xmlns:a14="http://schemas.microsoft.com/office/drawing/2010/main">
-                <a:solidFill>
-                  <a:srgbClr val="FFFFFF"/>
-                </a:solidFill>
-              </a14:hiddenFill>
-            </a:ext>
-          </a:extLst>
-        </p:spPr>
-      </p:pic>
       <p:sp>
         <p:nvSpPr>
           <p:cNvPr id="41" name="文本框 3">
@@ -29460,6 +29382,30 @@
           </a:p>
         </p:txBody>
       </p:sp>
+      <p:pic>
+        <p:nvPicPr>
+          <p:cNvPr id="58" name="Picture 57" descr="1.1-标准校徽.png"/>
+          <p:cNvPicPr>
+            <a:picLocks noChangeAspect="1"/>
+          </p:cNvPicPr>
+          <p:nvPr/>
+        </p:nvPicPr>
+        <p:blipFill>
+          <a:blip r:embed="rId2"/>
+          <a:stretch>
+            <a:fillRect/>
+          </a:stretch>
+        </p:blipFill>
+        <p:spPr>
+          <a:xfrm>
+            <a:off x="9272973" y="163913"/>
+            <a:ext cx="728636" cy="721875"/>
+          </a:xfrm>
+          <a:prstGeom prst="rect">
+            <a:avLst/>
+          </a:prstGeom>
+        </p:spPr>
+      </p:pic>
     </p:spTree>
   </p:cSld>
   <p:clrMapOvr>

</xml_diff>

<commit_message>
final poster: bird photo + architecture diagram + AMD template layout
</commit_message>
<xml_diff>
--- a/report/pitta_poster.pptx
+++ b/report/pitta_poster.pptx
@@ -17949,133 +17949,16 @@
           <a:chExt cx="0" cy="0"/>
         </a:xfrm>
       </p:grpSpPr>
-      <p:cxnSp>
-        <p:nvCxnSpPr>
-          <p:cNvPr id="12" name="Straight Connector 11">
-            <a:extLst>
-              <a:ext uri="{FF2B5EF4-FFF2-40B4-BE49-F238E27FC236}">
-                <a16:creationId xmlns:a16="http://schemas.microsoft.com/office/drawing/2014/main" id="{C6959FA9-7E35-379E-77F4-1F6BBF5DF8D9}"/>
-              </a:ext>
-            </a:extLst>
-          </p:cNvPr>
-          <p:cNvCxnSpPr>
-            <a:cxnSpLocks/>
-          </p:cNvCxnSpPr>
-          <p:nvPr/>
-        </p:nvCxnSpPr>
-        <p:spPr>
-          <a:xfrm>
-            <a:off x="5986823" y="174738"/>
-            <a:ext cx="2322305" cy="1743280"/>
-          </a:xfrm>
-          <a:prstGeom prst="line">
-            <a:avLst/>
-          </a:prstGeom>
-          <a:ln w="12700"/>
-        </p:spPr>
-        <p:style>
-          <a:lnRef idx="1">
-            <a:schemeClr val="dk1"/>
-          </a:lnRef>
-          <a:fillRef idx="0">
-            <a:schemeClr val="dk1"/>
-          </a:fillRef>
-          <a:effectRef idx="0">
-            <a:schemeClr val="dk1"/>
-          </a:effectRef>
-          <a:fontRef idx="minor">
-            <a:schemeClr val="tx1"/>
-          </a:fontRef>
-        </p:style>
-      </p:cxnSp>
-      <p:cxnSp>
-        <p:nvCxnSpPr>
-          <p:cNvPr id="13" name="Straight Connector 12">
-            <a:extLst>
-              <a:ext uri="{FF2B5EF4-FFF2-40B4-BE49-F238E27FC236}">
-                <a16:creationId xmlns:a16="http://schemas.microsoft.com/office/drawing/2014/main" id="{933CCBA0-FAB3-2B8C-FF7C-6D01676E605B}"/>
-              </a:ext>
-            </a:extLst>
-          </p:cNvPr>
-          <p:cNvCxnSpPr>
-            <a:cxnSpLocks/>
-          </p:cNvCxnSpPr>
-          <p:nvPr/>
-        </p:nvCxnSpPr>
-        <p:spPr>
-          <a:xfrm flipV="1">
-            <a:off x="8309128" y="1906544"/>
-            <a:ext cx="3703067" cy="10740"/>
-          </a:xfrm>
-          <a:prstGeom prst="line">
-            <a:avLst/>
-          </a:prstGeom>
-          <a:ln w="12700"/>
-        </p:spPr>
-        <p:style>
-          <a:lnRef idx="1">
-            <a:schemeClr val="dk1"/>
-          </a:lnRef>
-          <a:fillRef idx="0">
-            <a:schemeClr val="dk1"/>
-          </a:fillRef>
-          <a:effectRef idx="0">
-            <a:schemeClr val="dk1"/>
-          </a:effectRef>
-          <a:fontRef idx="minor">
-            <a:schemeClr val="tx1"/>
-          </a:fontRef>
-        </p:style>
-      </p:cxnSp>
-      <p:cxnSp>
-        <p:nvCxnSpPr>
-          <p:cNvPr id="14" name="Straight Connector 13">
-            <a:extLst>
-              <a:ext uri="{FF2B5EF4-FFF2-40B4-BE49-F238E27FC236}">
-                <a16:creationId xmlns:a16="http://schemas.microsoft.com/office/drawing/2014/main" id="{F1E00891-515C-956C-17FC-86789D545647}"/>
-              </a:ext>
-            </a:extLst>
-          </p:cNvPr>
-          <p:cNvCxnSpPr>
-            <a:cxnSpLocks/>
-          </p:cNvCxnSpPr>
-          <p:nvPr/>
-        </p:nvCxnSpPr>
-        <p:spPr>
-          <a:xfrm>
-            <a:off x="8309128" y="1918018"/>
-            <a:ext cx="0" cy="4729429"/>
-          </a:xfrm>
-          <a:prstGeom prst="line">
-            <a:avLst/>
-          </a:prstGeom>
-          <a:ln w="12700"/>
-        </p:spPr>
-        <p:style>
-          <a:lnRef idx="1">
-            <a:schemeClr val="dk1"/>
-          </a:lnRef>
-          <a:fillRef idx="0">
-            <a:schemeClr val="dk1"/>
-          </a:fillRef>
-          <a:effectRef idx="0">
-            <a:schemeClr val="dk1"/>
-          </a:effectRef>
-          <a:fontRef idx="minor">
-            <a:schemeClr val="tx1"/>
-          </a:fontRef>
-        </p:style>
-      </p:cxnSp>
-      <p:sp>
-        <p:nvSpPr>
-          <p:cNvPr id="15" name="TextBox 14"/>
+      <p:sp>
+        <p:nvSpPr>
+          <p:cNvPr id="2" name="TextBox 1"/>
           <p:cNvSpPr txBox="1"/>
           <p:nvPr/>
         </p:nvSpPr>
         <p:spPr>
           <a:xfrm>
-            <a:off x="274320" y="274320"/>
-            <a:ext cx="6400800" cy="731520"/>
+            <a:off x="274320" y="182880"/>
+            <a:ext cx="6400800" cy="640080"/>
           </a:xfrm>
           <a:prstGeom prst="rect">
             <a:avLst/>
@@ -18089,7 +17972,7 @@
           <a:lstStyle/>
           <a:p>
             <a:r>
-              <a:rPr sz="3200" b="1">
+              <a:rPr sz="2800" b="1">
                 <a:solidFill>
                   <a:srgbClr val="1A1A2E"/>
                 </a:solidFill>
@@ -18099,44 +17982,9 @@
           </a:p>
         </p:txBody>
       </p:sp>
-      <p:sp>
-        <p:nvSpPr>
-          <p:cNvPr id="16" name="TextBox 15"/>
-          <p:cNvSpPr txBox="1"/>
-          <p:nvPr/>
-        </p:nvSpPr>
-        <p:spPr>
-          <a:xfrm>
-            <a:off x="6858000" y="274320"/>
-            <a:ext cx="2286000" cy="731520"/>
-          </a:xfrm>
-          <a:prstGeom prst="rect">
-            <a:avLst/>
-          </a:prstGeom>
-          <a:noFill/>
-        </p:spPr>
-        <p:txBody>
-          <a:bodyPr wrap="none">
-            <a:spAutoFit/>
-          </a:bodyPr>
-          <a:lstStyle/>
-          <a:p>
-            <a:r>
-              <a:rPr sz="1800" b="1"/>
-              <a:t>武汉大学</a:t>
-            </a:r>
-          </a:p>
-          <a:p>
-            <a:r>
-              <a:rPr sz="1400"/>
-              <a:t>电子信息学院</a:t>
-            </a:r>
-          </a:p>
-        </p:txBody>
-      </p:sp>
       <p:pic>
         <p:nvPicPr>
-          <p:cNvPr id="17" name="Picture 16" descr="1.1-标准校徽.png"/>
+          <p:cNvPr id="3" name="Picture 2" descr="1.1-标准校徽.png"/>
           <p:cNvPicPr>
             <a:picLocks noChangeAspect="1"/>
           </p:cNvPicPr>
@@ -18150,8 +17998,8 @@
         </p:blipFill>
         <p:spPr>
           <a:xfrm>
-            <a:off x="9326880" y="182880"/>
-            <a:ext cx="822960" cy="822960"/>
+            <a:off x="9601200" y="137160"/>
+            <a:ext cx="731520" cy="731520"/>
           </a:xfrm>
           <a:prstGeom prst="rect">
             <a:avLst/>
@@ -18160,14 +18008,14 @@
       </p:pic>
       <p:sp>
         <p:nvSpPr>
-          <p:cNvPr id="18" name="TextBox 17"/>
+          <p:cNvPr id="4" name="TextBox 3"/>
           <p:cNvSpPr txBox="1"/>
           <p:nvPr/>
         </p:nvSpPr>
         <p:spPr>
           <a:xfrm>
-            <a:off x="6858000" y="1005840"/>
-            <a:ext cx="2743200" cy="365760"/>
+            <a:off x="7315200" y="182880"/>
+            <a:ext cx="2103120" cy="640080"/>
           </a:xfrm>
           <a:prstGeom prst="rect">
             <a:avLst/>
@@ -18181,22 +18029,28 @@
           <a:lstStyle/>
           <a:p>
             <a:r>
-              <a:rPr sz="1300"/>
-              <a:t>队员：XXX, XXX, XXX</a:t>
-            </a:r>
-          </a:p>
-        </p:txBody>
-      </p:sp>
-      <p:sp>
-        <p:nvSpPr>
-          <p:cNvPr id="19" name="TextBox 18"/>
+              <a:rPr sz="1600" b="1"/>
+              <a:t>武汉大学</a:t>
+            </a:r>
+          </a:p>
+          <a:p>
+            <a:r>
+              <a:rPr sz="1200"/>
+              <a:t>电子信息学院</a:t>
+            </a:r>
+          </a:p>
+        </p:txBody>
+      </p:sp>
+      <p:sp>
+        <p:nvSpPr>
+          <p:cNvPr id="5" name="TextBox 4"/>
           <p:cNvSpPr txBox="1"/>
           <p:nvPr/>
         </p:nvSpPr>
         <p:spPr>
           <a:xfrm>
-            <a:off x="10241280" y="1188720"/>
-            <a:ext cx="1828800" cy="365760"/>
+            <a:off x="7315200" y="868680"/>
+            <a:ext cx="2743200" cy="320040"/>
           </a:xfrm>
           <a:prstGeom prst="rect">
             <a:avLst/>
@@ -18211,21 +18065,21 @@
           <a:p>
             <a:r>
               <a:rPr sz="1100"/>
-              <a:t>板端：AMD PYNQ-Z2</a:t>
-            </a:r>
-          </a:p>
-        </p:txBody>
-      </p:sp>
-      <p:sp>
-        <p:nvSpPr>
-          <p:cNvPr id="20" name="TextBox 19"/>
+              <a:t>队员：XXX, XXX, XXX</a:t>
+            </a:r>
+          </a:p>
+        </p:txBody>
+      </p:sp>
+      <p:sp>
+        <p:nvSpPr>
+          <p:cNvPr id="6" name="TextBox 5"/>
           <p:cNvSpPr txBox="1"/>
           <p:nvPr/>
         </p:nvSpPr>
         <p:spPr>
           <a:xfrm>
-            <a:off x="274320" y="1188720"/>
-            <a:ext cx="3200400" cy="365760"/>
+            <a:off x="274320" y="1097280"/>
+            <a:ext cx="3200400" cy="320040"/>
           </a:xfrm>
           <a:prstGeom prst="rect">
             <a:avLst/>
@@ -18239,7 +18093,7 @@
           <a:lstStyle/>
           <a:p>
             <a:r>
-              <a:rPr sz="1600" b="1"/>
+              <a:rPr sz="1400" b="1"/>
               <a:t>项目简介</a:t>
             </a:r>
           </a:p>
@@ -18247,14 +18101,14 @@
       </p:sp>
       <p:sp>
         <p:nvSpPr>
-          <p:cNvPr id="21" name="TextBox 20"/>
+          <p:cNvPr id="7" name="TextBox 6"/>
           <p:cNvSpPr txBox="1"/>
           <p:nvPr/>
         </p:nvSpPr>
         <p:spPr>
           <a:xfrm>
-            <a:off x="274320" y="1645920"/>
-            <a:ext cx="3474720" cy="4114800"/>
+            <a:off x="274320" y="1463040"/>
+            <a:ext cx="3200400" cy="3200400"/>
           </a:xfrm>
           <a:prstGeom prst="rect">
             <a:avLst/>
@@ -18268,70 +18122,94 @@
           <a:lstStyle/>
           <a:p>
             <a:r>
-              <a:rPr sz="1100" b="1"/>
+              <a:rPr sz="1050" b="1"/>
               <a:t>背景：</a:t>
             </a:r>
           </a:p>
           <a:p>
             <a:r>
-              <a:rPr sz="1100" b="0"/>
-              <a:t>仙八色鸫是国家二级保护动物、IUCN 易危物种，野外监测需长时间蹲守。本系统在 PYNQ-Z2 上实现鸣声检测→视觉确认→自动录像全自动闭环。</a:t>
-            </a:r>
-          </a:p>
-          <a:p>
-            <a:r>
-              <a:rPr sz="1100" b="0"/>
+              <a:rPr sz="1050" b="0"/>
+              <a:t>仙八色鸫是国家二级保护动物，野外监测需长时间蹲守。本系统在 PYNQ-Z2 上实现鸣声检测→视觉确认→自动录像全自动闭环。</a:t>
+            </a:r>
+          </a:p>
+          <a:p>
+            <a:r>
+              <a:rPr sz="1050" b="0"/>
               <a:t/>
             </a:r>
           </a:p>
           <a:p>
             <a:r>
-              <a:rPr sz="1100" b="1"/>
+              <a:rPr sz="1050" b="1"/>
               <a:t>技术方案：</a:t>
             </a:r>
           </a:p>
           <a:p>
             <a:r>
-              <a:rPr sz="1100" b="0"/>
-              <a:t>1. PL 侧 I2S+AXI DMA 采集 INMP441 麦克风，32kHz 实时流不占 CPU</a:t>
-            </a:r>
-          </a:p>
-          <a:p>
-            <a:r>
-              <a:rPr sz="1100" b="0"/>
-              <a:t>2. PS 侧 3 层 CNN 鸟鸣检测，阈值 0.985 触发视觉端</a:t>
-            </a:r>
-          </a:p>
-          <a:p>
-            <a:r>
-              <a:rPr sz="1100" b="0"/>
-              <a:t>3. USB 摄像头 + YOLOv8n(NCNN) 确认目标，自动抓拍录像</a:t>
-            </a:r>
-          </a:p>
-          <a:p>
-            <a:r>
-              <a:rPr sz="1100" b="0"/>
-              <a:t>4. Vitis HLS 定点 GEMM 核验证 conv1 硬件加速（纯核 4.64x）</a:t>
-            </a:r>
-          </a:p>
-          <a:p>
-            <a:r>
-              <a:rPr sz="1100" b="0"/>
-              <a:t>5. 目标存在性录像：misses=3 后结束，存储效率提升 5-10 倍</a:t>
-            </a:r>
-          </a:p>
-        </p:txBody>
-      </p:sp>
-      <p:sp>
-        <p:nvSpPr>
-          <p:cNvPr id="22" name="TextBox 21"/>
+              <a:rPr sz="1050" b="0"/>
+              <a:t>1. PL I2S+DMA 采集麦克风</a:t>
+            </a:r>
+          </a:p>
+          <a:p>
+            <a:r>
+              <a:rPr sz="1050" b="0"/>
+              <a:t>2. PS CNN 鸟鸣检测触发</a:t>
+            </a:r>
+          </a:p>
+          <a:p>
+            <a:r>
+              <a:rPr sz="1050" b="0"/>
+              <a:t>3. YOLOv8n 视觉确认录像</a:t>
+            </a:r>
+          </a:p>
+          <a:p>
+            <a:r>
+              <a:rPr sz="1050" b="0"/>
+              <a:t>4. HLS GEMM 硬件加速验证</a:t>
+            </a:r>
+          </a:p>
+          <a:p>
+            <a:r>
+              <a:rPr sz="1050" b="0"/>
+              <a:t>5. 存在性录像存储效率高</a:t>
+            </a:r>
+          </a:p>
+        </p:txBody>
+      </p:sp>
+      <p:pic>
+        <p:nvPicPr>
+          <p:cNvPr id="8" name="Picture 7" descr="web_01.jpg"/>
+          <p:cNvPicPr>
+            <a:picLocks noChangeAspect="1"/>
+          </p:cNvPicPr>
+          <p:nvPr/>
+        </p:nvPicPr>
+        <p:blipFill>
+          <a:blip r:embed="rId10"/>
+          <a:stretch>
+            <a:fillRect/>
+          </a:stretch>
+        </p:blipFill>
+        <p:spPr>
+          <a:xfrm>
+            <a:off x="274320" y="4754880"/>
+            <a:ext cx="2011680" cy="1645920"/>
+          </a:xfrm>
+          <a:prstGeom prst="rect">
+            <a:avLst/>
+          </a:prstGeom>
+        </p:spPr>
+      </p:pic>
+      <p:sp>
+        <p:nvSpPr>
+          <p:cNvPr id="9" name="TextBox 8"/>
           <p:cNvSpPr txBox="1"/>
           <p:nvPr/>
         </p:nvSpPr>
         <p:spPr>
           <a:xfrm>
-            <a:off x="4114800" y="1188720"/>
-            <a:ext cx="2743200" cy="365760"/>
+            <a:off x="274320" y="6400800"/>
+            <a:ext cx="2011680" cy="274320"/>
           </a:xfrm>
           <a:prstGeom prst="rect">
             <a:avLst/>
@@ -18346,7 +18224,37 @@
           <a:p>
             <a:pPr algn="ctr"/>
             <a:r>
-              <a:rPr sz="1600" b="1"/>
+              <a:rPr sz="900"/>
+              <a:t>仙八色鸫 (Pitta nympha)</a:t>
+            </a:r>
+          </a:p>
+        </p:txBody>
+      </p:sp>
+      <p:sp>
+        <p:nvSpPr>
+          <p:cNvPr id="10" name="TextBox 9"/>
+          <p:cNvSpPr txBox="1"/>
+          <p:nvPr/>
+        </p:nvSpPr>
+        <p:spPr>
+          <a:xfrm>
+            <a:off x="3840480" y="1097280"/>
+            <a:ext cx="3657600" cy="320040"/>
+          </a:xfrm>
+          <a:prstGeom prst="rect">
+            <a:avLst/>
+          </a:prstGeom>
+          <a:noFill/>
+        </p:spPr>
+        <p:txBody>
+          <a:bodyPr wrap="none">
+            <a:spAutoFit/>
+          </a:bodyPr>
+          <a:lstStyle/>
+          <a:p>
+            <a:pPr algn="ctr"/>
+            <a:r>
+              <a:rPr sz="1400" b="1"/>
               <a:t>系统架构</a:t>
             </a:r>
           </a:p>
@@ -18354,24 +18262,24 @@
       </p:sp>
       <p:sp>
         <p:nvSpPr>
-          <p:cNvPr id="23" name="Rounded Rectangle 22"/>
+          <p:cNvPr id="11" name="Rounded Rectangle 10"/>
           <p:cNvSpPr/>
           <p:nvPr/>
         </p:nvSpPr>
         <p:spPr>
           <a:xfrm>
-            <a:off x="4114800" y="1737360"/>
-            <a:ext cx="3474720" cy="1828800"/>
+            <a:off x="3840480" y="1554480"/>
+            <a:ext cx="3840480" cy="1645920"/>
           </a:xfrm>
           <a:prstGeom prst="roundRect">
             <a:avLst/>
           </a:prstGeom>
           <a:solidFill>
-            <a:srgbClr val="E8F0FE"/>
+            <a:srgbClr val="E3F2FD"/>
           </a:solidFill>
-          <a:ln>
+          <a:ln w="19050">
             <a:solidFill>
-              <a:srgbClr val="4A90D9"/>
+              <a:srgbClr val="1565C0"/>
             </a:solidFill>
           </a:ln>
         </p:spPr>
@@ -18390,61 +18298,41 @@
           </a:fontRef>
         </p:style>
         <p:txBody>
-          <a:bodyPr rtlCol="0" anchor="ctr" wrap="square"/>
+          <a:bodyPr rtlCol="0" anchor="ctr"/>
           <a:lstStyle/>
           <a:p>
             <a:pPr algn="ctr"/>
             <a:r>
-              <a:rPr sz="1100" b="1"/>
-              <a:t>音频采集与检测模块</a:t>
-            </a:r>
-          </a:p>
-          <a:p>
-            <a:r>
-              <a:rPr sz="1100" b="0"/>
-              <a:t>• INMP441 I2S 数字 MEMS 麦克风</a:t>
-            </a:r>
-          </a:p>
-          <a:p>
-            <a:r>
-              <a:rPr sz="1100" b="0"/>
-              <a:t>• 2s 窗口 → STFT/Mel [64,201]</a:t>
-            </a:r>
-          </a:p>
-          <a:p>
-            <a:r>
-              <a:rPr sz="1100" b="0"/>
-              <a:t>• 3 层 CNN + Sigmoid 输出鸟鸣概率</a:t>
-            </a:r>
-          </a:p>
-          <a:p>
-            <a:r>
-              <a:rPr sz="1100" b="0"/>
-              <a:t>• score ≥ 0.985 写触发文件</a:t>
-            </a:r>
-          </a:p>
-        </p:txBody>
-      </p:sp>
-      <p:sp>
-        <p:nvSpPr>
-          <p:cNvPr id="24" name="Rounded Rectangle 23"/>
+              <a:rPr sz="1100" b="1">
+                <a:solidFill>
+                  <a:srgbClr val="1565C0"/>
+                </a:solidFill>
+              </a:rPr>
+              <a:t>PL (FPGA)</a:t>
+            </a:r>
+          </a:p>
+        </p:txBody>
+      </p:sp>
+      <p:sp>
+        <p:nvSpPr>
+          <p:cNvPr id="12" name="Rounded Rectangle 11"/>
           <p:cNvSpPr/>
           <p:nvPr/>
         </p:nvSpPr>
         <p:spPr>
           <a:xfrm>
-            <a:off x="4114800" y="3840480"/>
-            <a:ext cx="3474720" cy="1828800"/>
+            <a:off x="4023360" y="2103120"/>
+            <a:ext cx="822960" cy="457200"/>
           </a:xfrm>
           <a:prstGeom prst="roundRect">
             <a:avLst/>
           </a:prstGeom>
           <a:solidFill>
-            <a:srgbClr val="E8F8E8"/>
+            <a:srgbClr val="BBDBFB"/>
           </a:solidFill>
           <a:ln>
             <a:solidFill>
-              <a:srgbClr val="4CAF50"/>
+              <a:srgbClr val="1565C0"/>
             </a:solidFill>
           </a:ln>
         </p:spPr>
@@ -18463,51 +18351,531 @@
           </a:fontRef>
         </p:style>
         <p:txBody>
-          <a:bodyPr rtlCol="0" anchor="ctr" wrap="square"/>
+          <a:bodyPr rtlCol="0" anchor="ctr"/>
           <a:lstStyle/>
           <a:p>
             <a:pPr algn="ctr"/>
             <a:r>
-              <a:rPr sz="1100" b="1"/>
-              <a:t>视觉检测与录像模块</a:t>
-            </a:r>
-          </a:p>
-          <a:p>
-            <a:r>
-              <a:rPr sz="1100" b="0"/>
-              <a:t>• USB UVC 摄像头 640×480</a:t>
-            </a:r>
-          </a:p>
-          <a:p>
-            <a:r>
-              <a:rPr sz="1100" b="0"/>
-              <a:t>• YOLOv8n (NCNN) 检测，conf ≥ 0.52</a:t>
-            </a:r>
-          </a:p>
-          <a:p>
-            <a:r>
-              <a:rPr sz="1100" b="0"/>
-              <a:t>• 检测到目标自动抓拍 + H.264 MP4</a:t>
-            </a:r>
-          </a:p>
-          <a:p>
-            <a:r>
-              <a:rPr sz="1100" b="0"/>
-              <a:t>• misses=3 且 span≥6s 后结束录像</a:t>
-            </a:r>
-          </a:p>
-        </p:txBody>
-      </p:sp>
-      <p:sp>
-        <p:nvSpPr>
-          <p:cNvPr id="25" name="TextBox 24"/>
+              <a:rPr sz="800"/>
+              <a:t>INMP441
+I2S</a:t>
+            </a:r>
+          </a:p>
+        </p:txBody>
+      </p:sp>
+      <p:sp>
+        <p:nvSpPr>
+          <p:cNvPr id="13" name="Rounded Rectangle 12"/>
+          <p:cNvSpPr/>
+          <p:nvPr/>
+        </p:nvSpPr>
+        <p:spPr>
+          <a:xfrm>
+            <a:off x="5029200" y="2103120"/>
+            <a:ext cx="822960" cy="457200"/>
+          </a:xfrm>
+          <a:prstGeom prst="roundRect">
+            <a:avLst/>
+          </a:prstGeom>
+          <a:solidFill>
+            <a:srgbClr val="BBDBFB"/>
+          </a:solidFill>
+          <a:ln>
+            <a:solidFill>
+              <a:srgbClr val="1565C0"/>
+            </a:solidFill>
+          </a:ln>
+        </p:spPr>
+        <p:style>
+          <a:lnRef idx="1">
+            <a:schemeClr val="accent1"/>
+          </a:lnRef>
+          <a:fillRef idx="3">
+            <a:schemeClr val="accent1"/>
+          </a:fillRef>
+          <a:effectRef idx="2">
+            <a:schemeClr val="accent1"/>
+          </a:effectRef>
+          <a:fontRef idx="minor">
+            <a:schemeClr val="lt1"/>
+          </a:fontRef>
+        </p:style>
+        <p:txBody>
+          <a:bodyPr rtlCol="0" anchor="ctr"/>
+          <a:lstStyle/>
+          <a:p>
+            <a:pPr algn="ctr"/>
+            <a:r>
+              <a:rPr sz="800"/>
+              <a:t>I2S
+接收核</a:t>
+            </a:r>
+          </a:p>
+        </p:txBody>
+      </p:sp>
+      <p:sp>
+        <p:nvSpPr>
+          <p:cNvPr id="14" name="Rounded Rectangle 13"/>
+          <p:cNvSpPr/>
+          <p:nvPr/>
+        </p:nvSpPr>
+        <p:spPr>
+          <a:xfrm>
+            <a:off x="6035040" y="2103120"/>
+            <a:ext cx="822960" cy="457200"/>
+          </a:xfrm>
+          <a:prstGeom prst="roundRect">
+            <a:avLst/>
+          </a:prstGeom>
+          <a:solidFill>
+            <a:srgbClr val="BBDBFB"/>
+          </a:solidFill>
+          <a:ln>
+            <a:solidFill>
+              <a:srgbClr val="1565C0"/>
+            </a:solidFill>
+          </a:ln>
+        </p:spPr>
+        <p:style>
+          <a:lnRef idx="1">
+            <a:schemeClr val="accent1"/>
+          </a:lnRef>
+          <a:fillRef idx="3">
+            <a:schemeClr val="accent1"/>
+          </a:fillRef>
+          <a:effectRef idx="2">
+            <a:schemeClr val="accent1"/>
+          </a:effectRef>
+          <a:fontRef idx="minor">
+            <a:schemeClr val="lt1"/>
+          </a:fontRef>
+        </p:style>
+        <p:txBody>
+          <a:bodyPr rtlCol="0" anchor="ctr"/>
+          <a:lstStyle/>
+          <a:p>
+            <a:pPr algn="ctr"/>
+            <a:r>
+              <a:rPr sz="800"/>
+              <a:t>AXI
+DMA</a:t>
+            </a:r>
+          </a:p>
+        </p:txBody>
+      </p:sp>
+      <p:sp>
+        <p:nvSpPr>
+          <p:cNvPr id="15" name="Rounded Rectangle 14"/>
+          <p:cNvSpPr/>
+          <p:nvPr/>
+        </p:nvSpPr>
+        <p:spPr>
+          <a:xfrm>
+            <a:off x="4023360" y="2651760"/>
+            <a:ext cx="822960" cy="457200"/>
+          </a:xfrm>
+          <a:prstGeom prst="roundRect">
+            <a:avLst/>
+          </a:prstGeom>
+          <a:solidFill>
+            <a:srgbClr val="BBDBFB"/>
+          </a:solidFill>
+          <a:ln>
+            <a:solidFill>
+              <a:srgbClr val="1565C0"/>
+            </a:solidFill>
+          </a:ln>
+        </p:spPr>
+        <p:style>
+          <a:lnRef idx="1">
+            <a:schemeClr val="accent1"/>
+          </a:lnRef>
+          <a:fillRef idx="3">
+            <a:schemeClr val="accent1"/>
+          </a:fillRef>
+          <a:effectRef idx="2">
+            <a:schemeClr val="accent1"/>
+          </a:effectRef>
+          <a:fontRef idx="minor">
+            <a:schemeClr val="lt1"/>
+          </a:fontRef>
+        </p:style>
+        <p:txBody>
+          <a:bodyPr rtlCol="0" anchor="ctr"/>
+          <a:lstStyle/>
+          <a:p>
+            <a:pPr algn="ctr"/>
+            <a:r>
+              <a:rPr sz="800"/>
+              <a:t>GEMM
+HLS核</a:t>
+            </a:r>
+          </a:p>
+        </p:txBody>
+      </p:sp>
+      <p:sp>
+        <p:nvSpPr>
+          <p:cNvPr id="16" name="Rounded Rectangle 15"/>
+          <p:cNvSpPr/>
+          <p:nvPr/>
+        </p:nvSpPr>
+        <p:spPr>
+          <a:xfrm>
+            <a:off x="3840480" y="3383280"/>
+            <a:ext cx="3840480" cy="2560320"/>
+          </a:xfrm>
+          <a:prstGeom prst="roundRect">
+            <a:avLst/>
+          </a:prstGeom>
+          <a:solidFill>
+            <a:srgbClr val="E8F5E9"/>
+          </a:solidFill>
+          <a:ln w="19050">
+            <a:solidFill>
+              <a:srgbClr val="2E7D32"/>
+            </a:solidFill>
+          </a:ln>
+        </p:spPr>
+        <p:style>
+          <a:lnRef idx="1">
+            <a:schemeClr val="accent1"/>
+          </a:lnRef>
+          <a:fillRef idx="3">
+            <a:schemeClr val="accent1"/>
+          </a:fillRef>
+          <a:effectRef idx="2">
+            <a:schemeClr val="accent1"/>
+          </a:effectRef>
+          <a:fontRef idx="minor">
+            <a:schemeClr val="lt1"/>
+          </a:fontRef>
+        </p:style>
+        <p:txBody>
+          <a:bodyPr rtlCol="0" anchor="ctr"/>
+          <a:lstStyle/>
+          <a:p>
+            <a:pPr algn="ctr"/>
+            <a:r>
+              <a:rPr sz="1100" b="1">
+                <a:solidFill>
+                  <a:srgbClr val="2E7D32"/>
+                </a:solidFill>
+              </a:rPr>
+              <a:t>PS (ARM Cortex-A9)</a:t>
+            </a:r>
+          </a:p>
+        </p:txBody>
+      </p:sp>
+      <p:sp>
+        <p:nvSpPr>
+          <p:cNvPr id="17" name="Rounded Rectangle 16"/>
+          <p:cNvSpPr/>
+          <p:nvPr/>
+        </p:nvSpPr>
+        <p:spPr>
+          <a:xfrm>
+            <a:off x="4023360" y="3931920"/>
+            <a:ext cx="1005840" cy="502920"/>
+          </a:xfrm>
+          <a:prstGeom prst="roundRect">
+            <a:avLst/>
+          </a:prstGeom>
+          <a:solidFill>
+            <a:srgbClr val="C8E6C9"/>
+          </a:solidFill>
+          <a:ln>
+            <a:solidFill>
+              <a:srgbClr val="2E7D32"/>
+            </a:solidFill>
+          </a:ln>
+        </p:spPr>
+        <p:style>
+          <a:lnRef idx="1">
+            <a:schemeClr val="accent1"/>
+          </a:lnRef>
+          <a:fillRef idx="3">
+            <a:schemeClr val="accent1"/>
+          </a:fillRef>
+          <a:effectRef idx="2">
+            <a:schemeClr val="accent1"/>
+          </a:effectRef>
+          <a:fontRef idx="minor">
+            <a:schemeClr val="lt1"/>
+          </a:fontRef>
+        </p:style>
+        <p:txBody>
+          <a:bodyPr rtlCol="0" anchor="ctr"/>
+          <a:lstStyle/>
+          <a:p>
+            <a:pPr algn="ctr"/>
+            <a:r>
+              <a:rPr sz="800"/>
+              <a:t>STFT/Mel
+特征提取</a:t>
+            </a:r>
+          </a:p>
+        </p:txBody>
+      </p:sp>
+      <p:sp>
+        <p:nvSpPr>
+          <p:cNvPr id="18" name="Rounded Rectangle 17"/>
+          <p:cNvSpPr/>
+          <p:nvPr/>
+        </p:nvSpPr>
+        <p:spPr>
+          <a:xfrm>
+            <a:off x="5212080" y="3931920"/>
+            <a:ext cx="1005840" cy="502920"/>
+          </a:xfrm>
+          <a:prstGeom prst="roundRect">
+            <a:avLst/>
+          </a:prstGeom>
+          <a:solidFill>
+            <a:srgbClr val="C8E6C9"/>
+          </a:solidFill>
+          <a:ln>
+            <a:solidFill>
+              <a:srgbClr val="2E7D32"/>
+            </a:solidFill>
+          </a:ln>
+        </p:spPr>
+        <p:style>
+          <a:lnRef idx="1">
+            <a:schemeClr val="accent1"/>
+          </a:lnRef>
+          <a:fillRef idx="3">
+            <a:schemeClr val="accent1"/>
+          </a:fillRef>
+          <a:effectRef idx="2">
+            <a:schemeClr val="accent1"/>
+          </a:effectRef>
+          <a:fontRef idx="minor">
+            <a:schemeClr val="lt1"/>
+          </a:fontRef>
+        </p:style>
+        <p:txBody>
+          <a:bodyPr rtlCol="0" anchor="ctr"/>
+          <a:lstStyle/>
+          <a:p>
+            <a:pPr algn="ctr"/>
+            <a:r>
+              <a:rPr sz="800"/>
+              <a:t>鸟鸣CNN
+score</a:t>
+            </a:r>
+          </a:p>
+        </p:txBody>
+      </p:sp>
+      <p:sp>
+        <p:nvSpPr>
+          <p:cNvPr id="19" name="Rounded Rectangle 18"/>
+          <p:cNvSpPr/>
+          <p:nvPr/>
+        </p:nvSpPr>
+        <p:spPr>
+          <a:xfrm>
+            <a:off x="6400800" y="3931920"/>
+            <a:ext cx="1005840" cy="502920"/>
+          </a:xfrm>
+          <a:prstGeom prst="roundRect">
+            <a:avLst/>
+          </a:prstGeom>
+          <a:solidFill>
+            <a:srgbClr val="C8E6C9"/>
+          </a:solidFill>
+          <a:ln>
+            <a:solidFill>
+              <a:srgbClr val="2E7D32"/>
+            </a:solidFill>
+          </a:ln>
+        </p:spPr>
+        <p:style>
+          <a:lnRef idx="1">
+            <a:schemeClr val="accent1"/>
+          </a:lnRef>
+          <a:fillRef idx="3">
+            <a:schemeClr val="accent1"/>
+          </a:fillRef>
+          <a:effectRef idx="2">
+            <a:schemeClr val="accent1"/>
+          </a:effectRef>
+          <a:fontRef idx="minor">
+            <a:schemeClr val="lt1"/>
+          </a:fontRef>
+        </p:style>
+        <p:txBody>
+          <a:bodyPr rtlCol="0" anchor="ctr"/>
+          <a:lstStyle/>
+          <a:p>
+            <a:pPr algn="ctr"/>
+            <a:r>
+              <a:rPr sz="800"/>
+              <a:t>触发
+文件</a:t>
+            </a:r>
+          </a:p>
+        </p:txBody>
+      </p:sp>
+      <p:sp>
+        <p:nvSpPr>
+          <p:cNvPr id="20" name="Rounded Rectangle 19"/>
+          <p:cNvSpPr/>
+          <p:nvPr/>
+        </p:nvSpPr>
+        <p:spPr>
+          <a:xfrm>
+            <a:off x="4023360" y="4572000"/>
+            <a:ext cx="1005840" cy="502920"/>
+          </a:xfrm>
+          <a:prstGeom prst="roundRect">
+            <a:avLst/>
+          </a:prstGeom>
+          <a:solidFill>
+            <a:srgbClr val="C8E6C9"/>
+          </a:solidFill>
+          <a:ln>
+            <a:solidFill>
+              <a:srgbClr val="2E7D32"/>
+            </a:solidFill>
+          </a:ln>
+        </p:spPr>
+        <p:style>
+          <a:lnRef idx="1">
+            <a:schemeClr val="accent1"/>
+          </a:lnRef>
+          <a:fillRef idx="3">
+            <a:schemeClr val="accent1"/>
+          </a:fillRef>
+          <a:effectRef idx="2">
+            <a:schemeClr val="accent1"/>
+          </a:effectRef>
+          <a:fontRef idx="minor">
+            <a:schemeClr val="lt1"/>
+          </a:fontRef>
+        </p:style>
+        <p:txBody>
+          <a:bodyPr rtlCol="0" anchor="ctr"/>
+          <a:lstStyle/>
+          <a:p>
+            <a:pPr algn="ctr"/>
+            <a:r>
+              <a:rPr sz="800"/>
+              <a:t>USB
+摄像头</a:t>
+            </a:r>
+          </a:p>
+        </p:txBody>
+      </p:sp>
+      <p:sp>
+        <p:nvSpPr>
+          <p:cNvPr id="21" name="Rounded Rectangle 20"/>
+          <p:cNvSpPr/>
+          <p:nvPr/>
+        </p:nvSpPr>
+        <p:spPr>
+          <a:xfrm>
+            <a:off x="5212080" y="4572000"/>
+            <a:ext cx="1005840" cy="502920"/>
+          </a:xfrm>
+          <a:prstGeom prst="roundRect">
+            <a:avLst/>
+          </a:prstGeom>
+          <a:solidFill>
+            <a:srgbClr val="C8E6C9"/>
+          </a:solidFill>
+          <a:ln>
+            <a:solidFill>
+              <a:srgbClr val="2E7D32"/>
+            </a:solidFill>
+          </a:ln>
+        </p:spPr>
+        <p:style>
+          <a:lnRef idx="1">
+            <a:schemeClr val="accent1"/>
+          </a:lnRef>
+          <a:fillRef idx="3">
+            <a:schemeClr val="accent1"/>
+          </a:fillRef>
+          <a:effectRef idx="2">
+            <a:schemeClr val="accent1"/>
+          </a:effectRef>
+          <a:fontRef idx="minor">
+            <a:schemeClr val="lt1"/>
+          </a:fontRef>
+        </p:style>
+        <p:txBody>
+          <a:bodyPr rtlCol="0" anchor="ctr"/>
+          <a:lstStyle/>
+          <a:p>
+            <a:pPr algn="ctr"/>
+            <a:r>
+              <a:rPr sz="800"/>
+              <a:t>YOLOv8n
+(NCNN)</a:t>
+            </a:r>
+          </a:p>
+        </p:txBody>
+      </p:sp>
+      <p:sp>
+        <p:nvSpPr>
+          <p:cNvPr id="22" name="Rounded Rectangle 21"/>
+          <p:cNvSpPr/>
+          <p:nvPr/>
+        </p:nvSpPr>
+        <p:spPr>
+          <a:xfrm>
+            <a:off x="6400800" y="4572000"/>
+            <a:ext cx="1005840" cy="502920"/>
+          </a:xfrm>
+          <a:prstGeom prst="roundRect">
+            <a:avLst/>
+          </a:prstGeom>
+          <a:solidFill>
+            <a:srgbClr val="C8E6C9"/>
+          </a:solidFill>
+          <a:ln>
+            <a:solidFill>
+              <a:srgbClr val="2E7D32"/>
+            </a:solidFill>
+          </a:ln>
+        </p:spPr>
+        <p:style>
+          <a:lnRef idx="1">
+            <a:schemeClr val="accent1"/>
+          </a:lnRef>
+          <a:fillRef idx="3">
+            <a:schemeClr val="accent1"/>
+          </a:fillRef>
+          <a:effectRef idx="2">
+            <a:schemeClr val="accent1"/>
+          </a:effectRef>
+          <a:fontRef idx="minor">
+            <a:schemeClr val="lt1"/>
+          </a:fontRef>
+        </p:style>
+        <p:txBody>
+          <a:bodyPr rtlCol="0" anchor="ctr"/>
+          <a:lstStyle/>
+          <a:p>
+            <a:pPr algn="ctr"/>
+            <a:r>
+              <a:rPr sz="800"/>
+              <a:t>抓拍+
+H.264录像</a:t>
+            </a:r>
+          </a:p>
+        </p:txBody>
+      </p:sp>
+      <p:sp>
+        <p:nvSpPr>
+          <p:cNvPr id="23" name="TextBox 22"/>
           <p:cNvSpPr txBox="1"/>
           <p:nvPr/>
         </p:nvSpPr>
         <p:spPr>
           <a:xfrm>
-            <a:off x="8686800" y="3840480"/>
-            <a:ext cx="3200400" cy="365760"/>
+            <a:off x="8046720" y="1371600"/>
+            <a:ext cx="274320" cy="320040"/>
           </a:xfrm>
           <a:prstGeom prst="rect">
             <a:avLst/>
@@ -18521,22 +18889,26 @@
           <a:lstStyle/>
           <a:p>
             <a:r>
-              <a:rPr sz="1600" b="1"/>
-              <a:t>实测性能</a:t>
-            </a:r>
-          </a:p>
-        </p:txBody>
-      </p:sp>
-      <p:sp>
-        <p:nvSpPr>
-          <p:cNvPr id="26" name="TextBox 25"/>
+              <a:rPr sz="1400" b="1">
+                <a:solidFill>
+                  <a:srgbClr val="333333"/>
+                </a:solidFill>
+              </a:rPr>
+              <a:t>C</a:t>
+            </a:r>
+          </a:p>
+        </p:txBody>
+      </p:sp>
+      <p:sp>
+        <p:nvSpPr>
+          <p:cNvPr id="24" name="TextBox 23"/>
           <p:cNvSpPr txBox="1"/>
           <p:nvPr/>
         </p:nvSpPr>
         <p:spPr>
           <a:xfrm>
-            <a:off x="8686800" y="4297680"/>
-            <a:ext cx="3200400" cy="2286000"/>
+            <a:off x="8046720" y="1691640"/>
+            <a:ext cx="274320" cy="320040"/>
           </a:xfrm>
           <a:prstGeom prst="rect">
             <a:avLst/>
@@ -18544,50 +18916,542 @@
           <a:noFill/>
         </p:spPr>
         <p:txBody>
+          <a:bodyPr wrap="none">
+            <a:spAutoFit/>
+          </a:bodyPr>
+          <a:lstStyle/>
+          <a:p>
+            <a:r>
+              <a:rPr sz="1400" b="1">
+                <a:solidFill>
+                  <a:srgbClr val="333333"/>
+                </a:solidFill>
+              </a:rPr>
+              <a:t>R</a:t>
+            </a:r>
+          </a:p>
+        </p:txBody>
+      </p:sp>
+      <p:sp>
+        <p:nvSpPr>
+          <p:cNvPr id="25" name="TextBox 24"/>
+          <p:cNvSpPr txBox="1"/>
+          <p:nvPr/>
+        </p:nvSpPr>
+        <p:spPr>
+          <a:xfrm>
+            <a:off x="8046720" y="2011680"/>
+            <a:ext cx="274320" cy="320040"/>
+          </a:xfrm>
+          <a:prstGeom prst="rect">
+            <a:avLst/>
+          </a:prstGeom>
+          <a:noFill/>
+        </p:spPr>
+        <p:txBody>
+          <a:bodyPr wrap="none">
+            <a:spAutoFit/>
+          </a:bodyPr>
+          <a:lstStyle/>
+          <a:p>
+            <a:r>
+              <a:rPr sz="1400" b="1">
+                <a:solidFill>
+                  <a:srgbClr val="333333"/>
+                </a:solidFill>
+              </a:rPr>
+              <a:t>E</a:t>
+            </a:r>
+          </a:p>
+        </p:txBody>
+      </p:sp>
+      <p:sp>
+        <p:nvSpPr>
+          <p:cNvPr id="26" name="TextBox 25"/>
+          <p:cNvSpPr txBox="1"/>
+          <p:nvPr/>
+        </p:nvSpPr>
+        <p:spPr>
+          <a:xfrm>
+            <a:off x="8046720" y="2331720"/>
+            <a:ext cx="274320" cy="320040"/>
+          </a:xfrm>
+          <a:prstGeom prst="rect">
+            <a:avLst/>
+          </a:prstGeom>
+          <a:noFill/>
+        </p:spPr>
+        <p:txBody>
+          <a:bodyPr wrap="none">
+            <a:spAutoFit/>
+          </a:bodyPr>
+          <a:lstStyle/>
+          <a:p>
+            <a:r>
+              <a:rPr sz="1400" b="1">
+                <a:solidFill>
+                  <a:srgbClr val="333333"/>
+                </a:solidFill>
+              </a:rPr>
+              <a:t>A</a:t>
+            </a:r>
+          </a:p>
+        </p:txBody>
+      </p:sp>
+      <p:sp>
+        <p:nvSpPr>
+          <p:cNvPr id="27" name="TextBox 26"/>
+          <p:cNvSpPr txBox="1"/>
+          <p:nvPr/>
+        </p:nvSpPr>
+        <p:spPr>
+          <a:xfrm>
+            <a:off x="8046720" y="2651760"/>
+            <a:ext cx="274320" cy="320040"/>
+          </a:xfrm>
+          <a:prstGeom prst="rect">
+            <a:avLst/>
+          </a:prstGeom>
+          <a:noFill/>
+        </p:spPr>
+        <p:txBody>
+          <a:bodyPr wrap="none">
+            <a:spAutoFit/>
+          </a:bodyPr>
+          <a:lstStyle/>
+          <a:p>
+            <a:r>
+              <a:rPr sz="1400" b="1">
+                <a:solidFill>
+                  <a:srgbClr val="333333"/>
+                </a:solidFill>
+              </a:rPr>
+              <a:t>T</a:t>
+            </a:r>
+          </a:p>
+        </p:txBody>
+      </p:sp>
+      <p:sp>
+        <p:nvSpPr>
+          <p:cNvPr id="28" name="TextBox 27"/>
+          <p:cNvSpPr txBox="1"/>
+          <p:nvPr/>
+        </p:nvSpPr>
+        <p:spPr>
+          <a:xfrm>
+            <a:off x="8046720" y="2971800"/>
+            <a:ext cx="274320" cy="320040"/>
+          </a:xfrm>
+          <a:prstGeom prst="rect">
+            <a:avLst/>
+          </a:prstGeom>
+          <a:noFill/>
+        </p:spPr>
+        <p:txBody>
+          <a:bodyPr wrap="none">
+            <a:spAutoFit/>
+          </a:bodyPr>
+          <a:lstStyle/>
+          <a:p>
+            <a:r>
+              <a:rPr sz="1400" b="1">
+                <a:solidFill>
+                  <a:srgbClr val="333333"/>
+                </a:solidFill>
+              </a:rPr>
+              <a:t>I</a:t>
+            </a:r>
+          </a:p>
+        </p:txBody>
+      </p:sp>
+      <p:sp>
+        <p:nvSpPr>
+          <p:cNvPr id="29" name="TextBox 28"/>
+          <p:cNvSpPr txBox="1"/>
+          <p:nvPr/>
+        </p:nvSpPr>
+        <p:spPr>
+          <a:xfrm>
+            <a:off x="8046720" y="3291839"/>
+            <a:ext cx="274320" cy="320040"/>
+          </a:xfrm>
+          <a:prstGeom prst="rect">
+            <a:avLst/>
+          </a:prstGeom>
+          <a:noFill/>
+        </p:spPr>
+        <p:txBody>
+          <a:bodyPr wrap="none">
+            <a:spAutoFit/>
+          </a:bodyPr>
+          <a:lstStyle/>
+          <a:p>
+            <a:r>
+              <a:rPr sz="1400" b="1">
+                <a:solidFill>
+                  <a:srgbClr val="333333"/>
+                </a:solidFill>
+              </a:rPr>
+              <a:t>V</a:t>
+            </a:r>
+          </a:p>
+        </p:txBody>
+      </p:sp>
+      <p:sp>
+        <p:nvSpPr>
+          <p:cNvPr id="30" name="TextBox 29"/>
+          <p:cNvSpPr txBox="1"/>
+          <p:nvPr/>
+        </p:nvSpPr>
+        <p:spPr>
+          <a:xfrm>
+            <a:off x="8046720" y="3611879"/>
+            <a:ext cx="274320" cy="320040"/>
+          </a:xfrm>
+          <a:prstGeom prst="rect">
+            <a:avLst/>
+          </a:prstGeom>
+          <a:noFill/>
+        </p:spPr>
+        <p:txBody>
+          <a:bodyPr wrap="none">
+            <a:spAutoFit/>
+          </a:bodyPr>
+          <a:lstStyle/>
+          <a:p>
+            <a:r>
+              <a:rPr sz="1400" b="1">
+                <a:solidFill>
+                  <a:srgbClr val="333333"/>
+                </a:solidFill>
+              </a:rPr>
+              <a:t>E</a:t>
+            </a:r>
+          </a:p>
+        </p:txBody>
+      </p:sp>
+      <p:sp>
+        <p:nvSpPr>
+          <p:cNvPr id="31" name="TextBox 30"/>
+          <p:cNvSpPr txBox="1"/>
+          <p:nvPr/>
+        </p:nvSpPr>
+        <p:spPr>
+          <a:xfrm>
+            <a:off x="8503920" y="2560320"/>
+            <a:ext cx="274320" cy="320040"/>
+          </a:xfrm>
+          <a:prstGeom prst="rect">
+            <a:avLst/>
+          </a:prstGeom>
+          <a:noFill/>
+        </p:spPr>
+        <p:txBody>
+          <a:bodyPr wrap="none">
+            <a:spAutoFit/>
+          </a:bodyPr>
+          <a:lstStyle/>
+          <a:p>
+            <a:r>
+              <a:rPr sz="1400" b="1">
+                <a:solidFill>
+                  <a:srgbClr val="333333"/>
+                </a:solidFill>
+              </a:rPr>
+              <a:t>R</a:t>
+            </a:r>
+          </a:p>
+        </p:txBody>
+      </p:sp>
+      <p:sp>
+        <p:nvSpPr>
+          <p:cNvPr id="32" name="TextBox 31"/>
+          <p:cNvSpPr txBox="1"/>
+          <p:nvPr/>
+        </p:nvSpPr>
+        <p:spPr>
+          <a:xfrm>
+            <a:off x="8503920" y="2880360"/>
+            <a:ext cx="274320" cy="320040"/>
+          </a:xfrm>
+          <a:prstGeom prst="rect">
+            <a:avLst/>
+          </a:prstGeom>
+          <a:noFill/>
+        </p:spPr>
+        <p:txBody>
+          <a:bodyPr wrap="none">
+            <a:spAutoFit/>
+          </a:bodyPr>
+          <a:lstStyle/>
+          <a:p>
+            <a:r>
+              <a:rPr sz="1400" b="1">
+                <a:solidFill>
+                  <a:srgbClr val="333333"/>
+                </a:solidFill>
+              </a:rPr>
+              <a:t>E</a:t>
+            </a:r>
+          </a:p>
+        </p:txBody>
+      </p:sp>
+      <p:sp>
+        <p:nvSpPr>
+          <p:cNvPr id="33" name="TextBox 32"/>
+          <p:cNvSpPr txBox="1"/>
+          <p:nvPr/>
+        </p:nvSpPr>
+        <p:spPr>
+          <a:xfrm>
+            <a:off x="8503920" y="3200400"/>
+            <a:ext cx="274320" cy="320040"/>
+          </a:xfrm>
+          <a:prstGeom prst="rect">
+            <a:avLst/>
+          </a:prstGeom>
+          <a:noFill/>
+        </p:spPr>
+        <p:txBody>
+          <a:bodyPr wrap="none">
+            <a:spAutoFit/>
+          </a:bodyPr>
+          <a:lstStyle/>
+          <a:p>
+            <a:r>
+              <a:rPr sz="1400" b="1">
+                <a:solidFill>
+                  <a:srgbClr val="333333"/>
+                </a:solidFill>
+              </a:rPr>
+              <a:t>S</a:t>
+            </a:r>
+          </a:p>
+        </p:txBody>
+      </p:sp>
+      <p:sp>
+        <p:nvSpPr>
+          <p:cNvPr id="34" name="TextBox 33"/>
+          <p:cNvSpPr txBox="1"/>
+          <p:nvPr/>
+        </p:nvSpPr>
+        <p:spPr>
+          <a:xfrm>
+            <a:off x="8503920" y="3520439"/>
+            <a:ext cx="274320" cy="320040"/>
+          </a:xfrm>
+          <a:prstGeom prst="rect">
+            <a:avLst/>
+          </a:prstGeom>
+          <a:noFill/>
+        </p:spPr>
+        <p:txBody>
+          <a:bodyPr wrap="none">
+            <a:spAutoFit/>
+          </a:bodyPr>
+          <a:lstStyle/>
+          <a:p>
+            <a:r>
+              <a:rPr sz="1400" b="1">
+                <a:solidFill>
+                  <a:srgbClr val="333333"/>
+                </a:solidFill>
+              </a:rPr>
+              <a:t>U</a:t>
+            </a:r>
+          </a:p>
+        </p:txBody>
+      </p:sp>
+      <p:sp>
+        <p:nvSpPr>
+          <p:cNvPr id="35" name="TextBox 34"/>
+          <p:cNvSpPr txBox="1"/>
+          <p:nvPr/>
+        </p:nvSpPr>
+        <p:spPr>
+          <a:xfrm>
+            <a:off x="8503920" y="3840479"/>
+            <a:ext cx="274320" cy="320040"/>
+          </a:xfrm>
+          <a:prstGeom prst="rect">
+            <a:avLst/>
+          </a:prstGeom>
+          <a:noFill/>
+        </p:spPr>
+        <p:txBody>
+          <a:bodyPr wrap="none">
+            <a:spAutoFit/>
+          </a:bodyPr>
+          <a:lstStyle/>
+          <a:p>
+            <a:r>
+              <a:rPr sz="1400" b="1">
+                <a:solidFill>
+                  <a:srgbClr val="333333"/>
+                </a:solidFill>
+              </a:rPr>
+              <a:t>L</a:t>
+            </a:r>
+          </a:p>
+        </p:txBody>
+      </p:sp>
+      <p:sp>
+        <p:nvSpPr>
+          <p:cNvPr id="36" name="TextBox 35"/>
+          <p:cNvSpPr txBox="1"/>
+          <p:nvPr/>
+        </p:nvSpPr>
+        <p:spPr>
+          <a:xfrm>
+            <a:off x="8503920" y="4160520"/>
+            <a:ext cx="274320" cy="320040"/>
+          </a:xfrm>
+          <a:prstGeom prst="rect">
+            <a:avLst/>
+          </a:prstGeom>
+          <a:noFill/>
+        </p:spPr>
+        <p:txBody>
+          <a:bodyPr wrap="none">
+            <a:spAutoFit/>
+          </a:bodyPr>
+          <a:lstStyle/>
+          <a:p>
+            <a:r>
+              <a:rPr sz="1400" b="1">
+                <a:solidFill>
+                  <a:srgbClr val="333333"/>
+                </a:solidFill>
+              </a:rPr>
+              <a:t>T</a:t>
+            </a:r>
+          </a:p>
+        </p:txBody>
+      </p:sp>
+      <p:sp>
+        <p:nvSpPr>
+          <p:cNvPr id="37" name="TextBox 36"/>
+          <p:cNvSpPr txBox="1"/>
+          <p:nvPr/>
+        </p:nvSpPr>
+        <p:spPr>
+          <a:xfrm>
+            <a:off x="8503920" y="4480559"/>
+            <a:ext cx="274320" cy="320040"/>
+          </a:xfrm>
+          <a:prstGeom prst="rect">
+            <a:avLst/>
+          </a:prstGeom>
+          <a:noFill/>
+        </p:spPr>
+        <p:txBody>
+          <a:bodyPr wrap="none">
+            <a:spAutoFit/>
+          </a:bodyPr>
+          <a:lstStyle/>
+          <a:p>
+            <a:r>
+              <a:rPr sz="1400" b="1">
+                <a:solidFill>
+                  <a:srgbClr val="333333"/>
+                </a:solidFill>
+              </a:rPr>
+              <a:t>S</a:t>
+            </a:r>
+          </a:p>
+        </p:txBody>
+      </p:sp>
+      <p:sp>
+        <p:nvSpPr>
+          <p:cNvPr id="38" name="TextBox 37"/>
+          <p:cNvSpPr txBox="1"/>
+          <p:nvPr/>
+        </p:nvSpPr>
+        <p:spPr>
+          <a:xfrm>
+            <a:off x="8961120" y="1371600"/>
+            <a:ext cx="3017520" cy="3657600"/>
+          </a:xfrm>
+          <a:prstGeom prst="rect">
+            <a:avLst/>
+          </a:prstGeom>
+          <a:noFill/>
+        </p:spPr>
+        <p:txBody>
           <a:bodyPr wrap="square">
             <a:spAutoFit/>
           </a:bodyPr>
           <a:lstStyle/>
           <a:p>
             <a:r>
-              <a:rPr sz="1100"/>
-              <a:t>• 音频事件级召回 97.4%（155 事件）</a:t>
-            </a:r>
-          </a:p>
-          <a:p>
-            <a:r>
-              <a:rPr sz="1100"/>
-              <a:t>• 图像独立测试召回 96.2%（266 图）</a:t>
-            </a:r>
-          </a:p>
-          <a:p>
-            <a:r>
-              <a:rPr sz="1100"/>
-              <a:t>• 音频窗口特异性 100%（2063 负样本）</a:t>
-            </a:r>
-          </a:p>
-          <a:p>
-            <a:r>
-              <a:rPr sz="1100"/>
-              <a:t>• 端到端触发延迟约 10.5s</a:t>
-            </a:r>
-          </a:p>
-          <a:p>
-            <a:r>
-              <a:rPr sz="1100"/>
-              <a:t>• GEMM 纯核加速 4.64x（端到端 0.59x）</a:t>
-            </a:r>
-          </a:p>
-          <a:p>
-            <a:r>
-              <a:rPr sz="1100"/>
-              <a:t>• 音频 overlay LUT 仅占 3.15%</a:t>
-            </a:r>
-          </a:p>
-          <a:p>
-            <a:r>
-              <a:rPr sz="1100"/>
-              <a:t>• 录像 37.4s / 187 帧 H.264</a:t>
+              <a:rPr sz="1050" b="1"/>
+              <a:t>实测性能</a:t>
+            </a:r>
+          </a:p>
+          <a:p>
+            <a:r>
+              <a:rPr sz="1050" b="0"/>
+              <a:t/>
+            </a:r>
+          </a:p>
+          <a:p>
+            <a:r>
+              <a:rPr sz="1050" b="0"/>
+              <a:t>• 音频事件召回 97.4%</a:t>
+            </a:r>
+          </a:p>
+          <a:p>
+            <a:r>
+              <a:rPr sz="1050" b="0"/>
+              <a:t>  (155 人耳核对事件)</a:t>
+            </a:r>
+          </a:p>
+          <a:p>
+            <a:r>
+              <a:rPr sz="1050" b="0"/>
+              <a:t>• 图像召回 96.2%</a:t>
+            </a:r>
+          </a:p>
+          <a:p>
+            <a:r>
+              <a:rPr sz="1050" b="0"/>
+              <a:t>  (266 独立测试图)</a:t>
+            </a:r>
+          </a:p>
+          <a:p>
+            <a:r>
+              <a:rPr sz="1050" b="0"/>
+              <a:t>• 音频特异性 100%</a:t>
+            </a:r>
+          </a:p>
+          <a:p>
+            <a:r>
+              <a:rPr sz="1050" b="0"/>
+              <a:t>  (2063 负样本 0 误报)</a:t>
+            </a:r>
+          </a:p>
+          <a:p>
+            <a:r>
+              <a:rPr sz="1050" b="0"/>
+              <a:t>• 端到端延迟 ~10.5s</a:t>
+            </a:r>
+          </a:p>
+          <a:p>
+            <a:r>
+              <a:rPr sz="1050" b="0"/>
+              <a:t>• GEMM 纯核加速 4.64x</a:t>
+            </a:r>
+          </a:p>
+          <a:p>
+            <a:r>
+              <a:rPr sz="1050" b="0"/>
+              <a:t>• 音频 overlay LUT 3.15%</a:t>
+            </a:r>
+          </a:p>
+          <a:p>
+            <a:r>
+              <a:rPr sz="1050" b="0"/>
+              <a:t>• 录像 37.4s H.264</a:t>
             </a:r>
           </a:p>
         </p:txBody>
@@ -18635,133 +19499,16 @@
           <a:p/>
         </p:txBody>
       </p:sp>
-      <p:cxnSp>
-        <p:nvCxnSpPr>
-          <p:cNvPr id="12" name="Straight Connector 11">
-            <a:extLst>
-              <a:ext uri="{FF2B5EF4-FFF2-40B4-BE49-F238E27FC236}">
-                <a16:creationId xmlns:a16="http://schemas.microsoft.com/office/drawing/2014/main" id="{C6959FA9-7E35-379E-77F4-1F6BBF5DF8D9}"/>
-              </a:ext>
-            </a:extLst>
-          </p:cNvPr>
-          <p:cNvCxnSpPr>
-            <a:cxnSpLocks/>
-          </p:cNvCxnSpPr>
-          <p:nvPr/>
-        </p:nvCxnSpPr>
-        <p:spPr>
-          <a:xfrm>
-            <a:off x="5986823" y="174738"/>
-            <a:ext cx="2322305" cy="1743280"/>
-          </a:xfrm>
-          <a:prstGeom prst="line">
-            <a:avLst/>
-          </a:prstGeom>
-          <a:ln w="12700"/>
-        </p:spPr>
-        <p:style>
-          <a:lnRef idx="1">
-            <a:schemeClr val="dk1"/>
-          </a:lnRef>
-          <a:fillRef idx="0">
-            <a:schemeClr val="dk1"/>
-          </a:fillRef>
-          <a:effectRef idx="0">
-            <a:schemeClr val="dk1"/>
-          </a:effectRef>
-          <a:fontRef idx="minor">
-            <a:schemeClr val="tx1"/>
-          </a:fontRef>
-        </p:style>
-      </p:cxnSp>
-      <p:cxnSp>
-        <p:nvCxnSpPr>
-          <p:cNvPr id="13" name="Straight Connector 12">
-            <a:extLst>
-              <a:ext uri="{FF2B5EF4-FFF2-40B4-BE49-F238E27FC236}">
-                <a16:creationId xmlns:a16="http://schemas.microsoft.com/office/drawing/2014/main" id="{933CCBA0-FAB3-2B8C-FF7C-6D01676E605B}"/>
-              </a:ext>
-            </a:extLst>
-          </p:cNvPr>
-          <p:cNvCxnSpPr>
-            <a:cxnSpLocks/>
-          </p:cNvCxnSpPr>
-          <p:nvPr/>
-        </p:nvCxnSpPr>
-        <p:spPr>
-          <a:xfrm flipV="1">
-            <a:off x="8309128" y="1906544"/>
-            <a:ext cx="3703067" cy="10740"/>
-          </a:xfrm>
-          <a:prstGeom prst="line">
-            <a:avLst/>
-          </a:prstGeom>
-          <a:ln w="12700"/>
-        </p:spPr>
-        <p:style>
-          <a:lnRef idx="1">
-            <a:schemeClr val="dk1"/>
-          </a:lnRef>
-          <a:fillRef idx="0">
-            <a:schemeClr val="dk1"/>
-          </a:fillRef>
-          <a:effectRef idx="0">
-            <a:schemeClr val="dk1"/>
-          </a:effectRef>
-          <a:fontRef idx="minor">
-            <a:schemeClr val="tx1"/>
-          </a:fontRef>
-        </p:style>
-      </p:cxnSp>
-      <p:cxnSp>
-        <p:nvCxnSpPr>
-          <p:cNvPr id="14" name="Straight Connector 13">
-            <a:extLst>
-              <a:ext uri="{FF2B5EF4-FFF2-40B4-BE49-F238E27FC236}">
-                <a16:creationId xmlns:a16="http://schemas.microsoft.com/office/drawing/2014/main" id="{F1E00891-515C-956C-17FC-86789D545647}"/>
-              </a:ext>
-            </a:extLst>
-          </p:cNvPr>
-          <p:cNvCxnSpPr>
-            <a:cxnSpLocks/>
-          </p:cNvCxnSpPr>
-          <p:nvPr/>
-        </p:nvCxnSpPr>
-        <p:spPr>
-          <a:xfrm>
-            <a:off x="8309128" y="1918018"/>
-            <a:ext cx="0" cy="4729429"/>
-          </a:xfrm>
-          <a:prstGeom prst="line">
-            <a:avLst/>
-          </a:prstGeom>
-          <a:ln w="12700"/>
-        </p:spPr>
-        <p:style>
-          <a:lnRef idx="1">
-            <a:schemeClr val="dk1"/>
-          </a:lnRef>
-          <a:fillRef idx="0">
-            <a:schemeClr val="dk1"/>
-          </a:fillRef>
-          <a:effectRef idx="0">
-            <a:schemeClr val="dk1"/>
-          </a:effectRef>
-          <a:fontRef idx="minor">
-            <a:schemeClr val="tx1"/>
-          </a:fontRef>
-        </p:style>
-      </p:cxnSp>
-      <p:sp>
-        <p:nvSpPr>
-          <p:cNvPr id="15" name="TextBox 14"/>
+      <p:sp>
+        <p:nvSpPr>
+          <p:cNvPr id="2" name="TextBox 1"/>
           <p:cNvSpPr txBox="1"/>
           <p:nvPr/>
         </p:nvSpPr>
         <p:spPr>
           <a:xfrm>
-            <a:off x="274320" y="274320"/>
-            <a:ext cx="6400800" cy="731520"/>
+            <a:off x="274320" y="182880"/>
+            <a:ext cx="6400800" cy="640080"/>
           </a:xfrm>
           <a:prstGeom prst="rect">
             <a:avLst/>
@@ -18775,54 +19522,19 @@
           <a:lstStyle/>
           <a:p>
             <a:r>
-              <a:rPr sz="3200" b="1">
+              <a:rPr sz="2800" b="1">
                 <a:solidFill>
                   <a:srgbClr val="1A1A2E"/>
                 </a:solidFill>
               </a:rPr>
-              <a:t>Acoustic-Visual Collaborative Monitoring for Fairy Pitta</a:t>
-            </a:r>
-          </a:p>
-        </p:txBody>
-      </p:sp>
-      <p:sp>
-        <p:nvSpPr>
-          <p:cNvPr id="16" name="TextBox 15"/>
-          <p:cNvSpPr txBox="1"/>
-          <p:nvPr/>
-        </p:nvSpPr>
-        <p:spPr>
-          <a:xfrm>
-            <a:off x="6858000" y="274320"/>
-            <a:ext cx="2286000" cy="731520"/>
-          </a:xfrm>
-          <a:prstGeom prst="rect">
-            <a:avLst/>
-          </a:prstGeom>
-          <a:noFill/>
-        </p:spPr>
-        <p:txBody>
-          <a:bodyPr wrap="none">
-            <a:spAutoFit/>
-          </a:bodyPr>
-          <a:lstStyle/>
-          <a:p>
-            <a:r>
-              <a:rPr sz="1800" b="1"/>
-              <a:t>Wuhan University</a:t>
-            </a:r>
-          </a:p>
-          <a:p>
-            <a:r>
-              <a:rPr sz="1400"/>
-              <a:t>School of Electronic Engineering</a:t>
+              <a:t>Acoustic-Visual Monitoring for Fairy Pitta</a:t>
             </a:r>
           </a:p>
         </p:txBody>
       </p:sp>
       <p:pic>
         <p:nvPicPr>
-          <p:cNvPr id="17" name="Picture 16" descr="1.1-标准校徽.png"/>
+          <p:cNvPr id="3" name="Picture 2" descr="1.1-标准校徽.png"/>
           <p:cNvPicPr>
             <a:picLocks noChangeAspect="1"/>
           </p:cNvPicPr>
@@ -18836,8 +19548,8 @@
         </p:blipFill>
         <p:spPr>
           <a:xfrm>
-            <a:off x="9326880" y="182880"/>
-            <a:ext cx="822960" cy="822960"/>
+            <a:off x="9601200" y="137160"/>
+            <a:ext cx="731520" cy="731520"/>
           </a:xfrm>
           <a:prstGeom prst="rect">
             <a:avLst/>
@@ -18846,14 +19558,14 @@
       </p:pic>
       <p:sp>
         <p:nvSpPr>
-          <p:cNvPr id="18" name="TextBox 17"/>
+          <p:cNvPr id="4" name="TextBox 3"/>
           <p:cNvSpPr txBox="1"/>
           <p:nvPr/>
         </p:nvSpPr>
         <p:spPr>
           <a:xfrm>
-            <a:off x="6858000" y="1005840"/>
-            <a:ext cx="2743200" cy="365760"/>
+            <a:off x="7315200" y="182880"/>
+            <a:ext cx="2103120" cy="640080"/>
           </a:xfrm>
           <a:prstGeom prst="rect">
             <a:avLst/>
@@ -18867,22 +19579,28 @@
           <a:lstStyle/>
           <a:p>
             <a:r>
-              <a:rPr sz="1300"/>
-              <a:t>Team: XXX, XXX, XXX</a:t>
-            </a:r>
-          </a:p>
-        </p:txBody>
-      </p:sp>
-      <p:sp>
-        <p:nvSpPr>
-          <p:cNvPr id="19" name="TextBox 18"/>
+              <a:rPr sz="1600" b="1"/>
+              <a:t>Wuhan University</a:t>
+            </a:r>
+          </a:p>
+          <a:p>
+            <a:r>
+              <a:rPr sz="1200"/>
+              <a:t>School of Electronic Engineering</a:t>
+            </a:r>
+          </a:p>
+        </p:txBody>
+      </p:sp>
+      <p:sp>
+        <p:nvSpPr>
+          <p:cNvPr id="5" name="TextBox 4"/>
           <p:cNvSpPr txBox="1"/>
           <p:nvPr/>
         </p:nvSpPr>
         <p:spPr>
           <a:xfrm>
-            <a:off x="10241280" y="1188720"/>
-            <a:ext cx="1828800" cy="365760"/>
+            <a:off x="7315200" y="868680"/>
+            <a:ext cx="2743200" cy="320040"/>
           </a:xfrm>
           <a:prstGeom prst="rect">
             <a:avLst/>
@@ -18897,21 +19615,21 @@
           <a:p>
             <a:r>
               <a:rPr sz="1100"/>
-              <a:t>On-board: AMD PYNQ-Z2</a:t>
-            </a:r>
-          </a:p>
-        </p:txBody>
-      </p:sp>
-      <p:sp>
-        <p:nvSpPr>
-          <p:cNvPr id="20" name="TextBox 19"/>
+              <a:t>Team: XXX, XXX, XXX</a:t>
+            </a:r>
+          </a:p>
+        </p:txBody>
+      </p:sp>
+      <p:sp>
+        <p:nvSpPr>
+          <p:cNvPr id="6" name="TextBox 5"/>
           <p:cNvSpPr txBox="1"/>
           <p:nvPr/>
         </p:nvSpPr>
         <p:spPr>
           <a:xfrm>
-            <a:off x="274320" y="1188720"/>
-            <a:ext cx="3200400" cy="365760"/>
+            <a:off x="274320" y="1097280"/>
+            <a:ext cx="3200400" cy="320040"/>
           </a:xfrm>
           <a:prstGeom prst="rect">
             <a:avLst/>
@@ -18925,7 +19643,7 @@
           <a:lstStyle/>
           <a:p>
             <a:r>
-              <a:rPr sz="1600" b="1"/>
+              <a:rPr sz="1400" b="1"/>
               <a:t>INTRODUCTION</a:t>
             </a:r>
           </a:p>
@@ -18933,14 +19651,14 @@
       </p:sp>
       <p:sp>
         <p:nvSpPr>
-          <p:cNvPr id="21" name="TextBox 20"/>
+          <p:cNvPr id="7" name="TextBox 6"/>
           <p:cNvSpPr txBox="1"/>
           <p:nvPr/>
         </p:nvSpPr>
         <p:spPr>
           <a:xfrm>
-            <a:off x="274320" y="1645920"/>
-            <a:ext cx="3474720" cy="4114800"/>
+            <a:off x="274320" y="1463040"/>
+            <a:ext cx="3200400" cy="3200400"/>
           </a:xfrm>
           <a:prstGeom prst="rect">
             <a:avLst/>
@@ -18954,70 +19672,94 @@
           <a:lstStyle/>
           <a:p>
             <a:r>
-              <a:rPr sz="1100" b="1"/>
+              <a:rPr sz="1050" b="1"/>
               <a:t>Background:</a:t>
             </a:r>
           </a:p>
           <a:p>
             <a:r>
-              <a:rPr sz="1100" b="0"/>
-              <a:t>Fairy Pitta is a national protected species in China. This system achieves call detection, visual confirmation, and auto recording fully on PYNQ-Z2.</a:t>
-            </a:r>
-          </a:p>
-          <a:p>
-            <a:r>
-              <a:rPr sz="1100" b="0"/>
+              <a:rPr sz="1050" b="0"/>
+              <a:t>Fairy Pitta is a national protected species. This system achieves call detection, visual confirmation, and auto recording on PYNQ-Z2.</a:t>
+            </a:r>
+          </a:p>
+          <a:p>
+            <a:r>
+              <a:rPr sz="1050" b="0"/>
               <a:t/>
             </a:r>
           </a:p>
           <a:p>
             <a:r>
-              <a:rPr sz="1100" b="1"/>
+              <a:rPr sz="1050" b="1"/>
               <a:t>Approach:</a:t>
             </a:r>
           </a:p>
           <a:p>
             <a:r>
-              <a:rPr sz="1100" b="0"/>
-              <a:t>1. PL I2S+AXI DMA: 32kHz mic stream, zero CPU overhead</a:t>
-            </a:r>
-          </a:p>
-          <a:p>
-            <a:r>
-              <a:rPr sz="1100" b="0"/>
-              <a:t>2. PS 3-layer CNN bird call detection, trigger at 0.985</a:t>
-            </a:r>
-          </a:p>
-          <a:p>
-            <a:r>
-              <a:rPr sz="1100" b="0"/>
-              <a:t>3. USB camera + YOLOv8n(NCNN) confirmation + recording</a:t>
-            </a:r>
-          </a:p>
-          <a:p>
-            <a:r>
-              <a:rPr sz="1100" b="0"/>
-              <a:t>4. Vitis HLS GEMM IP for conv1 (4.64x core speedup)</a:t>
-            </a:r>
-          </a:p>
-          <a:p>
-            <a:r>
-              <a:rPr sz="1100" b="0"/>
-              <a:t>5. Presence-based recording: 5-10x storage efficiency</a:t>
-            </a:r>
-          </a:p>
-        </p:txBody>
-      </p:sp>
-      <p:sp>
-        <p:nvSpPr>
-          <p:cNvPr id="22" name="TextBox 21"/>
+              <a:rPr sz="1050" b="0"/>
+              <a:t>1. PL I2S+DMA mic acquisition</a:t>
+            </a:r>
+          </a:p>
+          <a:p>
+            <a:r>
+              <a:rPr sz="1050" b="0"/>
+              <a:t>2. PS CNN bird call trigger</a:t>
+            </a:r>
+          </a:p>
+          <a:p>
+            <a:r>
+              <a:rPr sz="1050" b="0"/>
+              <a:t>3. YOLOv8n visual recording</a:t>
+            </a:r>
+          </a:p>
+          <a:p>
+            <a:r>
+              <a:rPr sz="1050" b="0"/>
+              <a:t>4. HLS GEMM acceleration</a:t>
+            </a:r>
+          </a:p>
+          <a:p>
+            <a:r>
+              <a:rPr sz="1050" b="0"/>
+              <a:t>5. Efficient presence-based recording</a:t>
+            </a:r>
+          </a:p>
+        </p:txBody>
+      </p:sp>
+      <p:pic>
+        <p:nvPicPr>
+          <p:cNvPr id="8" name="Picture 7" descr="web_01.jpg"/>
+          <p:cNvPicPr>
+            <a:picLocks noChangeAspect="1"/>
+          </p:cNvPicPr>
+          <p:nvPr/>
+        </p:nvPicPr>
+        <p:blipFill>
+          <a:blip r:embed="rId10"/>
+          <a:stretch>
+            <a:fillRect/>
+          </a:stretch>
+        </p:blipFill>
+        <p:spPr>
+          <a:xfrm>
+            <a:off x="274320" y="4754880"/>
+            <a:ext cx="2011680" cy="1645920"/>
+          </a:xfrm>
+          <a:prstGeom prst="rect">
+            <a:avLst/>
+          </a:prstGeom>
+        </p:spPr>
+      </p:pic>
+      <p:sp>
+        <p:nvSpPr>
+          <p:cNvPr id="9" name="TextBox 8"/>
           <p:cNvSpPr txBox="1"/>
           <p:nvPr/>
         </p:nvSpPr>
         <p:spPr>
           <a:xfrm>
-            <a:off x="4114800" y="1188720"/>
-            <a:ext cx="2743200" cy="365760"/>
+            <a:off x="274320" y="6400800"/>
+            <a:ext cx="2011680" cy="274320"/>
           </a:xfrm>
           <a:prstGeom prst="rect">
             <a:avLst/>
@@ -19032,7 +19774,37 @@
           <a:p>
             <a:pPr algn="ctr"/>
             <a:r>
-              <a:rPr sz="1600" b="1"/>
+              <a:rPr sz="900"/>
+              <a:t>Fairy Pitta (Pitta nympha)</a:t>
+            </a:r>
+          </a:p>
+        </p:txBody>
+      </p:sp>
+      <p:sp>
+        <p:nvSpPr>
+          <p:cNvPr id="10" name="TextBox 9"/>
+          <p:cNvSpPr txBox="1"/>
+          <p:nvPr/>
+        </p:nvSpPr>
+        <p:spPr>
+          <a:xfrm>
+            <a:off x="3840480" y="1097280"/>
+            <a:ext cx="3657600" cy="320040"/>
+          </a:xfrm>
+          <a:prstGeom prst="rect">
+            <a:avLst/>
+          </a:prstGeom>
+          <a:noFill/>
+        </p:spPr>
+        <p:txBody>
+          <a:bodyPr wrap="none">
+            <a:spAutoFit/>
+          </a:bodyPr>
+          <a:lstStyle/>
+          <a:p>
+            <a:pPr algn="ctr"/>
+            <a:r>
+              <a:rPr sz="1400" b="1"/>
               <a:t>System Architecture</a:t>
             </a:r>
           </a:p>
@@ -19040,24 +19812,24 @@
       </p:sp>
       <p:sp>
         <p:nvSpPr>
-          <p:cNvPr id="23" name="Rounded Rectangle 22"/>
+          <p:cNvPr id="11" name="Rounded Rectangle 10"/>
           <p:cNvSpPr/>
           <p:nvPr/>
         </p:nvSpPr>
         <p:spPr>
           <a:xfrm>
-            <a:off x="4114800" y="1737360"/>
-            <a:ext cx="3474720" cy="1828800"/>
+            <a:off x="3840480" y="1554480"/>
+            <a:ext cx="3840480" cy="1645920"/>
           </a:xfrm>
           <a:prstGeom prst="roundRect">
             <a:avLst/>
           </a:prstGeom>
           <a:solidFill>
-            <a:srgbClr val="E8F0FE"/>
+            <a:srgbClr val="E3F2FD"/>
           </a:solidFill>
-          <a:ln>
+          <a:ln w="19050">
             <a:solidFill>
-              <a:srgbClr val="4A90D9"/>
+              <a:srgbClr val="1565C0"/>
             </a:solidFill>
           </a:ln>
         </p:spPr>
@@ -19076,61 +19848,41 @@
           </a:fontRef>
         </p:style>
         <p:txBody>
-          <a:bodyPr rtlCol="0" anchor="ctr" wrap="square"/>
+          <a:bodyPr rtlCol="0" anchor="ctr"/>
           <a:lstStyle/>
           <a:p>
             <a:pPr algn="ctr"/>
             <a:r>
-              <a:rPr sz="1100" b="1"/>
-              <a:t>Audio Acquisition &amp; Detection</a:t>
-            </a:r>
-          </a:p>
-          <a:p>
-            <a:r>
-              <a:rPr sz="1100" b="0"/>
-              <a:t>- INMP441 I2S digital MEMS microphone</a:t>
-            </a:r>
-          </a:p>
-          <a:p>
-            <a:r>
-              <a:rPr sz="1100" b="0"/>
-              <a:t>- 2s window to STFT/Mel [64,201]</a:t>
-            </a:r>
-          </a:p>
-          <a:p>
-            <a:r>
-              <a:rPr sz="1100" b="0"/>
-              <a:t>- 3-layer CNN + Sigmoid call probability</a:t>
-            </a:r>
-          </a:p>
-          <a:p>
-            <a:r>
-              <a:rPr sz="1100" b="0"/>
-              <a:t>- score &gt;= 0.985 triggers visual module</a:t>
-            </a:r>
-          </a:p>
-        </p:txBody>
-      </p:sp>
-      <p:sp>
-        <p:nvSpPr>
-          <p:cNvPr id="24" name="Rounded Rectangle 23"/>
+              <a:rPr sz="1100" b="1">
+                <a:solidFill>
+                  <a:srgbClr val="1565C0"/>
+                </a:solidFill>
+              </a:rPr>
+              <a:t>PL (FPGA)</a:t>
+            </a:r>
+          </a:p>
+        </p:txBody>
+      </p:sp>
+      <p:sp>
+        <p:nvSpPr>
+          <p:cNvPr id="12" name="Rounded Rectangle 11"/>
           <p:cNvSpPr/>
           <p:nvPr/>
         </p:nvSpPr>
         <p:spPr>
           <a:xfrm>
-            <a:off x="4114800" y="3840480"/>
-            <a:ext cx="3474720" cy="1828800"/>
+            <a:off x="4023360" y="2103120"/>
+            <a:ext cx="822960" cy="457200"/>
           </a:xfrm>
           <a:prstGeom prst="roundRect">
             <a:avLst/>
           </a:prstGeom>
           <a:solidFill>
-            <a:srgbClr val="E8F8E8"/>
+            <a:srgbClr val="BBDBFB"/>
           </a:solidFill>
           <a:ln>
             <a:solidFill>
-              <a:srgbClr val="4CAF50"/>
+              <a:srgbClr val="1565C0"/>
             </a:solidFill>
           </a:ln>
         </p:spPr>
@@ -19149,51 +19901,531 @@
           </a:fontRef>
         </p:style>
         <p:txBody>
-          <a:bodyPr rtlCol="0" anchor="ctr" wrap="square"/>
+          <a:bodyPr rtlCol="0" anchor="ctr"/>
           <a:lstStyle/>
           <a:p>
             <a:pPr algn="ctr"/>
             <a:r>
-              <a:rPr sz="1100" b="1"/>
-              <a:t>Visual Detection &amp; Recording</a:t>
-            </a:r>
-          </a:p>
-          <a:p>
-            <a:r>
-              <a:rPr sz="1100" b="0"/>
-              <a:t>- USB UVC camera 640x480</a:t>
-            </a:r>
-          </a:p>
-          <a:p>
-            <a:r>
-              <a:rPr sz="1100" b="0"/>
-              <a:t>- YOLOv8n (NCNN), confidence &gt;= 0.52</a:t>
-            </a:r>
-          </a:p>
-          <a:p>
-            <a:r>
-              <a:rPr sz="1100" b="0"/>
-              <a:t>- Auto snapshot + H.264 MP4 on detection</a:t>
-            </a:r>
-          </a:p>
-          <a:p>
-            <a:r>
-              <a:rPr sz="1100" b="0"/>
-              <a:t>- Stop after 3 misses + 6s span</a:t>
-            </a:r>
-          </a:p>
-        </p:txBody>
-      </p:sp>
-      <p:sp>
-        <p:nvSpPr>
-          <p:cNvPr id="25" name="TextBox 24"/>
+              <a:rPr sz="800"/>
+              <a:t>INMP441
+I2S</a:t>
+            </a:r>
+          </a:p>
+        </p:txBody>
+      </p:sp>
+      <p:sp>
+        <p:nvSpPr>
+          <p:cNvPr id="13" name="Rounded Rectangle 12"/>
+          <p:cNvSpPr/>
+          <p:nvPr/>
+        </p:nvSpPr>
+        <p:spPr>
+          <a:xfrm>
+            <a:off x="5029200" y="2103120"/>
+            <a:ext cx="822960" cy="457200"/>
+          </a:xfrm>
+          <a:prstGeom prst="roundRect">
+            <a:avLst/>
+          </a:prstGeom>
+          <a:solidFill>
+            <a:srgbClr val="BBDBFB"/>
+          </a:solidFill>
+          <a:ln>
+            <a:solidFill>
+              <a:srgbClr val="1565C0"/>
+            </a:solidFill>
+          </a:ln>
+        </p:spPr>
+        <p:style>
+          <a:lnRef idx="1">
+            <a:schemeClr val="accent1"/>
+          </a:lnRef>
+          <a:fillRef idx="3">
+            <a:schemeClr val="accent1"/>
+          </a:fillRef>
+          <a:effectRef idx="2">
+            <a:schemeClr val="accent1"/>
+          </a:effectRef>
+          <a:fontRef idx="minor">
+            <a:schemeClr val="lt1"/>
+          </a:fontRef>
+        </p:style>
+        <p:txBody>
+          <a:bodyPr rtlCol="0" anchor="ctr"/>
+          <a:lstStyle/>
+          <a:p>
+            <a:pPr algn="ctr"/>
+            <a:r>
+              <a:rPr sz="800"/>
+              <a:t>I2S
+Receiver</a:t>
+            </a:r>
+          </a:p>
+        </p:txBody>
+      </p:sp>
+      <p:sp>
+        <p:nvSpPr>
+          <p:cNvPr id="14" name="Rounded Rectangle 13"/>
+          <p:cNvSpPr/>
+          <p:nvPr/>
+        </p:nvSpPr>
+        <p:spPr>
+          <a:xfrm>
+            <a:off x="6035040" y="2103120"/>
+            <a:ext cx="822960" cy="457200"/>
+          </a:xfrm>
+          <a:prstGeom prst="roundRect">
+            <a:avLst/>
+          </a:prstGeom>
+          <a:solidFill>
+            <a:srgbClr val="BBDBFB"/>
+          </a:solidFill>
+          <a:ln>
+            <a:solidFill>
+              <a:srgbClr val="1565C0"/>
+            </a:solidFill>
+          </a:ln>
+        </p:spPr>
+        <p:style>
+          <a:lnRef idx="1">
+            <a:schemeClr val="accent1"/>
+          </a:lnRef>
+          <a:fillRef idx="3">
+            <a:schemeClr val="accent1"/>
+          </a:fillRef>
+          <a:effectRef idx="2">
+            <a:schemeClr val="accent1"/>
+          </a:effectRef>
+          <a:fontRef idx="minor">
+            <a:schemeClr val="lt1"/>
+          </a:fontRef>
+        </p:style>
+        <p:txBody>
+          <a:bodyPr rtlCol="0" anchor="ctr"/>
+          <a:lstStyle/>
+          <a:p>
+            <a:pPr algn="ctr"/>
+            <a:r>
+              <a:rPr sz="800"/>
+              <a:t>AXI
+DMA</a:t>
+            </a:r>
+          </a:p>
+        </p:txBody>
+      </p:sp>
+      <p:sp>
+        <p:nvSpPr>
+          <p:cNvPr id="15" name="Rounded Rectangle 14"/>
+          <p:cNvSpPr/>
+          <p:nvPr/>
+        </p:nvSpPr>
+        <p:spPr>
+          <a:xfrm>
+            <a:off x="4023360" y="2651760"/>
+            <a:ext cx="822960" cy="457200"/>
+          </a:xfrm>
+          <a:prstGeom prst="roundRect">
+            <a:avLst/>
+          </a:prstGeom>
+          <a:solidFill>
+            <a:srgbClr val="BBDBFB"/>
+          </a:solidFill>
+          <a:ln>
+            <a:solidFill>
+              <a:srgbClr val="1565C0"/>
+            </a:solidFill>
+          </a:ln>
+        </p:spPr>
+        <p:style>
+          <a:lnRef idx="1">
+            <a:schemeClr val="accent1"/>
+          </a:lnRef>
+          <a:fillRef idx="3">
+            <a:schemeClr val="accent1"/>
+          </a:fillRef>
+          <a:effectRef idx="2">
+            <a:schemeClr val="accent1"/>
+          </a:effectRef>
+          <a:fontRef idx="minor">
+            <a:schemeClr val="lt1"/>
+          </a:fontRef>
+        </p:style>
+        <p:txBody>
+          <a:bodyPr rtlCol="0" anchor="ctr"/>
+          <a:lstStyle/>
+          <a:p>
+            <a:pPr algn="ctr"/>
+            <a:r>
+              <a:rPr sz="800"/>
+              <a:t>GEMM
+HLS IP</a:t>
+            </a:r>
+          </a:p>
+        </p:txBody>
+      </p:sp>
+      <p:sp>
+        <p:nvSpPr>
+          <p:cNvPr id="16" name="Rounded Rectangle 15"/>
+          <p:cNvSpPr/>
+          <p:nvPr/>
+        </p:nvSpPr>
+        <p:spPr>
+          <a:xfrm>
+            <a:off x="3840480" y="3383280"/>
+            <a:ext cx="3840480" cy="2560320"/>
+          </a:xfrm>
+          <a:prstGeom prst="roundRect">
+            <a:avLst/>
+          </a:prstGeom>
+          <a:solidFill>
+            <a:srgbClr val="E8F5E9"/>
+          </a:solidFill>
+          <a:ln w="19050">
+            <a:solidFill>
+              <a:srgbClr val="2E7D32"/>
+            </a:solidFill>
+          </a:ln>
+        </p:spPr>
+        <p:style>
+          <a:lnRef idx="1">
+            <a:schemeClr val="accent1"/>
+          </a:lnRef>
+          <a:fillRef idx="3">
+            <a:schemeClr val="accent1"/>
+          </a:fillRef>
+          <a:effectRef idx="2">
+            <a:schemeClr val="accent1"/>
+          </a:effectRef>
+          <a:fontRef idx="minor">
+            <a:schemeClr val="lt1"/>
+          </a:fontRef>
+        </p:style>
+        <p:txBody>
+          <a:bodyPr rtlCol="0" anchor="ctr"/>
+          <a:lstStyle/>
+          <a:p>
+            <a:pPr algn="ctr"/>
+            <a:r>
+              <a:rPr sz="1100" b="1">
+                <a:solidFill>
+                  <a:srgbClr val="2E7D32"/>
+                </a:solidFill>
+              </a:rPr>
+              <a:t>PS (ARM Cortex-A9)</a:t>
+            </a:r>
+          </a:p>
+        </p:txBody>
+      </p:sp>
+      <p:sp>
+        <p:nvSpPr>
+          <p:cNvPr id="17" name="Rounded Rectangle 16"/>
+          <p:cNvSpPr/>
+          <p:nvPr/>
+        </p:nvSpPr>
+        <p:spPr>
+          <a:xfrm>
+            <a:off x="4023360" y="3931920"/>
+            <a:ext cx="1005840" cy="502920"/>
+          </a:xfrm>
+          <a:prstGeom prst="roundRect">
+            <a:avLst/>
+          </a:prstGeom>
+          <a:solidFill>
+            <a:srgbClr val="C8E6C9"/>
+          </a:solidFill>
+          <a:ln>
+            <a:solidFill>
+              <a:srgbClr val="2E7D32"/>
+            </a:solidFill>
+          </a:ln>
+        </p:spPr>
+        <p:style>
+          <a:lnRef idx="1">
+            <a:schemeClr val="accent1"/>
+          </a:lnRef>
+          <a:fillRef idx="3">
+            <a:schemeClr val="accent1"/>
+          </a:fillRef>
+          <a:effectRef idx="2">
+            <a:schemeClr val="accent1"/>
+          </a:effectRef>
+          <a:fontRef idx="minor">
+            <a:schemeClr val="lt1"/>
+          </a:fontRef>
+        </p:style>
+        <p:txBody>
+          <a:bodyPr rtlCol="0" anchor="ctr"/>
+          <a:lstStyle/>
+          <a:p>
+            <a:pPr algn="ctr"/>
+            <a:r>
+              <a:rPr sz="800"/>
+              <a:t>STFT/Mel
+Features</a:t>
+            </a:r>
+          </a:p>
+        </p:txBody>
+      </p:sp>
+      <p:sp>
+        <p:nvSpPr>
+          <p:cNvPr id="18" name="Rounded Rectangle 17"/>
+          <p:cNvSpPr/>
+          <p:nvPr/>
+        </p:nvSpPr>
+        <p:spPr>
+          <a:xfrm>
+            <a:off x="5212080" y="3931920"/>
+            <a:ext cx="1005840" cy="502920"/>
+          </a:xfrm>
+          <a:prstGeom prst="roundRect">
+            <a:avLst/>
+          </a:prstGeom>
+          <a:solidFill>
+            <a:srgbClr val="C8E6C9"/>
+          </a:solidFill>
+          <a:ln>
+            <a:solidFill>
+              <a:srgbClr val="2E7D32"/>
+            </a:solidFill>
+          </a:ln>
+        </p:spPr>
+        <p:style>
+          <a:lnRef idx="1">
+            <a:schemeClr val="accent1"/>
+          </a:lnRef>
+          <a:fillRef idx="3">
+            <a:schemeClr val="accent1"/>
+          </a:fillRef>
+          <a:effectRef idx="2">
+            <a:schemeClr val="accent1"/>
+          </a:effectRef>
+          <a:fontRef idx="minor">
+            <a:schemeClr val="lt1"/>
+          </a:fontRef>
+        </p:style>
+        <p:txBody>
+          <a:bodyPr rtlCol="0" anchor="ctr"/>
+          <a:lstStyle/>
+          <a:p>
+            <a:pPr algn="ctr"/>
+            <a:r>
+              <a:rPr sz="800"/>
+              <a:t>Bird CNN
+score</a:t>
+            </a:r>
+          </a:p>
+        </p:txBody>
+      </p:sp>
+      <p:sp>
+        <p:nvSpPr>
+          <p:cNvPr id="19" name="Rounded Rectangle 18"/>
+          <p:cNvSpPr/>
+          <p:nvPr/>
+        </p:nvSpPr>
+        <p:spPr>
+          <a:xfrm>
+            <a:off x="6400800" y="3931920"/>
+            <a:ext cx="1005840" cy="502920"/>
+          </a:xfrm>
+          <a:prstGeom prst="roundRect">
+            <a:avLst/>
+          </a:prstGeom>
+          <a:solidFill>
+            <a:srgbClr val="C8E6C9"/>
+          </a:solidFill>
+          <a:ln>
+            <a:solidFill>
+              <a:srgbClr val="2E7D32"/>
+            </a:solidFill>
+          </a:ln>
+        </p:spPr>
+        <p:style>
+          <a:lnRef idx="1">
+            <a:schemeClr val="accent1"/>
+          </a:lnRef>
+          <a:fillRef idx="3">
+            <a:schemeClr val="accent1"/>
+          </a:fillRef>
+          <a:effectRef idx="2">
+            <a:schemeClr val="accent1"/>
+          </a:effectRef>
+          <a:fontRef idx="minor">
+            <a:schemeClr val="lt1"/>
+          </a:fontRef>
+        </p:style>
+        <p:txBody>
+          <a:bodyPr rtlCol="0" anchor="ctr"/>
+          <a:lstStyle/>
+          <a:p>
+            <a:pPr algn="ctr"/>
+            <a:r>
+              <a:rPr sz="800"/>
+              <a:t>Trigger
+file</a:t>
+            </a:r>
+          </a:p>
+        </p:txBody>
+      </p:sp>
+      <p:sp>
+        <p:nvSpPr>
+          <p:cNvPr id="20" name="Rounded Rectangle 19"/>
+          <p:cNvSpPr/>
+          <p:nvPr/>
+        </p:nvSpPr>
+        <p:spPr>
+          <a:xfrm>
+            <a:off x="4023360" y="4572000"/>
+            <a:ext cx="1005840" cy="502920"/>
+          </a:xfrm>
+          <a:prstGeom prst="roundRect">
+            <a:avLst/>
+          </a:prstGeom>
+          <a:solidFill>
+            <a:srgbClr val="C8E6C9"/>
+          </a:solidFill>
+          <a:ln>
+            <a:solidFill>
+              <a:srgbClr val="2E7D32"/>
+            </a:solidFill>
+          </a:ln>
+        </p:spPr>
+        <p:style>
+          <a:lnRef idx="1">
+            <a:schemeClr val="accent1"/>
+          </a:lnRef>
+          <a:fillRef idx="3">
+            <a:schemeClr val="accent1"/>
+          </a:fillRef>
+          <a:effectRef idx="2">
+            <a:schemeClr val="accent1"/>
+          </a:effectRef>
+          <a:fontRef idx="minor">
+            <a:schemeClr val="lt1"/>
+          </a:fontRef>
+        </p:style>
+        <p:txBody>
+          <a:bodyPr rtlCol="0" anchor="ctr"/>
+          <a:lstStyle/>
+          <a:p>
+            <a:pPr algn="ctr"/>
+            <a:r>
+              <a:rPr sz="800"/>
+              <a:t>USB
+Camera</a:t>
+            </a:r>
+          </a:p>
+        </p:txBody>
+      </p:sp>
+      <p:sp>
+        <p:nvSpPr>
+          <p:cNvPr id="21" name="Rounded Rectangle 20"/>
+          <p:cNvSpPr/>
+          <p:nvPr/>
+        </p:nvSpPr>
+        <p:spPr>
+          <a:xfrm>
+            <a:off x="5212080" y="4572000"/>
+            <a:ext cx="1005840" cy="502920"/>
+          </a:xfrm>
+          <a:prstGeom prst="roundRect">
+            <a:avLst/>
+          </a:prstGeom>
+          <a:solidFill>
+            <a:srgbClr val="C8E6C9"/>
+          </a:solidFill>
+          <a:ln>
+            <a:solidFill>
+              <a:srgbClr val="2E7D32"/>
+            </a:solidFill>
+          </a:ln>
+        </p:spPr>
+        <p:style>
+          <a:lnRef idx="1">
+            <a:schemeClr val="accent1"/>
+          </a:lnRef>
+          <a:fillRef idx="3">
+            <a:schemeClr val="accent1"/>
+          </a:fillRef>
+          <a:effectRef idx="2">
+            <a:schemeClr val="accent1"/>
+          </a:effectRef>
+          <a:fontRef idx="minor">
+            <a:schemeClr val="lt1"/>
+          </a:fontRef>
+        </p:style>
+        <p:txBody>
+          <a:bodyPr rtlCol="0" anchor="ctr"/>
+          <a:lstStyle/>
+          <a:p>
+            <a:pPr algn="ctr"/>
+            <a:r>
+              <a:rPr sz="800"/>
+              <a:t>YOLOv8n
+(NCNN)</a:t>
+            </a:r>
+          </a:p>
+        </p:txBody>
+      </p:sp>
+      <p:sp>
+        <p:nvSpPr>
+          <p:cNvPr id="22" name="Rounded Rectangle 21"/>
+          <p:cNvSpPr/>
+          <p:nvPr/>
+        </p:nvSpPr>
+        <p:spPr>
+          <a:xfrm>
+            <a:off x="6400800" y="4572000"/>
+            <a:ext cx="1005840" cy="502920"/>
+          </a:xfrm>
+          <a:prstGeom prst="roundRect">
+            <a:avLst/>
+          </a:prstGeom>
+          <a:solidFill>
+            <a:srgbClr val="C8E6C9"/>
+          </a:solidFill>
+          <a:ln>
+            <a:solidFill>
+              <a:srgbClr val="2E7D32"/>
+            </a:solidFill>
+          </a:ln>
+        </p:spPr>
+        <p:style>
+          <a:lnRef idx="1">
+            <a:schemeClr val="accent1"/>
+          </a:lnRef>
+          <a:fillRef idx="3">
+            <a:schemeClr val="accent1"/>
+          </a:fillRef>
+          <a:effectRef idx="2">
+            <a:schemeClr val="accent1"/>
+          </a:effectRef>
+          <a:fontRef idx="minor">
+            <a:schemeClr val="lt1"/>
+          </a:fontRef>
+        </p:style>
+        <p:txBody>
+          <a:bodyPr rtlCol="0" anchor="ctr"/>
+          <a:lstStyle/>
+          <a:p>
+            <a:pPr algn="ctr"/>
+            <a:r>
+              <a:rPr sz="800"/>
+              <a:t>Snap +
+H.264 Rec</a:t>
+            </a:r>
+          </a:p>
+        </p:txBody>
+      </p:sp>
+      <p:sp>
+        <p:nvSpPr>
+          <p:cNvPr id="23" name="TextBox 22"/>
           <p:cNvSpPr txBox="1"/>
           <p:nvPr/>
         </p:nvSpPr>
         <p:spPr>
           <a:xfrm>
-            <a:off x="8686800" y="3840480"/>
-            <a:ext cx="3200400" cy="365760"/>
+            <a:off x="8046720" y="1371600"/>
+            <a:ext cx="274320" cy="320040"/>
           </a:xfrm>
           <a:prstGeom prst="rect">
             <a:avLst/>
@@ -19207,22 +20439,26 @@
           <a:lstStyle/>
           <a:p>
             <a:r>
-              <a:rPr sz="1600" b="1"/>
-              <a:t>Performance Results</a:t>
-            </a:r>
-          </a:p>
-        </p:txBody>
-      </p:sp>
-      <p:sp>
-        <p:nvSpPr>
-          <p:cNvPr id="26" name="TextBox 25"/>
+              <a:rPr sz="1400" b="1">
+                <a:solidFill>
+                  <a:srgbClr val="333333"/>
+                </a:solidFill>
+              </a:rPr>
+              <a:t>C</a:t>
+            </a:r>
+          </a:p>
+        </p:txBody>
+      </p:sp>
+      <p:sp>
+        <p:nvSpPr>
+          <p:cNvPr id="24" name="TextBox 23"/>
           <p:cNvSpPr txBox="1"/>
           <p:nvPr/>
         </p:nvSpPr>
         <p:spPr>
           <a:xfrm>
-            <a:off x="8686800" y="4297680"/>
-            <a:ext cx="3200400" cy="2286000"/>
+            <a:off x="8046720" y="1691640"/>
+            <a:ext cx="274320" cy="320040"/>
           </a:xfrm>
           <a:prstGeom prst="rect">
             <a:avLst/>
@@ -19230,50 +20466,542 @@
           <a:noFill/>
         </p:spPr>
         <p:txBody>
+          <a:bodyPr wrap="none">
+            <a:spAutoFit/>
+          </a:bodyPr>
+          <a:lstStyle/>
+          <a:p>
+            <a:r>
+              <a:rPr sz="1400" b="1">
+                <a:solidFill>
+                  <a:srgbClr val="333333"/>
+                </a:solidFill>
+              </a:rPr>
+              <a:t>R</a:t>
+            </a:r>
+          </a:p>
+        </p:txBody>
+      </p:sp>
+      <p:sp>
+        <p:nvSpPr>
+          <p:cNvPr id="25" name="TextBox 24"/>
+          <p:cNvSpPr txBox="1"/>
+          <p:nvPr/>
+        </p:nvSpPr>
+        <p:spPr>
+          <a:xfrm>
+            <a:off x="8046720" y="2011680"/>
+            <a:ext cx="274320" cy="320040"/>
+          </a:xfrm>
+          <a:prstGeom prst="rect">
+            <a:avLst/>
+          </a:prstGeom>
+          <a:noFill/>
+        </p:spPr>
+        <p:txBody>
+          <a:bodyPr wrap="none">
+            <a:spAutoFit/>
+          </a:bodyPr>
+          <a:lstStyle/>
+          <a:p>
+            <a:r>
+              <a:rPr sz="1400" b="1">
+                <a:solidFill>
+                  <a:srgbClr val="333333"/>
+                </a:solidFill>
+              </a:rPr>
+              <a:t>E</a:t>
+            </a:r>
+          </a:p>
+        </p:txBody>
+      </p:sp>
+      <p:sp>
+        <p:nvSpPr>
+          <p:cNvPr id="26" name="TextBox 25"/>
+          <p:cNvSpPr txBox="1"/>
+          <p:nvPr/>
+        </p:nvSpPr>
+        <p:spPr>
+          <a:xfrm>
+            <a:off x="8046720" y="2331720"/>
+            <a:ext cx="274320" cy="320040"/>
+          </a:xfrm>
+          <a:prstGeom prst="rect">
+            <a:avLst/>
+          </a:prstGeom>
+          <a:noFill/>
+        </p:spPr>
+        <p:txBody>
+          <a:bodyPr wrap="none">
+            <a:spAutoFit/>
+          </a:bodyPr>
+          <a:lstStyle/>
+          <a:p>
+            <a:r>
+              <a:rPr sz="1400" b="1">
+                <a:solidFill>
+                  <a:srgbClr val="333333"/>
+                </a:solidFill>
+              </a:rPr>
+              <a:t>A</a:t>
+            </a:r>
+          </a:p>
+        </p:txBody>
+      </p:sp>
+      <p:sp>
+        <p:nvSpPr>
+          <p:cNvPr id="27" name="TextBox 26"/>
+          <p:cNvSpPr txBox="1"/>
+          <p:nvPr/>
+        </p:nvSpPr>
+        <p:spPr>
+          <a:xfrm>
+            <a:off x="8046720" y="2651760"/>
+            <a:ext cx="274320" cy="320040"/>
+          </a:xfrm>
+          <a:prstGeom prst="rect">
+            <a:avLst/>
+          </a:prstGeom>
+          <a:noFill/>
+        </p:spPr>
+        <p:txBody>
+          <a:bodyPr wrap="none">
+            <a:spAutoFit/>
+          </a:bodyPr>
+          <a:lstStyle/>
+          <a:p>
+            <a:r>
+              <a:rPr sz="1400" b="1">
+                <a:solidFill>
+                  <a:srgbClr val="333333"/>
+                </a:solidFill>
+              </a:rPr>
+              <a:t>T</a:t>
+            </a:r>
+          </a:p>
+        </p:txBody>
+      </p:sp>
+      <p:sp>
+        <p:nvSpPr>
+          <p:cNvPr id="28" name="TextBox 27"/>
+          <p:cNvSpPr txBox="1"/>
+          <p:nvPr/>
+        </p:nvSpPr>
+        <p:spPr>
+          <a:xfrm>
+            <a:off x="8046720" y="2971800"/>
+            <a:ext cx="274320" cy="320040"/>
+          </a:xfrm>
+          <a:prstGeom prst="rect">
+            <a:avLst/>
+          </a:prstGeom>
+          <a:noFill/>
+        </p:spPr>
+        <p:txBody>
+          <a:bodyPr wrap="none">
+            <a:spAutoFit/>
+          </a:bodyPr>
+          <a:lstStyle/>
+          <a:p>
+            <a:r>
+              <a:rPr sz="1400" b="1">
+                <a:solidFill>
+                  <a:srgbClr val="333333"/>
+                </a:solidFill>
+              </a:rPr>
+              <a:t>I</a:t>
+            </a:r>
+          </a:p>
+        </p:txBody>
+      </p:sp>
+      <p:sp>
+        <p:nvSpPr>
+          <p:cNvPr id="29" name="TextBox 28"/>
+          <p:cNvSpPr txBox="1"/>
+          <p:nvPr/>
+        </p:nvSpPr>
+        <p:spPr>
+          <a:xfrm>
+            <a:off x="8046720" y="3291839"/>
+            <a:ext cx="274320" cy="320040"/>
+          </a:xfrm>
+          <a:prstGeom prst="rect">
+            <a:avLst/>
+          </a:prstGeom>
+          <a:noFill/>
+        </p:spPr>
+        <p:txBody>
+          <a:bodyPr wrap="none">
+            <a:spAutoFit/>
+          </a:bodyPr>
+          <a:lstStyle/>
+          <a:p>
+            <a:r>
+              <a:rPr sz="1400" b="1">
+                <a:solidFill>
+                  <a:srgbClr val="333333"/>
+                </a:solidFill>
+              </a:rPr>
+              <a:t>V</a:t>
+            </a:r>
+          </a:p>
+        </p:txBody>
+      </p:sp>
+      <p:sp>
+        <p:nvSpPr>
+          <p:cNvPr id="30" name="TextBox 29"/>
+          <p:cNvSpPr txBox="1"/>
+          <p:nvPr/>
+        </p:nvSpPr>
+        <p:spPr>
+          <a:xfrm>
+            <a:off x="8046720" y="3611879"/>
+            <a:ext cx="274320" cy="320040"/>
+          </a:xfrm>
+          <a:prstGeom prst="rect">
+            <a:avLst/>
+          </a:prstGeom>
+          <a:noFill/>
+        </p:spPr>
+        <p:txBody>
+          <a:bodyPr wrap="none">
+            <a:spAutoFit/>
+          </a:bodyPr>
+          <a:lstStyle/>
+          <a:p>
+            <a:r>
+              <a:rPr sz="1400" b="1">
+                <a:solidFill>
+                  <a:srgbClr val="333333"/>
+                </a:solidFill>
+              </a:rPr>
+              <a:t>E</a:t>
+            </a:r>
+          </a:p>
+        </p:txBody>
+      </p:sp>
+      <p:sp>
+        <p:nvSpPr>
+          <p:cNvPr id="31" name="TextBox 30"/>
+          <p:cNvSpPr txBox="1"/>
+          <p:nvPr/>
+        </p:nvSpPr>
+        <p:spPr>
+          <a:xfrm>
+            <a:off x="8503920" y="2560320"/>
+            <a:ext cx="274320" cy="320040"/>
+          </a:xfrm>
+          <a:prstGeom prst="rect">
+            <a:avLst/>
+          </a:prstGeom>
+          <a:noFill/>
+        </p:spPr>
+        <p:txBody>
+          <a:bodyPr wrap="none">
+            <a:spAutoFit/>
+          </a:bodyPr>
+          <a:lstStyle/>
+          <a:p>
+            <a:r>
+              <a:rPr sz="1400" b="1">
+                <a:solidFill>
+                  <a:srgbClr val="333333"/>
+                </a:solidFill>
+              </a:rPr>
+              <a:t>R</a:t>
+            </a:r>
+          </a:p>
+        </p:txBody>
+      </p:sp>
+      <p:sp>
+        <p:nvSpPr>
+          <p:cNvPr id="32" name="TextBox 31"/>
+          <p:cNvSpPr txBox="1"/>
+          <p:nvPr/>
+        </p:nvSpPr>
+        <p:spPr>
+          <a:xfrm>
+            <a:off x="8503920" y="2880360"/>
+            <a:ext cx="274320" cy="320040"/>
+          </a:xfrm>
+          <a:prstGeom prst="rect">
+            <a:avLst/>
+          </a:prstGeom>
+          <a:noFill/>
+        </p:spPr>
+        <p:txBody>
+          <a:bodyPr wrap="none">
+            <a:spAutoFit/>
+          </a:bodyPr>
+          <a:lstStyle/>
+          <a:p>
+            <a:r>
+              <a:rPr sz="1400" b="1">
+                <a:solidFill>
+                  <a:srgbClr val="333333"/>
+                </a:solidFill>
+              </a:rPr>
+              <a:t>E</a:t>
+            </a:r>
+          </a:p>
+        </p:txBody>
+      </p:sp>
+      <p:sp>
+        <p:nvSpPr>
+          <p:cNvPr id="33" name="TextBox 32"/>
+          <p:cNvSpPr txBox="1"/>
+          <p:nvPr/>
+        </p:nvSpPr>
+        <p:spPr>
+          <a:xfrm>
+            <a:off x="8503920" y="3200400"/>
+            <a:ext cx="274320" cy="320040"/>
+          </a:xfrm>
+          <a:prstGeom prst="rect">
+            <a:avLst/>
+          </a:prstGeom>
+          <a:noFill/>
+        </p:spPr>
+        <p:txBody>
+          <a:bodyPr wrap="none">
+            <a:spAutoFit/>
+          </a:bodyPr>
+          <a:lstStyle/>
+          <a:p>
+            <a:r>
+              <a:rPr sz="1400" b="1">
+                <a:solidFill>
+                  <a:srgbClr val="333333"/>
+                </a:solidFill>
+              </a:rPr>
+              <a:t>S</a:t>
+            </a:r>
+          </a:p>
+        </p:txBody>
+      </p:sp>
+      <p:sp>
+        <p:nvSpPr>
+          <p:cNvPr id="34" name="TextBox 33"/>
+          <p:cNvSpPr txBox="1"/>
+          <p:nvPr/>
+        </p:nvSpPr>
+        <p:spPr>
+          <a:xfrm>
+            <a:off x="8503920" y="3520439"/>
+            <a:ext cx="274320" cy="320040"/>
+          </a:xfrm>
+          <a:prstGeom prst="rect">
+            <a:avLst/>
+          </a:prstGeom>
+          <a:noFill/>
+        </p:spPr>
+        <p:txBody>
+          <a:bodyPr wrap="none">
+            <a:spAutoFit/>
+          </a:bodyPr>
+          <a:lstStyle/>
+          <a:p>
+            <a:r>
+              <a:rPr sz="1400" b="1">
+                <a:solidFill>
+                  <a:srgbClr val="333333"/>
+                </a:solidFill>
+              </a:rPr>
+              <a:t>U</a:t>
+            </a:r>
+          </a:p>
+        </p:txBody>
+      </p:sp>
+      <p:sp>
+        <p:nvSpPr>
+          <p:cNvPr id="35" name="TextBox 34"/>
+          <p:cNvSpPr txBox="1"/>
+          <p:nvPr/>
+        </p:nvSpPr>
+        <p:spPr>
+          <a:xfrm>
+            <a:off x="8503920" y="3840479"/>
+            <a:ext cx="274320" cy="320040"/>
+          </a:xfrm>
+          <a:prstGeom prst="rect">
+            <a:avLst/>
+          </a:prstGeom>
+          <a:noFill/>
+        </p:spPr>
+        <p:txBody>
+          <a:bodyPr wrap="none">
+            <a:spAutoFit/>
+          </a:bodyPr>
+          <a:lstStyle/>
+          <a:p>
+            <a:r>
+              <a:rPr sz="1400" b="1">
+                <a:solidFill>
+                  <a:srgbClr val="333333"/>
+                </a:solidFill>
+              </a:rPr>
+              <a:t>L</a:t>
+            </a:r>
+          </a:p>
+        </p:txBody>
+      </p:sp>
+      <p:sp>
+        <p:nvSpPr>
+          <p:cNvPr id="36" name="TextBox 35"/>
+          <p:cNvSpPr txBox="1"/>
+          <p:nvPr/>
+        </p:nvSpPr>
+        <p:spPr>
+          <a:xfrm>
+            <a:off x="8503920" y="4160520"/>
+            <a:ext cx="274320" cy="320040"/>
+          </a:xfrm>
+          <a:prstGeom prst="rect">
+            <a:avLst/>
+          </a:prstGeom>
+          <a:noFill/>
+        </p:spPr>
+        <p:txBody>
+          <a:bodyPr wrap="none">
+            <a:spAutoFit/>
+          </a:bodyPr>
+          <a:lstStyle/>
+          <a:p>
+            <a:r>
+              <a:rPr sz="1400" b="1">
+                <a:solidFill>
+                  <a:srgbClr val="333333"/>
+                </a:solidFill>
+              </a:rPr>
+              <a:t>T</a:t>
+            </a:r>
+          </a:p>
+        </p:txBody>
+      </p:sp>
+      <p:sp>
+        <p:nvSpPr>
+          <p:cNvPr id="37" name="TextBox 36"/>
+          <p:cNvSpPr txBox="1"/>
+          <p:nvPr/>
+        </p:nvSpPr>
+        <p:spPr>
+          <a:xfrm>
+            <a:off x="8503920" y="4480559"/>
+            <a:ext cx="274320" cy="320040"/>
+          </a:xfrm>
+          <a:prstGeom prst="rect">
+            <a:avLst/>
+          </a:prstGeom>
+          <a:noFill/>
+        </p:spPr>
+        <p:txBody>
+          <a:bodyPr wrap="none">
+            <a:spAutoFit/>
+          </a:bodyPr>
+          <a:lstStyle/>
+          <a:p>
+            <a:r>
+              <a:rPr sz="1400" b="1">
+                <a:solidFill>
+                  <a:srgbClr val="333333"/>
+                </a:solidFill>
+              </a:rPr>
+              <a:t>S</a:t>
+            </a:r>
+          </a:p>
+        </p:txBody>
+      </p:sp>
+      <p:sp>
+        <p:nvSpPr>
+          <p:cNvPr id="38" name="TextBox 37"/>
+          <p:cNvSpPr txBox="1"/>
+          <p:nvPr/>
+        </p:nvSpPr>
+        <p:spPr>
+          <a:xfrm>
+            <a:off x="8961120" y="1371600"/>
+            <a:ext cx="3017520" cy="3657600"/>
+          </a:xfrm>
+          <a:prstGeom prst="rect">
+            <a:avLst/>
+          </a:prstGeom>
+          <a:noFill/>
+        </p:spPr>
+        <p:txBody>
           <a:bodyPr wrap="square">
             <a:spAutoFit/>
           </a:bodyPr>
           <a:lstStyle/>
           <a:p>
             <a:r>
-              <a:rPr sz="1100"/>
-              <a:t>- Audio event recall: 97.4% (155 events)</a:t>
-            </a:r>
-          </a:p>
-          <a:p>
-            <a:r>
-              <a:rPr sz="1100"/>
-              <a:t>- Image recall: 96.2% (266 independent images)</a:t>
-            </a:r>
-          </a:p>
-          <a:p>
-            <a:r>
-              <a:rPr sz="1100"/>
-              <a:t>- Audio specificity: 100% (2063 negatives)</a:t>
-            </a:r>
-          </a:p>
-          <a:p>
-            <a:r>
-              <a:rPr sz="1100"/>
-              <a:t>- End-to-end trigger latency: ~10.5s</a:t>
-            </a:r>
-          </a:p>
-          <a:p>
-            <a:r>
-              <a:rPr sz="1100"/>
-              <a:t>- GEMM core speedup: 4.64x (0.59x end-to-end)</a:t>
-            </a:r>
-          </a:p>
-          <a:p>
-            <a:r>
-              <a:rPr sz="1100"/>
-              <a:t>- Audio overlay LUT: only 3.15%</a:t>
-            </a:r>
-          </a:p>
-          <a:p>
-            <a:r>
-              <a:rPr sz="1100"/>
-              <a:t>- Recording: 37.4s / 187 frames H.264</a:t>
+              <a:rPr sz="1050" b="1"/>
+              <a:t>Performance</a:t>
+            </a:r>
+          </a:p>
+          <a:p>
+            <a:r>
+              <a:rPr sz="1050" b="0"/>
+              <a:t/>
+            </a:r>
+          </a:p>
+          <a:p>
+            <a:r>
+              <a:rPr sz="1050" b="0"/>
+              <a:t>- Audio recall: 97.4%</a:t>
+            </a:r>
+          </a:p>
+          <a:p>
+            <a:r>
+              <a:rPr sz="1050" b="0"/>
+              <a:t>  (155 human-verified events)</a:t>
+            </a:r>
+          </a:p>
+          <a:p>
+            <a:r>
+              <a:rPr sz="1050" b="0"/>
+              <a:t>- Image recall: 96.2%</a:t>
+            </a:r>
+          </a:p>
+          <a:p>
+            <a:r>
+              <a:rPr sz="1050" b="0"/>
+              <a:t>  (266 independent images)</a:t>
+            </a:r>
+          </a:p>
+          <a:p>
+            <a:r>
+              <a:rPr sz="1050" b="0"/>
+              <a:t>- Audio specificity: 100%</a:t>
+            </a:r>
+          </a:p>
+          <a:p>
+            <a:r>
+              <a:rPr sz="1050" b="0"/>
+              <a:t>  (2063 negatives, 0 FP)</a:t>
+            </a:r>
+          </a:p>
+          <a:p>
+            <a:r>
+              <a:rPr sz="1050" b="0"/>
+              <a:t>- End-to-end latency: ~10.5s</a:t>
+            </a:r>
+          </a:p>
+          <a:p>
+            <a:r>
+              <a:rPr sz="1050" b="0"/>
+              <a:t>- GEMM core speedup: 4.64x</a:t>
+            </a:r>
+          </a:p>
+          <a:p>
+            <a:r>
+              <a:rPr sz="1050" b="0"/>
+              <a:t>- Audio overlay LUT: 3.15%</a:t>
+            </a:r>
+          </a:p>
+          <a:p>
+            <a:r>
+              <a:rPr sz="1050" b="0"/>
+              <a:t>- Recording: 37.4s H.264</a:t>
             </a:r>
           </a:p>
         </p:txBody>

</xml_diff>

<commit_message>
poster fix: remove yellow hints, fill cards, single title
</commit_message>
<xml_diff>
--- a/report/pitta_poster.pptx
+++ b/report/pitta_poster.pptx
@@ -18166,6 +18166,12 @@
           <a:p>
             <a:r>
               <a:rPr sz="1100"/>
+              <a:t/>
+            </a:r>
+          </a:p>
+          <a:p>
+            <a:r>
+              <a:rPr sz="1100"/>
               <a:t>PL 侧 I2S 采集 INMP441 麦克风数据并集成 HLS GEMM 硬件加速核；PS 侧运行鸟鸣检测与 YOLOv8n 视觉检测，实现鸣声触发→视觉确认→自动录像闭环。</a:t>
             </a:r>
           </a:p>
@@ -18305,105 +18311,7 @@
               <a:defRPr/>
             </a:pPr>
             <a:r>
-              <a:rPr kumimoji="0" lang="en-US" sz="2400" b="1" i="0" u="none" strike="noStrike" kern="1200" cap="none" spc="0" normalizeH="0" baseline="0" noProof="0" dirty="0">
-                <a:ln>
-                  <a:noFill/>
-                </a:ln>
-                <a:solidFill>
-                  <a:prstClr val="black"/>
-                </a:solidFill>
-                <a:effectLst/>
-                <a:uLnTx/>
-                <a:uFillTx/>
-                <a:latin typeface="Times New Roman" panose="02020603050405020304" pitchFamily="18" charset="0"/>
-                <a:ea typeface="+mn-ea"/>
-                <a:cs typeface="Times New Roman" panose="02020603050405020304" pitchFamily="18" charset="0"/>
-                <a:sym typeface="+mn-ea"/>
-              </a:rPr>
-              <a:t>仙八色鸫鸣声与图像协同监测系统</a:t>
-            </a:r>
-            <a:r>
-              <a:rPr kumimoji="0" lang="zh-CN" altLang="en-US" sz="2400" b="1" i="0" u="none" strike="noStrike" kern="1200" cap="none" spc="0" normalizeH="0" baseline="0" noProof="0" dirty="0">
-                <a:ln>
-                  <a:noFill/>
-                </a:ln>
-                <a:solidFill>
-                  <a:prstClr val="black"/>
-                </a:solidFill>
-                <a:effectLst/>
-                <a:highlight>
-                  <a:srgbClr val="FFFF00"/>
-                </a:highlight>
-                <a:uLnTx/>
-                <a:uFillTx/>
-                <a:latin typeface="Times New Roman" panose="02020603050405020304" pitchFamily="18" charset="0"/>
-                <a:ea typeface="等线" panose="02010600030101010101" pitchFamily="2" charset="-122"/>
-                <a:cs typeface="Times New Roman" panose="02020603050405020304" pitchFamily="18" charset="0"/>
-                <a:sym typeface="+mn-ea"/>
-              </a:rPr>
-              <a:t>仙八色鸫鸣声与图像协同监测系统</a:t>
-            </a:r>
-            <a:r>
-              <a:rPr kumimoji="0" lang="en-US" altLang="zh-CN" sz="2400" b="1" i="0" u="none" strike="noStrike" kern="1200" cap="none" spc="0" normalizeH="0" baseline="0" noProof="0" dirty="0">
-                <a:ln>
-                  <a:noFill/>
-                </a:ln>
-                <a:solidFill>
-                  <a:prstClr val="black"/>
-                </a:solidFill>
-                <a:effectLst/>
-                <a:highlight>
-                  <a:srgbClr val="FFFF00"/>
-                </a:highlight>
-                <a:uLnTx/>
-                <a:uFillTx/>
-                <a:latin typeface="Times New Roman" panose="02020603050405020304" pitchFamily="18" charset="0"/>
-                <a:ea typeface="等线" panose="02010600030101010101" pitchFamily="2" charset="-122"/>
-                <a:cs typeface="Times New Roman" panose="02020603050405020304" pitchFamily="18" charset="0"/>
-                <a:sym typeface="+mn-ea"/>
-              </a:rPr>
-              <a:t>仙八色鸫鸣声与图像协同监测系统</a:t>
-            </a:r>
-            <a:r>
-              <a:rPr kumimoji="0" lang="zh-CN" altLang="en-US" sz="2400" b="1" i="0" u="none" strike="noStrike" kern="1200" cap="none" spc="0" normalizeH="0" baseline="0" noProof="0" dirty="0">
-                <a:ln>
-                  <a:noFill/>
-                </a:ln>
-                <a:solidFill>
-                  <a:prstClr val="black"/>
-                </a:solidFill>
-                <a:effectLst/>
-                <a:highlight>
-                  <a:srgbClr val="FFFF00"/>
-                </a:highlight>
-                <a:uLnTx/>
-                <a:uFillTx/>
-                <a:latin typeface="Times New Roman" panose="02020603050405020304" pitchFamily="18" charset="0"/>
-                <a:ea typeface="等线" panose="02010600030101010101" pitchFamily="2" charset="-122"/>
-                <a:cs typeface="Times New Roman" panose="02020603050405020304" pitchFamily="18" charset="0"/>
-                <a:sym typeface="+mn-ea"/>
-              </a:rPr>
-              <a:t>仙八色鸫鸣声与图像协同监测系统</a:t>
-            </a:r>
-            <a:r>
-              <a:rPr kumimoji="0" lang="en-US" altLang="zh-CN" sz="2400" b="1" i="0" u="none" strike="noStrike" kern="1200" cap="none" spc="0" normalizeH="0" baseline="0" noProof="0" dirty="0">
-                <a:ln>
-                  <a:noFill/>
-                </a:ln>
-                <a:solidFill>
-                  <a:prstClr val="black"/>
-                </a:solidFill>
-                <a:effectLst/>
-                <a:highlight>
-                  <a:srgbClr val="FFFF00"/>
-                </a:highlight>
-                <a:uLnTx/>
-                <a:uFillTx/>
-                <a:latin typeface="Times New Roman" panose="02020603050405020304" pitchFamily="18" charset="0"/>
-                <a:ea typeface="等线" panose="02010600030101010101" pitchFamily="2" charset="-122"/>
-                <a:cs typeface="Times New Roman" panose="02020603050405020304" pitchFamily="18" charset="0"/>
-                <a:sym typeface="+mn-ea"/>
-              </a:rPr>
+              <a:rPr sz="2400" b="1"/>
               <a:t>仙八色鸫鸣声与图像协同监测系统</a:t>
             </a:r>
             <a:endParaRPr kumimoji="0" lang="en-US" sz="2400" b="1" i="0" u="none" strike="noStrike" kern="1200" cap="none" spc="0" normalizeH="0" baseline="0" noProof="0" dirty="0">
@@ -18663,7 +18571,7 @@
                 <a:cs typeface="Times New Roman" panose="02020603050405020304" pitchFamily="18" charset="0"/>
                 <a:sym typeface="+mn-ea"/>
               </a:rPr>
-              <a:t>应用场景</a:t>
+              <a:t>应用场景：林地野外监测</a:t>
             </a:r>
           </a:p>
         </p:txBody>
@@ -19921,7 +19829,7 @@
               <a:defRPr/>
             </a:pPr>
             <a:r>
-              <a:rPr kumimoji="0" lang="en-US" altLang="zh-CN" sz="1100" b="1" i="1" u="none" strike="noStrike" kern="1200" cap="none" spc="0" normalizeH="0" baseline="0" noProof="0" dirty="0">
+              <a:rPr kumimoji="0" lang="en-US" altLang="zh-CN" sz="1000" b="1" i="1" u="none" strike="noStrike" kern="1200" cap="none" spc="0" normalizeH="0" baseline="0" noProof="0" dirty="0">
                 <a:ln>
                   <a:noFill/>
                 </a:ln>
@@ -19987,7 +19895,7 @@
             </a:pPr>
             <a:r>
               <a:rPr sz="1200" b="1"/>
-              <a:t>武汉大学，</a:t>
+              <a:t>武汉大学</a:t>
             </a:r>
           </a:p>
           <a:p>
@@ -21058,13 +20966,13 @@
           <a:p>
             <a:r>
               <a:rPr sz="1100"/>
-              <a:t>1. INMP441 I2S 数字 MEMS 麦克风采集；</a:t>
+              <a:t>1. INMP441 I2S 数字麦克风采集；</a:t>
             </a:r>
           </a:p>
           <a:p>
             <a:r>
               <a:rPr sz="1100"/>
-              <a:t>2. STFT/Mel 频谱 + 3 层 CNN 鸟鸣检测；</a:t>
+              <a:t>2. STFT/Mel + 3 层 CNN 鸟鸣检测；</a:t>
             </a:r>
           </a:p>
           <a:p>
@@ -21322,2067 +21230,6 @@
           </a:prstGeom>
         </p:spPr>
       </p:pic>
-      <p:sp>
-        <p:nvSpPr>
-          <p:cNvPr id="48" name="Content Placeholder 2">
-            <a:extLst>
-              <a:ext uri="{FF2B5EF4-FFF2-40B4-BE49-F238E27FC236}">
-                <a16:creationId xmlns:a16="http://schemas.microsoft.com/office/drawing/2014/main" id="{7E1E88F6-BAF0-0A44-5F1D-0F6693085835}"/>
-              </a:ext>
-            </a:extLst>
-          </p:cNvPr>
-          <p:cNvSpPr txBox="1">
-            <a:spLocks/>
-          </p:cNvSpPr>
-          <p:nvPr/>
-        </p:nvSpPr>
-        <p:spPr>
-          <a:xfrm>
-            <a:off x="1036793" y="1576933"/>
-            <a:ext cx="2221767" cy="251867"/>
-          </a:xfrm>
-          <a:prstGeom prst="rect">
-            <a:avLst/>
-          </a:prstGeom>
-        </p:spPr>
-        <p:txBody>
-          <a:bodyPr vert="horz" lIns="91440" tIns="45720" rIns="91440" bIns="45720" rtlCol="0">
-            <a:noAutofit/>
-          </a:bodyPr>
-          <a:lstStyle>
-            <a:lvl1pPr marL="228600" indent="-228600" algn="l" defTabSz="914400" rtl="0" eaLnBrk="1" latinLnBrk="0" hangingPunct="1">
-              <a:lnSpc>
-                <a:spcPct val="90000"/>
-              </a:lnSpc>
-              <a:spcBef>
-                <a:spcPts val="1000"/>
-              </a:spcBef>
-              <a:buFont typeface="Arial" panose="020B0604020202020204" pitchFamily="34" charset="0"/>
-              <a:buChar char="•"/>
-              <a:defRPr sz="2800" kern="1200">
-                <a:solidFill>
-                  <a:schemeClr val="tx1"/>
-                </a:solidFill>
-                <a:latin typeface="+mn-lt"/>
-                <a:ea typeface="+mn-ea"/>
-                <a:cs typeface="+mn-cs"/>
-              </a:defRPr>
-            </a:lvl1pPr>
-            <a:lvl2pPr marL="685800" indent="-228600" algn="l" defTabSz="914400" rtl="0" eaLnBrk="1" latinLnBrk="0" hangingPunct="1">
-              <a:lnSpc>
-                <a:spcPct val="90000"/>
-              </a:lnSpc>
-              <a:spcBef>
-                <a:spcPts val="500"/>
-              </a:spcBef>
-              <a:buFont typeface="Arial" panose="020B0604020202020204" pitchFamily="34" charset="0"/>
-              <a:buChar char="•"/>
-              <a:defRPr sz="2400" kern="1200">
-                <a:solidFill>
-                  <a:schemeClr val="tx1"/>
-                </a:solidFill>
-                <a:latin typeface="+mn-lt"/>
-                <a:ea typeface="+mn-ea"/>
-                <a:cs typeface="+mn-cs"/>
-              </a:defRPr>
-            </a:lvl2pPr>
-            <a:lvl3pPr marL="1143000" indent="-228600" algn="l" defTabSz="914400" rtl="0" eaLnBrk="1" latinLnBrk="0" hangingPunct="1">
-              <a:lnSpc>
-                <a:spcPct val="90000"/>
-              </a:lnSpc>
-              <a:spcBef>
-                <a:spcPts val="500"/>
-              </a:spcBef>
-              <a:buFont typeface="Arial" panose="020B0604020202020204" pitchFamily="34" charset="0"/>
-              <a:buChar char="•"/>
-              <a:defRPr sz="2000" kern="1200">
-                <a:solidFill>
-                  <a:schemeClr val="tx1"/>
-                </a:solidFill>
-                <a:latin typeface="+mn-lt"/>
-                <a:ea typeface="+mn-ea"/>
-                <a:cs typeface="+mn-cs"/>
-              </a:defRPr>
-            </a:lvl3pPr>
-            <a:lvl4pPr marL="1600200" indent="-228600" algn="l" defTabSz="914400" rtl="0" eaLnBrk="1" latinLnBrk="0" hangingPunct="1">
-              <a:lnSpc>
-                <a:spcPct val="90000"/>
-              </a:lnSpc>
-              <a:spcBef>
-                <a:spcPts val="500"/>
-              </a:spcBef>
-              <a:buFont typeface="Arial" panose="020B0604020202020204" pitchFamily="34" charset="0"/>
-              <a:buChar char="•"/>
-              <a:defRPr sz="1800" kern="1200">
-                <a:solidFill>
-                  <a:schemeClr val="tx1"/>
-                </a:solidFill>
-                <a:latin typeface="+mn-lt"/>
-                <a:ea typeface="+mn-ea"/>
-                <a:cs typeface="+mn-cs"/>
-              </a:defRPr>
-            </a:lvl4pPr>
-            <a:lvl5pPr marL="2057400" indent="-228600" algn="l" defTabSz="914400" rtl="0" eaLnBrk="1" latinLnBrk="0" hangingPunct="1">
-              <a:lnSpc>
-                <a:spcPct val="90000"/>
-              </a:lnSpc>
-              <a:spcBef>
-                <a:spcPts val="500"/>
-              </a:spcBef>
-              <a:buFont typeface="Arial" panose="020B0604020202020204" pitchFamily="34" charset="0"/>
-              <a:buChar char="•"/>
-              <a:defRPr sz="1800" kern="1200">
-                <a:solidFill>
-                  <a:schemeClr val="tx1"/>
-                </a:solidFill>
-                <a:latin typeface="+mn-lt"/>
-                <a:ea typeface="+mn-ea"/>
-                <a:cs typeface="+mn-cs"/>
-              </a:defRPr>
-            </a:lvl5pPr>
-            <a:lvl6pPr marL="2514600" indent="-228600" algn="l" defTabSz="914400" rtl="0" eaLnBrk="1" latinLnBrk="0" hangingPunct="1">
-              <a:lnSpc>
-                <a:spcPct val="90000"/>
-              </a:lnSpc>
-              <a:spcBef>
-                <a:spcPts val="500"/>
-              </a:spcBef>
-              <a:buFont typeface="Arial" panose="020B0604020202020204" pitchFamily="34" charset="0"/>
-              <a:buChar char="•"/>
-              <a:defRPr sz="1800" kern="1200">
-                <a:solidFill>
-                  <a:schemeClr val="tx1"/>
-                </a:solidFill>
-                <a:latin typeface="+mn-lt"/>
-                <a:ea typeface="+mn-ea"/>
-                <a:cs typeface="+mn-cs"/>
-              </a:defRPr>
-            </a:lvl6pPr>
-            <a:lvl7pPr marL="2971800" indent="-228600" algn="l" defTabSz="914400" rtl="0" eaLnBrk="1" latinLnBrk="0" hangingPunct="1">
-              <a:lnSpc>
-                <a:spcPct val="90000"/>
-              </a:lnSpc>
-              <a:spcBef>
-                <a:spcPts val="500"/>
-              </a:spcBef>
-              <a:buFont typeface="Arial" panose="020B0604020202020204" pitchFamily="34" charset="0"/>
-              <a:buChar char="•"/>
-              <a:defRPr sz="1800" kern="1200">
-                <a:solidFill>
-                  <a:schemeClr val="tx1"/>
-                </a:solidFill>
-                <a:latin typeface="+mn-lt"/>
-                <a:ea typeface="+mn-ea"/>
-                <a:cs typeface="+mn-cs"/>
-              </a:defRPr>
-            </a:lvl7pPr>
-            <a:lvl8pPr marL="3429000" indent="-228600" algn="l" defTabSz="914400" rtl="0" eaLnBrk="1" latinLnBrk="0" hangingPunct="1">
-              <a:lnSpc>
-                <a:spcPct val="90000"/>
-              </a:lnSpc>
-              <a:spcBef>
-                <a:spcPts val="500"/>
-              </a:spcBef>
-              <a:buFont typeface="Arial" panose="020B0604020202020204" pitchFamily="34" charset="0"/>
-              <a:buChar char="•"/>
-              <a:defRPr sz="1800" kern="1200">
-                <a:solidFill>
-                  <a:schemeClr val="tx1"/>
-                </a:solidFill>
-                <a:latin typeface="+mn-lt"/>
-                <a:ea typeface="+mn-ea"/>
-                <a:cs typeface="+mn-cs"/>
-              </a:defRPr>
-            </a:lvl8pPr>
-            <a:lvl9pPr marL="3886200" indent="-228600" algn="l" defTabSz="914400" rtl="0" eaLnBrk="1" latinLnBrk="0" hangingPunct="1">
-              <a:lnSpc>
-                <a:spcPct val="90000"/>
-              </a:lnSpc>
-              <a:spcBef>
-                <a:spcPts val="500"/>
-              </a:spcBef>
-              <a:buFont typeface="Arial" panose="020B0604020202020204" pitchFamily="34" charset="0"/>
-              <a:buChar char="•"/>
-              <a:defRPr sz="1800" kern="1200">
-                <a:solidFill>
-                  <a:schemeClr val="tx1"/>
-                </a:solidFill>
-                <a:latin typeface="+mn-lt"/>
-                <a:ea typeface="+mn-ea"/>
-                <a:cs typeface="+mn-cs"/>
-              </a:defRPr>
-            </a:lvl9pPr>
-          </a:lstStyle>
-          <a:p>
-            <a:pPr marL="0" marR="0" lvl="0" indent="0" algn="l" defTabSz="914400" rtl="0" eaLnBrk="1" fontAlgn="auto" latinLnBrk="0" hangingPunct="1">
-              <a:lnSpc>
-                <a:spcPct val="100000"/>
-              </a:lnSpc>
-              <a:spcBef>
-                <a:spcPts val="1000"/>
-              </a:spcBef>
-              <a:spcAft>
-                <a:spcPts val="0"/>
-              </a:spcAft>
-              <a:buClrTx/>
-              <a:buSzTx/>
-              <a:buFont typeface="Arial" panose="020B0604020202020204" pitchFamily="34" charset="0"/>
-              <a:buNone/>
-              <a:tabLst/>
-              <a:defRPr/>
-            </a:pPr>
-            <a:endParaRPr kumimoji="0" lang="en-US" sz="1100" b="0" i="0" u="none" strike="noStrike" kern="1200" cap="none" spc="0" normalizeH="0" baseline="0" noProof="0" dirty="0">
-              <a:ln>
-                <a:noFill/>
-              </a:ln>
-              <a:solidFill>
-                <a:prstClr val="black"/>
-              </a:solidFill>
-              <a:effectLst/>
-              <a:highlight>
-                <a:srgbClr val="FFFF00"/>
-              </a:highlight>
-              <a:uLnTx/>
-              <a:uFillTx/>
-              <a:latin typeface="Calibri" panose="020F0502020204030204"/>
-              <a:ea typeface="+mn-ea"/>
-              <a:cs typeface="+mn-cs"/>
-            </a:endParaRPr>
-          </a:p>
-        </p:txBody>
-      </p:sp>
-      <p:sp>
-        <p:nvSpPr>
-          <p:cNvPr id="49" name="Content Placeholder 2">
-            <a:extLst>
-              <a:ext uri="{FF2B5EF4-FFF2-40B4-BE49-F238E27FC236}">
-                <a16:creationId xmlns:a16="http://schemas.microsoft.com/office/drawing/2014/main" id="{1993D883-5FD0-5FA9-2211-42E39F416E95}"/>
-              </a:ext>
-            </a:extLst>
-          </p:cNvPr>
-          <p:cNvSpPr txBox="1">
-            <a:spLocks/>
-          </p:cNvSpPr>
-          <p:nvPr/>
-        </p:nvSpPr>
-        <p:spPr>
-          <a:xfrm>
-            <a:off x="7037169" y="-1643"/>
-            <a:ext cx="3436277" cy="251867"/>
-          </a:xfrm>
-          <a:prstGeom prst="rect">
-            <a:avLst/>
-          </a:prstGeom>
-        </p:spPr>
-        <p:txBody>
-          <a:bodyPr vert="horz" lIns="91440" tIns="45720" rIns="91440" bIns="45720" rtlCol="0">
-            <a:noAutofit/>
-          </a:bodyPr>
-          <a:lstStyle>
-            <a:lvl1pPr marL="228600" indent="-228600" algn="l" defTabSz="914400" rtl="0" eaLnBrk="1" latinLnBrk="0" hangingPunct="1">
-              <a:lnSpc>
-                <a:spcPct val="90000"/>
-              </a:lnSpc>
-              <a:spcBef>
-                <a:spcPts val="1000"/>
-              </a:spcBef>
-              <a:buFont typeface="Arial" panose="020B0604020202020204" pitchFamily="34" charset="0"/>
-              <a:buChar char="•"/>
-              <a:defRPr sz="2800" kern="1200">
-                <a:solidFill>
-                  <a:schemeClr val="tx1"/>
-                </a:solidFill>
-                <a:latin typeface="+mn-lt"/>
-                <a:ea typeface="+mn-ea"/>
-                <a:cs typeface="+mn-cs"/>
-              </a:defRPr>
-            </a:lvl1pPr>
-            <a:lvl2pPr marL="685800" indent="-228600" algn="l" defTabSz="914400" rtl="0" eaLnBrk="1" latinLnBrk="0" hangingPunct="1">
-              <a:lnSpc>
-                <a:spcPct val="90000"/>
-              </a:lnSpc>
-              <a:spcBef>
-                <a:spcPts val="500"/>
-              </a:spcBef>
-              <a:buFont typeface="Arial" panose="020B0604020202020204" pitchFamily="34" charset="0"/>
-              <a:buChar char="•"/>
-              <a:defRPr sz="2400" kern="1200">
-                <a:solidFill>
-                  <a:schemeClr val="tx1"/>
-                </a:solidFill>
-                <a:latin typeface="+mn-lt"/>
-                <a:ea typeface="+mn-ea"/>
-                <a:cs typeface="+mn-cs"/>
-              </a:defRPr>
-            </a:lvl2pPr>
-            <a:lvl3pPr marL="1143000" indent="-228600" algn="l" defTabSz="914400" rtl="0" eaLnBrk="1" latinLnBrk="0" hangingPunct="1">
-              <a:lnSpc>
-                <a:spcPct val="90000"/>
-              </a:lnSpc>
-              <a:spcBef>
-                <a:spcPts val="500"/>
-              </a:spcBef>
-              <a:buFont typeface="Arial" panose="020B0604020202020204" pitchFamily="34" charset="0"/>
-              <a:buChar char="•"/>
-              <a:defRPr sz="2000" kern="1200">
-                <a:solidFill>
-                  <a:schemeClr val="tx1"/>
-                </a:solidFill>
-                <a:latin typeface="+mn-lt"/>
-                <a:ea typeface="+mn-ea"/>
-                <a:cs typeface="+mn-cs"/>
-              </a:defRPr>
-            </a:lvl3pPr>
-            <a:lvl4pPr marL="1600200" indent="-228600" algn="l" defTabSz="914400" rtl="0" eaLnBrk="1" latinLnBrk="0" hangingPunct="1">
-              <a:lnSpc>
-                <a:spcPct val="90000"/>
-              </a:lnSpc>
-              <a:spcBef>
-                <a:spcPts val="500"/>
-              </a:spcBef>
-              <a:buFont typeface="Arial" panose="020B0604020202020204" pitchFamily="34" charset="0"/>
-              <a:buChar char="•"/>
-              <a:defRPr sz="1800" kern="1200">
-                <a:solidFill>
-                  <a:schemeClr val="tx1"/>
-                </a:solidFill>
-                <a:latin typeface="+mn-lt"/>
-                <a:ea typeface="+mn-ea"/>
-                <a:cs typeface="+mn-cs"/>
-              </a:defRPr>
-            </a:lvl4pPr>
-            <a:lvl5pPr marL="2057400" indent="-228600" algn="l" defTabSz="914400" rtl="0" eaLnBrk="1" latinLnBrk="0" hangingPunct="1">
-              <a:lnSpc>
-                <a:spcPct val="90000"/>
-              </a:lnSpc>
-              <a:spcBef>
-                <a:spcPts val="500"/>
-              </a:spcBef>
-              <a:buFont typeface="Arial" panose="020B0604020202020204" pitchFamily="34" charset="0"/>
-              <a:buChar char="•"/>
-              <a:defRPr sz="1800" kern="1200">
-                <a:solidFill>
-                  <a:schemeClr val="tx1"/>
-                </a:solidFill>
-                <a:latin typeface="+mn-lt"/>
-                <a:ea typeface="+mn-ea"/>
-                <a:cs typeface="+mn-cs"/>
-              </a:defRPr>
-            </a:lvl5pPr>
-            <a:lvl6pPr marL="2514600" indent="-228600" algn="l" defTabSz="914400" rtl="0" eaLnBrk="1" latinLnBrk="0" hangingPunct="1">
-              <a:lnSpc>
-                <a:spcPct val="90000"/>
-              </a:lnSpc>
-              <a:spcBef>
-                <a:spcPts val="500"/>
-              </a:spcBef>
-              <a:buFont typeface="Arial" panose="020B0604020202020204" pitchFamily="34" charset="0"/>
-              <a:buChar char="•"/>
-              <a:defRPr sz="1800" kern="1200">
-                <a:solidFill>
-                  <a:schemeClr val="tx1"/>
-                </a:solidFill>
-                <a:latin typeface="+mn-lt"/>
-                <a:ea typeface="+mn-ea"/>
-                <a:cs typeface="+mn-cs"/>
-              </a:defRPr>
-            </a:lvl6pPr>
-            <a:lvl7pPr marL="2971800" indent="-228600" algn="l" defTabSz="914400" rtl="0" eaLnBrk="1" latinLnBrk="0" hangingPunct="1">
-              <a:lnSpc>
-                <a:spcPct val="90000"/>
-              </a:lnSpc>
-              <a:spcBef>
-                <a:spcPts val="500"/>
-              </a:spcBef>
-              <a:buFont typeface="Arial" panose="020B0604020202020204" pitchFamily="34" charset="0"/>
-              <a:buChar char="•"/>
-              <a:defRPr sz="1800" kern="1200">
-                <a:solidFill>
-                  <a:schemeClr val="tx1"/>
-                </a:solidFill>
-                <a:latin typeface="+mn-lt"/>
-                <a:ea typeface="+mn-ea"/>
-                <a:cs typeface="+mn-cs"/>
-              </a:defRPr>
-            </a:lvl7pPr>
-            <a:lvl8pPr marL="3429000" indent="-228600" algn="l" defTabSz="914400" rtl="0" eaLnBrk="1" latinLnBrk="0" hangingPunct="1">
-              <a:lnSpc>
-                <a:spcPct val="90000"/>
-              </a:lnSpc>
-              <a:spcBef>
-                <a:spcPts val="500"/>
-              </a:spcBef>
-              <a:buFont typeface="Arial" panose="020B0604020202020204" pitchFamily="34" charset="0"/>
-              <a:buChar char="•"/>
-              <a:defRPr sz="1800" kern="1200">
-                <a:solidFill>
-                  <a:schemeClr val="tx1"/>
-                </a:solidFill>
-                <a:latin typeface="+mn-lt"/>
-                <a:ea typeface="+mn-ea"/>
-                <a:cs typeface="+mn-cs"/>
-              </a:defRPr>
-            </a:lvl8pPr>
-            <a:lvl9pPr marL="3886200" indent="-228600" algn="l" defTabSz="914400" rtl="0" eaLnBrk="1" latinLnBrk="0" hangingPunct="1">
-              <a:lnSpc>
-                <a:spcPct val="90000"/>
-              </a:lnSpc>
-              <a:spcBef>
-                <a:spcPts val="500"/>
-              </a:spcBef>
-              <a:buFont typeface="Arial" panose="020B0604020202020204" pitchFamily="34" charset="0"/>
-              <a:buChar char="•"/>
-              <a:defRPr sz="1800" kern="1200">
-                <a:solidFill>
-                  <a:schemeClr val="tx1"/>
-                </a:solidFill>
-                <a:latin typeface="+mn-lt"/>
-                <a:ea typeface="+mn-ea"/>
-                <a:cs typeface="+mn-cs"/>
-              </a:defRPr>
-            </a:lvl9pPr>
-          </a:lstStyle>
-          <a:p>
-            <a:pPr marL="0" marR="0" lvl="0" indent="0" algn="l" defTabSz="914400" rtl="0" eaLnBrk="1" fontAlgn="auto" latinLnBrk="0" hangingPunct="1">
-              <a:lnSpc>
-                <a:spcPct val="100000"/>
-              </a:lnSpc>
-              <a:spcBef>
-                <a:spcPts val="1000"/>
-              </a:spcBef>
-              <a:spcAft>
-                <a:spcPts val="0"/>
-              </a:spcAft>
-              <a:buClrTx/>
-              <a:buSzTx/>
-              <a:buFont typeface="Arial" panose="020B0604020202020204" pitchFamily="34" charset="0"/>
-              <a:buNone/>
-              <a:tabLst/>
-              <a:defRPr/>
-            </a:pPr>
-            <a:endParaRPr kumimoji="0" lang="en-US" sz="1100" b="0" i="0" u="none" strike="noStrike" kern="1200" cap="none" spc="0" normalizeH="0" baseline="0" noProof="0" dirty="0">
-              <a:ln>
-                <a:noFill/>
-              </a:ln>
-              <a:solidFill>
-                <a:prstClr val="black"/>
-              </a:solidFill>
-              <a:effectLst/>
-              <a:highlight>
-                <a:srgbClr val="FFFF00"/>
-              </a:highlight>
-              <a:uLnTx/>
-              <a:uFillTx/>
-              <a:latin typeface="Calibri" panose="020F0502020204030204"/>
-              <a:ea typeface="+mn-ea"/>
-              <a:cs typeface="+mn-cs"/>
-            </a:endParaRPr>
-          </a:p>
-        </p:txBody>
-      </p:sp>
-      <p:sp>
-        <p:nvSpPr>
-          <p:cNvPr id="50" name="Content Placeholder 2">
-            <a:extLst>
-              <a:ext uri="{FF2B5EF4-FFF2-40B4-BE49-F238E27FC236}">
-                <a16:creationId xmlns:a16="http://schemas.microsoft.com/office/drawing/2014/main" id="{897393DB-7396-E381-825C-5E441FE5FB47}"/>
-              </a:ext>
-            </a:extLst>
-          </p:cNvPr>
-          <p:cNvSpPr txBox="1">
-            <a:spLocks/>
-          </p:cNvSpPr>
-          <p:nvPr/>
-        </p:nvSpPr>
-        <p:spPr>
-          <a:xfrm>
-            <a:off x="10360536" y="1393972"/>
-            <a:ext cx="1313365" cy="251867"/>
-          </a:xfrm>
-          <a:prstGeom prst="rect">
-            <a:avLst/>
-          </a:prstGeom>
-        </p:spPr>
-        <p:txBody>
-          <a:bodyPr vert="horz" lIns="91440" tIns="45720" rIns="91440" bIns="45720" rtlCol="0">
-            <a:noAutofit/>
-          </a:bodyPr>
-          <a:lstStyle>
-            <a:lvl1pPr marL="228600" indent="-228600" algn="l" defTabSz="914400" rtl="0" eaLnBrk="1" latinLnBrk="0" hangingPunct="1">
-              <a:lnSpc>
-                <a:spcPct val="90000"/>
-              </a:lnSpc>
-              <a:spcBef>
-                <a:spcPts val="1000"/>
-              </a:spcBef>
-              <a:buFont typeface="Arial" panose="020B0604020202020204" pitchFamily="34" charset="0"/>
-              <a:buChar char="•"/>
-              <a:defRPr sz="2800" kern="1200">
-                <a:solidFill>
-                  <a:schemeClr val="tx1"/>
-                </a:solidFill>
-                <a:latin typeface="+mn-lt"/>
-                <a:ea typeface="+mn-ea"/>
-                <a:cs typeface="+mn-cs"/>
-              </a:defRPr>
-            </a:lvl1pPr>
-            <a:lvl2pPr marL="685800" indent="-228600" algn="l" defTabSz="914400" rtl="0" eaLnBrk="1" latinLnBrk="0" hangingPunct="1">
-              <a:lnSpc>
-                <a:spcPct val="90000"/>
-              </a:lnSpc>
-              <a:spcBef>
-                <a:spcPts val="500"/>
-              </a:spcBef>
-              <a:buFont typeface="Arial" panose="020B0604020202020204" pitchFamily="34" charset="0"/>
-              <a:buChar char="•"/>
-              <a:defRPr sz="2400" kern="1200">
-                <a:solidFill>
-                  <a:schemeClr val="tx1"/>
-                </a:solidFill>
-                <a:latin typeface="+mn-lt"/>
-                <a:ea typeface="+mn-ea"/>
-                <a:cs typeface="+mn-cs"/>
-              </a:defRPr>
-            </a:lvl2pPr>
-            <a:lvl3pPr marL="1143000" indent="-228600" algn="l" defTabSz="914400" rtl="0" eaLnBrk="1" latinLnBrk="0" hangingPunct="1">
-              <a:lnSpc>
-                <a:spcPct val="90000"/>
-              </a:lnSpc>
-              <a:spcBef>
-                <a:spcPts val="500"/>
-              </a:spcBef>
-              <a:buFont typeface="Arial" panose="020B0604020202020204" pitchFamily="34" charset="0"/>
-              <a:buChar char="•"/>
-              <a:defRPr sz="2000" kern="1200">
-                <a:solidFill>
-                  <a:schemeClr val="tx1"/>
-                </a:solidFill>
-                <a:latin typeface="+mn-lt"/>
-                <a:ea typeface="+mn-ea"/>
-                <a:cs typeface="+mn-cs"/>
-              </a:defRPr>
-            </a:lvl3pPr>
-            <a:lvl4pPr marL="1600200" indent="-228600" algn="l" defTabSz="914400" rtl="0" eaLnBrk="1" latinLnBrk="0" hangingPunct="1">
-              <a:lnSpc>
-                <a:spcPct val="90000"/>
-              </a:lnSpc>
-              <a:spcBef>
-                <a:spcPts val="500"/>
-              </a:spcBef>
-              <a:buFont typeface="Arial" panose="020B0604020202020204" pitchFamily="34" charset="0"/>
-              <a:buChar char="•"/>
-              <a:defRPr sz="1800" kern="1200">
-                <a:solidFill>
-                  <a:schemeClr val="tx1"/>
-                </a:solidFill>
-                <a:latin typeface="+mn-lt"/>
-                <a:ea typeface="+mn-ea"/>
-                <a:cs typeface="+mn-cs"/>
-              </a:defRPr>
-            </a:lvl4pPr>
-            <a:lvl5pPr marL="2057400" indent="-228600" algn="l" defTabSz="914400" rtl="0" eaLnBrk="1" latinLnBrk="0" hangingPunct="1">
-              <a:lnSpc>
-                <a:spcPct val="90000"/>
-              </a:lnSpc>
-              <a:spcBef>
-                <a:spcPts val="500"/>
-              </a:spcBef>
-              <a:buFont typeface="Arial" panose="020B0604020202020204" pitchFamily="34" charset="0"/>
-              <a:buChar char="•"/>
-              <a:defRPr sz="1800" kern="1200">
-                <a:solidFill>
-                  <a:schemeClr val="tx1"/>
-                </a:solidFill>
-                <a:latin typeface="+mn-lt"/>
-                <a:ea typeface="+mn-ea"/>
-                <a:cs typeface="+mn-cs"/>
-              </a:defRPr>
-            </a:lvl5pPr>
-            <a:lvl6pPr marL="2514600" indent="-228600" algn="l" defTabSz="914400" rtl="0" eaLnBrk="1" latinLnBrk="0" hangingPunct="1">
-              <a:lnSpc>
-                <a:spcPct val="90000"/>
-              </a:lnSpc>
-              <a:spcBef>
-                <a:spcPts val="500"/>
-              </a:spcBef>
-              <a:buFont typeface="Arial" panose="020B0604020202020204" pitchFamily="34" charset="0"/>
-              <a:buChar char="•"/>
-              <a:defRPr sz="1800" kern="1200">
-                <a:solidFill>
-                  <a:schemeClr val="tx1"/>
-                </a:solidFill>
-                <a:latin typeface="+mn-lt"/>
-                <a:ea typeface="+mn-ea"/>
-                <a:cs typeface="+mn-cs"/>
-              </a:defRPr>
-            </a:lvl6pPr>
-            <a:lvl7pPr marL="2971800" indent="-228600" algn="l" defTabSz="914400" rtl="0" eaLnBrk="1" latinLnBrk="0" hangingPunct="1">
-              <a:lnSpc>
-                <a:spcPct val="90000"/>
-              </a:lnSpc>
-              <a:spcBef>
-                <a:spcPts val="500"/>
-              </a:spcBef>
-              <a:buFont typeface="Arial" panose="020B0604020202020204" pitchFamily="34" charset="0"/>
-              <a:buChar char="•"/>
-              <a:defRPr sz="1800" kern="1200">
-                <a:solidFill>
-                  <a:schemeClr val="tx1"/>
-                </a:solidFill>
-                <a:latin typeface="+mn-lt"/>
-                <a:ea typeface="+mn-ea"/>
-                <a:cs typeface="+mn-cs"/>
-              </a:defRPr>
-            </a:lvl7pPr>
-            <a:lvl8pPr marL="3429000" indent="-228600" algn="l" defTabSz="914400" rtl="0" eaLnBrk="1" latinLnBrk="0" hangingPunct="1">
-              <a:lnSpc>
-                <a:spcPct val="90000"/>
-              </a:lnSpc>
-              <a:spcBef>
-                <a:spcPts val="500"/>
-              </a:spcBef>
-              <a:buFont typeface="Arial" panose="020B0604020202020204" pitchFamily="34" charset="0"/>
-              <a:buChar char="•"/>
-              <a:defRPr sz="1800" kern="1200">
-                <a:solidFill>
-                  <a:schemeClr val="tx1"/>
-                </a:solidFill>
-                <a:latin typeface="+mn-lt"/>
-                <a:ea typeface="+mn-ea"/>
-                <a:cs typeface="+mn-cs"/>
-              </a:defRPr>
-            </a:lvl8pPr>
-            <a:lvl9pPr marL="3886200" indent="-228600" algn="l" defTabSz="914400" rtl="0" eaLnBrk="1" latinLnBrk="0" hangingPunct="1">
-              <a:lnSpc>
-                <a:spcPct val="90000"/>
-              </a:lnSpc>
-              <a:spcBef>
-                <a:spcPts val="500"/>
-              </a:spcBef>
-              <a:buFont typeface="Arial" panose="020B0604020202020204" pitchFamily="34" charset="0"/>
-              <a:buChar char="•"/>
-              <a:defRPr sz="1800" kern="1200">
-                <a:solidFill>
-                  <a:schemeClr val="tx1"/>
-                </a:solidFill>
-                <a:latin typeface="+mn-lt"/>
-                <a:ea typeface="+mn-ea"/>
-                <a:cs typeface="+mn-cs"/>
-              </a:defRPr>
-            </a:lvl9pPr>
-          </a:lstStyle>
-          <a:p>
-            <a:pPr marL="0" marR="0" lvl="0" indent="0" algn="l" defTabSz="914400" rtl="0" eaLnBrk="1" fontAlgn="auto" latinLnBrk="0" hangingPunct="1">
-              <a:lnSpc>
-                <a:spcPct val="100000"/>
-              </a:lnSpc>
-              <a:spcBef>
-                <a:spcPts val="1000"/>
-              </a:spcBef>
-              <a:spcAft>
-                <a:spcPts val="0"/>
-              </a:spcAft>
-              <a:buClrTx/>
-              <a:buSzTx/>
-              <a:buFont typeface="Arial" panose="020B0604020202020204" pitchFamily="34" charset="0"/>
-              <a:buNone/>
-              <a:tabLst/>
-              <a:defRPr/>
-            </a:pPr>
-            <a:endParaRPr kumimoji="0" lang="en-US" sz="1100" b="0" i="0" u="none" strike="noStrike" kern="1200" cap="none" spc="0" normalizeH="0" baseline="0" noProof="0" dirty="0">
-              <a:ln>
-                <a:noFill/>
-              </a:ln>
-              <a:solidFill>
-                <a:prstClr val="black"/>
-              </a:solidFill>
-              <a:effectLst/>
-              <a:highlight>
-                <a:srgbClr val="FFFF00"/>
-              </a:highlight>
-              <a:uLnTx/>
-              <a:uFillTx/>
-              <a:latin typeface="Calibri" panose="020F0502020204030204"/>
-              <a:ea typeface="+mn-ea"/>
-              <a:cs typeface="+mn-cs"/>
-            </a:endParaRPr>
-          </a:p>
-        </p:txBody>
-      </p:sp>
-      <p:sp>
-        <p:nvSpPr>
-          <p:cNvPr id="51" name="Content Placeholder 2">
-            <a:extLst>
-              <a:ext uri="{FF2B5EF4-FFF2-40B4-BE49-F238E27FC236}">
-                <a16:creationId xmlns:a16="http://schemas.microsoft.com/office/drawing/2014/main" id="{CC1BE607-126E-7592-8B85-CB85B5A2433F}"/>
-              </a:ext>
-            </a:extLst>
-          </p:cNvPr>
-          <p:cNvSpPr txBox="1">
-            <a:spLocks/>
-          </p:cNvSpPr>
-          <p:nvPr/>
-        </p:nvSpPr>
-        <p:spPr>
-          <a:xfrm>
-            <a:off x="10375403" y="1791718"/>
-            <a:ext cx="1829165" cy="251867"/>
-          </a:xfrm>
-          <a:prstGeom prst="rect">
-            <a:avLst/>
-          </a:prstGeom>
-        </p:spPr>
-        <p:txBody>
-          <a:bodyPr vert="horz" lIns="91440" tIns="45720" rIns="91440" bIns="45720" rtlCol="0">
-            <a:noAutofit/>
-          </a:bodyPr>
-          <a:lstStyle>
-            <a:lvl1pPr marL="228600" indent="-228600" algn="l" defTabSz="914400" rtl="0" eaLnBrk="1" latinLnBrk="0" hangingPunct="1">
-              <a:lnSpc>
-                <a:spcPct val="90000"/>
-              </a:lnSpc>
-              <a:spcBef>
-                <a:spcPts val="1000"/>
-              </a:spcBef>
-              <a:buFont typeface="Arial" panose="020B0604020202020204" pitchFamily="34" charset="0"/>
-              <a:buChar char="•"/>
-              <a:defRPr sz="2800" kern="1200">
-                <a:solidFill>
-                  <a:schemeClr val="tx1"/>
-                </a:solidFill>
-                <a:latin typeface="+mn-lt"/>
-                <a:ea typeface="+mn-ea"/>
-                <a:cs typeface="+mn-cs"/>
-              </a:defRPr>
-            </a:lvl1pPr>
-            <a:lvl2pPr marL="685800" indent="-228600" algn="l" defTabSz="914400" rtl="0" eaLnBrk="1" latinLnBrk="0" hangingPunct="1">
-              <a:lnSpc>
-                <a:spcPct val="90000"/>
-              </a:lnSpc>
-              <a:spcBef>
-                <a:spcPts val="500"/>
-              </a:spcBef>
-              <a:buFont typeface="Arial" panose="020B0604020202020204" pitchFamily="34" charset="0"/>
-              <a:buChar char="•"/>
-              <a:defRPr sz="2400" kern="1200">
-                <a:solidFill>
-                  <a:schemeClr val="tx1"/>
-                </a:solidFill>
-                <a:latin typeface="+mn-lt"/>
-                <a:ea typeface="+mn-ea"/>
-                <a:cs typeface="+mn-cs"/>
-              </a:defRPr>
-            </a:lvl2pPr>
-            <a:lvl3pPr marL="1143000" indent="-228600" algn="l" defTabSz="914400" rtl="0" eaLnBrk="1" latinLnBrk="0" hangingPunct="1">
-              <a:lnSpc>
-                <a:spcPct val="90000"/>
-              </a:lnSpc>
-              <a:spcBef>
-                <a:spcPts val="500"/>
-              </a:spcBef>
-              <a:buFont typeface="Arial" panose="020B0604020202020204" pitchFamily="34" charset="0"/>
-              <a:buChar char="•"/>
-              <a:defRPr sz="2000" kern="1200">
-                <a:solidFill>
-                  <a:schemeClr val="tx1"/>
-                </a:solidFill>
-                <a:latin typeface="+mn-lt"/>
-                <a:ea typeface="+mn-ea"/>
-                <a:cs typeface="+mn-cs"/>
-              </a:defRPr>
-            </a:lvl3pPr>
-            <a:lvl4pPr marL="1600200" indent="-228600" algn="l" defTabSz="914400" rtl="0" eaLnBrk="1" latinLnBrk="0" hangingPunct="1">
-              <a:lnSpc>
-                <a:spcPct val="90000"/>
-              </a:lnSpc>
-              <a:spcBef>
-                <a:spcPts val="500"/>
-              </a:spcBef>
-              <a:buFont typeface="Arial" panose="020B0604020202020204" pitchFamily="34" charset="0"/>
-              <a:buChar char="•"/>
-              <a:defRPr sz="1800" kern="1200">
-                <a:solidFill>
-                  <a:schemeClr val="tx1"/>
-                </a:solidFill>
-                <a:latin typeface="+mn-lt"/>
-                <a:ea typeface="+mn-ea"/>
-                <a:cs typeface="+mn-cs"/>
-              </a:defRPr>
-            </a:lvl4pPr>
-            <a:lvl5pPr marL="2057400" indent="-228600" algn="l" defTabSz="914400" rtl="0" eaLnBrk="1" latinLnBrk="0" hangingPunct="1">
-              <a:lnSpc>
-                <a:spcPct val="90000"/>
-              </a:lnSpc>
-              <a:spcBef>
-                <a:spcPts val="500"/>
-              </a:spcBef>
-              <a:buFont typeface="Arial" panose="020B0604020202020204" pitchFamily="34" charset="0"/>
-              <a:buChar char="•"/>
-              <a:defRPr sz="1800" kern="1200">
-                <a:solidFill>
-                  <a:schemeClr val="tx1"/>
-                </a:solidFill>
-                <a:latin typeface="+mn-lt"/>
-                <a:ea typeface="+mn-ea"/>
-                <a:cs typeface="+mn-cs"/>
-              </a:defRPr>
-            </a:lvl5pPr>
-            <a:lvl6pPr marL="2514600" indent="-228600" algn="l" defTabSz="914400" rtl="0" eaLnBrk="1" latinLnBrk="0" hangingPunct="1">
-              <a:lnSpc>
-                <a:spcPct val="90000"/>
-              </a:lnSpc>
-              <a:spcBef>
-                <a:spcPts val="500"/>
-              </a:spcBef>
-              <a:buFont typeface="Arial" panose="020B0604020202020204" pitchFamily="34" charset="0"/>
-              <a:buChar char="•"/>
-              <a:defRPr sz="1800" kern="1200">
-                <a:solidFill>
-                  <a:schemeClr val="tx1"/>
-                </a:solidFill>
-                <a:latin typeface="+mn-lt"/>
-                <a:ea typeface="+mn-ea"/>
-                <a:cs typeface="+mn-cs"/>
-              </a:defRPr>
-            </a:lvl6pPr>
-            <a:lvl7pPr marL="2971800" indent="-228600" algn="l" defTabSz="914400" rtl="0" eaLnBrk="1" latinLnBrk="0" hangingPunct="1">
-              <a:lnSpc>
-                <a:spcPct val="90000"/>
-              </a:lnSpc>
-              <a:spcBef>
-                <a:spcPts val="500"/>
-              </a:spcBef>
-              <a:buFont typeface="Arial" panose="020B0604020202020204" pitchFamily="34" charset="0"/>
-              <a:buChar char="•"/>
-              <a:defRPr sz="1800" kern="1200">
-                <a:solidFill>
-                  <a:schemeClr val="tx1"/>
-                </a:solidFill>
-                <a:latin typeface="+mn-lt"/>
-                <a:ea typeface="+mn-ea"/>
-                <a:cs typeface="+mn-cs"/>
-              </a:defRPr>
-            </a:lvl7pPr>
-            <a:lvl8pPr marL="3429000" indent="-228600" algn="l" defTabSz="914400" rtl="0" eaLnBrk="1" latinLnBrk="0" hangingPunct="1">
-              <a:lnSpc>
-                <a:spcPct val="90000"/>
-              </a:lnSpc>
-              <a:spcBef>
-                <a:spcPts val="500"/>
-              </a:spcBef>
-              <a:buFont typeface="Arial" panose="020B0604020202020204" pitchFamily="34" charset="0"/>
-              <a:buChar char="•"/>
-              <a:defRPr sz="1800" kern="1200">
-                <a:solidFill>
-                  <a:schemeClr val="tx1"/>
-                </a:solidFill>
-                <a:latin typeface="+mn-lt"/>
-                <a:ea typeface="+mn-ea"/>
-                <a:cs typeface="+mn-cs"/>
-              </a:defRPr>
-            </a:lvl8pPr>
-            <a:lvl9pPr marL="3886200" indent="-228600" algn="l" defTabSz="914400" rtl="0" eaLnBrk="1" latinLnBrk="0" hangingPunct="1">
-              <a:lnSpc>
-                <a:spcPct val="90000"/>
-              </a:lnSpc>
-              <a:spcBef>
-                <a:spcPts val="500"/>
-              </a:spcBef>
-              <a:buFont typeface="Arial" panose="020B0604020202020204" pitchFamily="34" charset="0"/>
-              <a:buChar char="•"/>
-              <a:defRPr sz="1800" kern="1200">
-                <a:solidFill>
-                  <a:schemeClr val="tx1"/>
-                </a:solidFill>
-                <a:latin typeface="+mn-lt"/>
-                <a:ea typeface="+mn-ea"/>
-                <a:cs typeface="+mn-cs"/>
-              </a:defRPr>
-            </a:lvl9pPr>
-          </a:lstStyle>
-          <a:p>
-            <a:pPr marL="0" marR="0" lvl="0" indent="0" algn="l" defTabSz="914400" rtl="0" eaLnBrk="1" fontAlgn="auto" latinLnBrk="0" hangingPunct="1">
-              <a:lnSpc>
-                <a:spcPct val="100000"/>
-              </a:lnSpc>
-              <a:spcBef>
-                <a:spcPts val="1000"/>
-              </a:spcBef>
-              <a:spcAft>
-                <a:spcPts val="0"/>
-              </a:spcAft>
-              <a:buClrTx/>
-              <a:buSzTx/>
-              <a:buFont typeface="Arial" panose="020B0604020202020204" pitchFamily="34" charset="0"/>
-              <a:buNone/>
-              <a:tabLst/>
-              <a:defRPr/>
-            </a:pPr>
-            <a:endParaRPr kumimoji="0" lang="en-US" sz="1100" b="0" i="0" u="none" strike="noStrike" kern="1200" cap="none" spc="0" normalizeH="0" baseline="0" noProof="0" dirty="0">
-              <a:ln>
-                <a:noFill/>
-              </a:ln>
-              <a:solidFill>
-                <a:prstClr val="black"/>
-              </a:solidFill>
-              <a:effectLst/>
-              <a:highlight>
-                <a:srgbClr val="FFFF00"/>
-              </a:highlight>
-              <a:uLnTx/>
-              <a:uFillTx/>
-              <a:latin typeface="Calibri" panose="020F0502020204030204"/>
-              <a:ea typeface="+mn-ea"/>
-              <a:cs typeface="+mn-cs"/>
-            </a:endParaRPr>
-          </a:p>
-        </p:txBody>
-      </p:sp>
-      <p:sp>
-        <p:nvSpPr>
-          <p:cNvPr id="52" name="Content Placeholder 2">
-            <a:extLst>
-              <a:ext uri="{FF2B5EF4-FFF2-40B4-BE49-F238E27FC236}">
-                <a16:creationId xmlns:a16="http://schemas.microsoft.com/office/drawing/2014/main" id="{9146613C-4A56-CAA4-7C28-55FE52F8BF13}"/>
-              </a:ext>
-            </a:extLst>
-          </p:cNvPr>
-          <p:cNvSpPr txBox="1">
-            <a:spLocks/>
-          </p:cNvSpPr>
-          <p:nvPr/>
-        </p:nvSpPr>
-        <p:spPr>
-          <a:xfrm>
-            <a:off x="9379171" y="796970"/>
-            <a:ext cx="556124" cy="251867"/>
-          </a:xfrm>
-          <a:prstGeom prst="rect">
-            <a:avLst/>
-          </a:prstGeom>
-        </p:spPr>
-        <p:txBody>
-          <a:bodyPr vert="horz" lIns="91440" tIns="45720" rIns="91440" bIns="45720" rtlCol="0">
-            <a:noAutofit/>
-          </a:bodyPr>
-          <a:lstStyle>
-            <a:lvl1pPr marL="228600" indent="-228600" algn="l" defTabSz="914400" rtl="0" eaLnBrk="1" latinLnBrk="0" hangingPunct="1">
-              <a:lnSpc>
-                <a:spcPct val="90000"/>
-              </a:lnSpc>
-              <a:spcBef>
-                <a:spcPts val="1000"/>
-              </a:spcBef>
-              <a:buFont typeface="Arial" panose="020B0604020202020204" pitchFamily="34" charset="0"/>
-              <a:buChar char="•"/>
-              <a:defRPr sz="2800" kern="1200">
-                <a:solidFill>
-                  <a:schemeClr val="tx1"/>
-                </a:solidFill>
-                <a:latin typeface="+mn-lt"/>
-                <a:ea typeface="+mn-ea"/>
-                <a:cs typeface="+mn-cs"/>
-              </a:defRPr>
-            </a:lvl1pPr>
-            <a:lvl2pPr marL="685800" indent="-228600" algn="l" defTabSz="914400" rtl="0" eaLnBrk="1" latinLnBrk="0" hangingPunct="1">
-              <a:lnSpc>
-                <a:spcPct val="90000"/>
-              </a:lnSpc>
-              <a:spcBef>
-                <a:spcPts val="500"/>
-              </a:spcBef>
-              <a:buFont typeface="Arial" panose="020B0604020202020204" pitchFamily="34" charset="0"/>
-              <a:buChar char="•"/>
-              <a:defRPr sz="2400" kern="1200">
-                <a:solidFill>
-                  <a:schemeClr val="tx1"/>
-                </a:solidFill>
-                <a:latin typeface="+mn-lt"/>
-                <a:ea typeface="+mn-ea"/>
-                <a:cs typeface="+mn-cs"/>
-              </a:defRPr>
-            </a:lvl2pPr>
-            <a:lvl3pPr marL="1143000" indent="-228600" algn="l" defTabSz="914400" rtl="0" eaLnBrk="1" latinLnBrk="0" hangingPunct="1">
-              <a:lnSpc>
-                <a:spcPct val="90000"/>
-              </a:lnSpc>
-              <a:spcBef>
-                <a:spcPts val="500"/>
-              </a:spcBef>
-              <a:buFont typeface="Arial" panose="020B0604020202020204" pitchFamily="34" charset="0"/>
-              <a:buChar char="•"/>
-              <a:defRPr sz="2000" kern="1200">
-                <a:solidFill>
-                  <a:schemeClr val="tx1"/>
-                </a:solidFill>
-                <a:latin typeface="+mn-lt"/>
-                <a:ea typeface="+mn-ea"/>
-                <a:cs typeface="+mn-cs"/>
-              </a:defRPr>
-            </a:lvl3pPr>
-            <a:lvl4pPr marL="1600200" indent="-228600" algn="l" defTabSz="914400" rtl="0" eaLnBrk="1" latinLnBrk="0" hangingPunct="1">
-              <a:lnSpc>
-                <a:spcPct val="90000"/>
-              </a:lnSpc>
-              <a:spcBef>
-                <a:spcPts val="500"/>
-              </a:spcBef>
-              <a:buFont typeface="Arial" panose="020B0604020202020204" pitchFamily="34" charset="0"/>
-              <a:buChar char="•"/>
-              <a:defRPr sz="1800" kern="1200">
-                <a:solidFill>
-                  <a:schemeClr val="tx1"/>
-                </a:solidFill>
-                <a:latin typeface="+mn-lt"/>
-                <a:ea typeface="+mn-ea"/>
-                <a:cs typeface="+mn-cs"/>
-              </a:defRPr>
-            </a:lvl4pPr>
-            <a:lvl5pPr marL="2057400" indent="-228600" algn="l" defTabSz="914400" rtl="0" eaLnBrk="1" latinLnBrk="0" hangingPunct="1">
-              <a:lnSpc>
-                <a:spcPct val="90000"/>
-              </a:lnSpc>
-              <a:spcBef>
-                <a:spcPts val="500"/>
-              </a:spcBef>
-              <a:buFont typeface="Arial" panose="020B0604020202020204" pitchFamily="34" charset="0"/>
-              <a:buChar char="•"/>
-              <a:defRPr sz="1800" kern="1200">
-                <a:solidFill>
-                  <a:schemeClr val="tx1"/>
-                </a:solidFill>
-                <a:latin typeface="+mn-lt"/>
-                <a:ea typeface="+mn-ea"/>
-                <a:cs typeface="+mn-cs"/>
-              </a:defRPr>
-            </a:lvl5pPr>
-            <a:lvl6pPr marL="2514600" indent="-228600" algn="l" defTabSz="914400" rtl="0" eaLnBrk="1" latinLnBrk="0" hangingPunct="1">
-              <a:lnSpc>
-                <a:spcPct val="90000"/>
-              </a:lnSpc>
-              <a:spcBef>
-                <a:spcPts val="500"/>
-              </a:spcBef>
-              <a:buFont typeface="Arial" panose="020B0604020202020204" pitchFamily="34" charset="0"/>
-              <a:buChar char="•"/>
-              <a:defRPr sz="1800" kern="1200">
-                <a:solidFill>
-                  <a:schemeClr val="tx1"/>
-                </a:solidFill>
-                <a:latin typeface="+mn-lt"/>
-                <a:ea typeface="+mn-ea"/>
-                <a:cs typeface="+mn-cs"/>
-              </a:defRPr>
-            </a:lvl6pPr>
-            <a:lvl7pPr marL="2971800" indent="-228600" algn="l" defTabSz="914400" rtl="0" eaLnBrk="1" latinLnBrk="0" hangingPunct="1">
-              <a:lnSpc>
-                <a:spcPct val="90000"/>
-              </a:lnSpc>
-              <a:spcBef>
-                <a:spcPts val="500"/>
-              </a:spcBef>
-              <a:buFont typeface="Arial" panose="020B0604020202020204" pitchFamily="34" charset="0"/>
-              <a:buChar char="•"/>
-              <a:defRPr sz="1800" kern="1200">
-                <a:solidFill>
-                  <a:schemeClr val="tx1"/>
-                </a:solidFill>
-                <a:latin typeface="+mn-lt"/>
-                <a:ea typeface="+mn-ea"/>
-                <a:cs typeface="+mn-cs"/>
-              </a:defRPr>
-            </a:lvl7pPr>
-            <a:lvl8pPr marL="3429000" indent="-228600" algn="l" defTabSz="914400" rtl="0" eaLnBrk="1" latinLnBrk="0" hangingPunct="1">
-              <a:lnSpc>
-                <a:spcPct val="90000"/>
-              </a:lnSpc>
-              <a:spcBef>
-                <a:spcPts val="500"/>
-              </a:spcBef>
-              <a:buFont typeface="Arial" panose="020B0604020202020204" pitchFamily="34" charset="0"/>
-              <a:buChar char="•"/>
-              <a:defRPr sz="1800" kern="1200">
-                <a:solidFill>
-                  <a:schemeClr val="tx1"/>
-                </a:solidFill>
-                <a:latin typeface="+mn-lt"/>
-                <a:ea typeface="+mn-ea"/>
-                <a:cs typeface="+mn-cs"/>
-              </a:defRPr>
-            </a:lvl8pPr>
-            <a:lvl9pPr marL="3886200" indent="-228600" algn="l" defTabSz="914400" rtl="0" eaLnBrk="1" latinLnBrk="0" hangingPunct="1">
-              <a:lnSpc>
-                <a:spcPct val="90000"/>
-              </a:lnSpc>
-              <a:spcBef>
-                <a:spcPts val="500"/>
-              </a:spcBef>
-              <a:buFont typeface="Arial" panose="020B0604020202020204" pitchFamily="34" charset="0"/>
-              <a:buChar char="•"/>
-              <a:defRPr sz="1800" kern="1200">
-                <a:solidFill>
-                  <a:schemeClr val="tx1"/>
-                </a:solidFill>
-                <a:latin typeface="+mn-lt"/>
-                <a:ea typeface="+mn-ea"/>
-                <a:cs typeface="+mn-cs"/>
-              </a:defRPr>
-            </a:lvl9pPr>
-          </a:lstStyle>
-          <a:p>
-            <a:pPr marL="0" marR="0" lvl="0" indent="0" algn="l" defTabSz="914400" rtl="0" eaLnBrk="1" fontAlgn="auto" latinLnBrk="0" hangingPunct="1">
-              <a:lnSpc>
-                <a:spcPct val="100000"/>
-              </a:lnSpc>
-              <a:spcBef>
-                <a:spcPts val="1000"/>
-              </a:spcBef>
-              <a:spcAft>
-                <a:spcPts val="0"/>
-              </a:spcAft>
-              <a:buClrTx/>
-              <a:buSzTx/>
-              <a:buFont typeface="Arial" panose="020B0604020202020204" pitchFamily="34" charset="0"/>
-              <a:buNone/>
-              <a:tabLst/>
-              <a:defRPr/>
-            </a:pPr>
-            <a:endParaRPr kumimoji="0" lang="en-US" sz="1100" b="0" i="0" u="none" strike="noStrike" kern="1200" cap="none" spc="0" normalizeH="0" baseline="0" noProof="0" dirty="0">
-              <a:ln>
-                <a:noFill/>
-              </a:ln>
-              <a:solidFill>
-                <a:prstClr val="black"/>
-              </a:solidFill>
-              <a:effectLst/>
-              <a:highlight>
-                <a:srgbClr val="FFFF00"/>
-              </a:highlight>
-              <a:uLnTx/>
-              <a:uFillTx/>
-              <a:latin typeface="Calibri" panose="020F0502020204030204"/>
-              <a:ea typeface="+mn-ea"/>
-              <a:cs typeface="+mn-cs"/>
-            </a:endParaRPr>
-          </a:p>
-        </p:txBody>
-      </p:sp>
-      <p:sp>
-        <p:nvSpPr>
-          <p:cNvPr id="53" name="Content Placeholder 2">
-            <a:extLst>
-              <a:ext uri="{FF2B5EF4-FFF2-40B4-BE49-F238E27FC236}">
-                <a16:creationId xmlns:a16="http://schemas.microsoft.com/office/drawing/2014/main" id="{85C6D8F8-15C3-DAC0-77D1-A24D8082D348}"/>
-              </a:ext>
-            </a:extLst>
-          </p:cNvPr>
-          <p:cNvSpPr txBox="1">
-            <a:spLocks/>
-          </p:cNvSpPr>
-          <p:nvPr/>
-        </p:nvSpPr>
-        <p:spPr>
-          <a:xfrm>
-            <a:off x="7580960" y="905778"/>
-            <a:ext cx="556124" cy="251867"/>
-          </a:xfrm>
-          <a:prstGeom prst="rect">
-            <a:avLst/>
-          </a:prstGeom>
-        </p:spPr>
-        <p:txBody>
-          <a:bodyPr vert="horz" lIns="91440" tIns="45720" rIns="91440" bIns="45720" rtlCol="0">
-            <a:noAutofit/>
-          </a:bodyPr>
-          <a:lstStyle>
-            <a:lvl1pPr marL="228600" indent="-228600" algn="l" defTabSz="914400" rtl="0" eaLnBrk="1" latinLnBrk="0" hangingPunct="1">
-              <a:lnSpc>
-                <a:spcPct val="90000"/>
-              </a:lnSpc>
-              <a:spcBef>
-                <a:spcPts val="1000"/>
-              </a:spcBef>
-              <a:buFont typeface="Arial" panose="020B0604020202020204" pitchFamily="34" charset="0"/>
-              <a:buChar char="•"/>
-              <a:defRPr sz="2800" kern="1200">
-                <a:solidFill>
-                  <a:schemeClr val="tx1"/>
-                </a:solidFill>
-                <a:latin typeface="+mn-lt"/>
-                <a:ea typeface="+mn-ea"/>
-                <a:cs typeface="+mn-cs"/>
-              </a:defRPr>
-            </a:lvl1pPr>
-            <a:lvl2pPr marL="685800" indent="-228600" algn="l" defTabSz="914400" rtl="0" eaLnBrk="1" latinLnBrk="0" hangingPunct="1">
-              <a:lnSpc>
-                <a:spcPct val="90000"/>
-              </a:lnSpc>
-              <a:spcBef>
-                <a:spcPts val="500"/>
-              </a:spcBef>
-              <a:buFont typeface="Arial" panose="020B0604020202020204" pitchFamily="34" charset="0"/>
-              <a:buChar char="•"/>
-              <a:defRPr sz="2400" kern="1200">
-                <a:solidFill>
-                  <a:schemeClr val="tx1"/>
-                </a:solidFill>
-                <a:latin typeface="+mn-lt"/>
-                <a:ea typeface="+mn-ea"/>
-                <a:cs typeface="+mn-cs"/>
-              </a:defRPr>
-            </a:lvl2pPr>
-            <a:lvl3pPr marL="1143000" indent="-228600" algn="l" defTabSz="914400" rtl="0" eaLnBrk="1" latinLnBrk="0" hangingPunct="1">
-              <a:lnSpc>
-                <a:spcPct val="90000"/>
-              </a:lnSpc>
-              <a:spcBef>
-                <a:spcPts val="500"/>
-              </a:spcBef>
-              <a:buFont typeface="Arial" panose="020B0604020202020204" pitchFamily="34" charset="0"/>
-              <a:buChar char="•"/>
-              <a:defRPr sz="2000" kern="1200">
-                <a:solidFill>
-                  <a:schemeClr val="tx1"/>
-                </a:solidFill>
-                <a:latin typeface="+mn-lt"/>
-                <a:ea typeface="+mn-ea"/>
-                <a:cs typeface="+mn-cs"/>
-              </a:defRPr>
-            </a:lvl3pPr>
-            <a:lvl4pPr marL="1600200" indent="-228600" algn="l" defTabSz="914400" rtl="0" eaLnBrk="1" latinLnBrk="0" hangingPunct="1">
-              <a:lnSpc>
-                <a:spcPct val="90000"/>
-              </a:lnSpc>
-              <a:spcBef>
-                <a:spcPts val="500"/>
-              </a:spcBef>
-              <a:buFont typeface="Arial" panose="020B0604020202020204" pitchFamily="34" charset="0"/>
-              <a:buChar char="•"/>
-              <a:defRPr sz="1800" kern="1200">
-                <a:solidFill>
-                  <a:schemeClr val="tx1"/>
-                </a:solidFill>
-                <a:latin typeface="+mn-lt"/>
-                <a:ea typeface="+mn-ea"/>
-                <a:cs typeface="+mn-cs"/>
-              </a:defRPr>
-            </a:lvl4pPr>
-            <a:lvl5pPr marL="2057400" indent="-228600" algn="l" defTabSz="914400" rtl="0" eaLnBrk="1" latinLnBrk="0" hangingPunct="1">
-              <a:lnSpc>
-                <a:spcPct val="90000"/>
-              </a:lnSpc>
-              <a:spcBef>
-                <a:spcPts val="500"/>
-              </a:spcBef>
-              <a:buFont typeface="Arial" panose="020B0604020202020204" pitchFamily="34" charset="0"/>
-              <a:buChar char="•"/>
-              <a:defRPr sz="1800" kern="1200">
-                <a:solidFill>
-                  <a:schemeClr val="tx1"/>
-                </a:solidFill>
-                <a:latin typeface="+mn-lt"/>
-                <a:ea typeface="+mn-ea"/>
-                <a:cs typeface="+mn-cs"/>
-              </a:defRPr>
-            </a:lvl5pPr>
-            <a:lvl6pPr marL="2514600" indent="-228600" algn="l" defTabSz="914400" rtl="0" eaLnBrk="1" latinLnBrk="0" hangingPunct="1">
-              <a:lnSpc>
-                <a:spcPct val="90000"/>
-              </a:lnSpc>
-              <a:spcBef>
-                <a:spcPts val="500"/>
-              </a:spcBef>
-              <a:buFont typeface="Arial" panose="020B0604020202020204" pitchFamily="34" charset="0"/>
-              <a:buChar char="•"/>
-              <a:defRPr sz="1800" kern="1200">
-                <a:solidFill>
-                  <a:schemeClr val="tx1"/>
-                </a:solidFill>
-                <a:latin typeface="+mn-lt"/>
-                <a:ea typeface="+mn-ea"/>
-                <a:cs typeface="+mn-cs"/>
-              </a:defRPr>
-            </a:lvl6pPr>
-            <a:lvl7pPr marL="2971800" indent="-228600" algn="l" defTabSz="914400" rtl="0" eaLnBrk="1" latinLnBrk="0" hangingPunct="1">
-              <a:lnSpc>
-                <a:spcPct val="90000"/>
-              </a:lnSpc>
-              <a:spcBef>
-                <a:spcPts val="500"/>
-              </a:spcBef>
-              <a:buFont typeface="Arial" panose="020B0604020202020204" pitchFamily="34" charset="0"/>
-              <a:buChar char="•"/>
-              <a:defRPr sz="1800" kern="1200">
-                <a:solidFill>
-                  <a:schemeClr val="tx1"/>
-                </a:solidFill>
-                <a:latin typeface="+mn-lt"/>
-                <a:ea typeface="+mn-ea"/>
-                <a:cs typeface="+mn-cs"/>
-              </a:defRPr>
-            </a:lvl7pPr>
-            <a:lvl8pPr marL="3429000" indent="-228600" algn="l" defTabSz="914400" rtl="0" eaLnBrk="1" latinLnBrk="0" hangingPunct="1">
-              <a:lnSpc>
-                <a:spcPct val="90000"/>
-              </a:lnSpc>
-              <a:spcBef>
-                <a:spcPts val="500"/>
-              </a:spcBef>
-              <a:buFont typeface="Arial" panose="020B0604020202020204" pitchFamily="34" charset="0"/>
-              <a:buChar char="•"/>
-              <a:defRPr sz="1800" kern="1200">
-                <a:solidFill>
-                  <a:schemeClr val="tx1"/>
-                </a:solidFill>
-                <a:latin typeface="+mn-lt"/>
-                <a:ea typeface="+mn-ea"/>
-                <a:cs typeface="+mn-cs"/>
-              </a:defRPr>
-            </a:lvl8pPr>
-            <a:lvl9pPr marL="3886200" indent="-228600" algn="l" defTabSz="914400" rtl="0" eaLnBrk="1" latinLnBrk="0" hangingPunct="1">
-              <a:lnSpc>
-                <a:spcPct val="90000"/>
-              </a:lnSpc>
-              <a:spcBef>
-                <a:spcPts val="500"/>
-              </a:spcBef>
-              <a:buFont typeface="Arial" panose="020B0604020202020204" pitchFamily="34" charset="0"/>
-              <a:buChar char="•"/>
-              <a:defRPr sz="1800" kern="1200">
-                <a:solidFill>
-                  <a:schemeClr val="tx1"/>
-                </a:solidFill>
-                <a:latin typeface="+mn-lt"/>
-                <a:ea typeface="+mn-ea"/>
-                <a:cs typeface="+mn-cs"/>
-              </a:defRPr>
-            </a:lvl9pPr>
-          </a:lstStyle>
-          <a:p>
-            <a:pPr marL="0" marR="0" lvl="0" indent="0" algn="l" defTabSz="914400" rtl="0" eaLnBrk="1" fontAlgn="auto" latinLnBrk="0" hangingPunct="1">
-              <a:lnSpc>
-                <a:spcPct val="100000"/>
-              </a:lnSpc>
-              <a:spcBef>
-                <a:spcPts val="1000"/>
-              </a:spcBef>
-              <a:spcAft>
-                <a:spcPts val="0"/>
-              </a:spcAft>
-              <a:buClrTx/>
-              <a:buSzTx/>
-              <a:buFont typeface="Arial" panose="020B0604020202020204" pitchFamily="34" charset="0"/>
-              <a:buNone/>
-              <a:tabLst/>
-              <a:defRPr/>
-            </a:pPr>
-            <a:endParaRPr kumimoji="0" lang="en-US" sz="1100" b="0" i="0" u="none" strike="noStrike" kern="1200" cap="none" spc="0" normalizeH="0" baseline="0" noProof="0" dirty="0">
-              <a:ln>
-                <a:noFill/>
-              </a:ln>
-              <a:solidFill>
-                <a:prstClr val="black"/>
-              </a:solidFill>
-              <a:effectLst/>
-              <a:highlight>
-                <a:srgbClr val="FFFF00"/>
-              </a:highlight>
-              <a:uLnTx/>
-              <a:uFillTx/>
-              <a:latin typeface="Calibri" panose="020F0502020204030204"/>
-              <a:ea typeface="+mn-ea"/>
-              <a:cs typeface="+mn-cs"/>
-            </a:endParaRPr>
-          </a:p>
-        </p:txBody>
-      </p:sp>
-      <p:sp>
-        <p:nvSpPr>
-          <p:cNvPr id="54" name="Content Placeholder 2">
-            <a:extLst>
-              <a:ext uri="{FF2B5EF4-FFF2-40B4-BE49-F238E27FC236}">
-                <a16:creationId xmlns:a16="http://schemas.microsoft.com/office/drawing/2014/main" id="{58960BED-4C88-4AA4-8F7B-F67A2FC46A15}"/>
-              </a:ext>
-            </a:extLst>
-          </p:cNvPr>
-          <p:cNvSpPr txBox="1">
-            <a:spLocks/>
-          </p:cNvSpPr>
-          <p:nvPr/>
-        </p:nvSpPr>
-        <p:spPr>
-          <a:xfrm>
-            <a:off x="4649501" y="3331017"/>
-            <a:ext cx="2132356" cy="251867"/>
-          </a:xfrm>
-          <a:prstGeom prst="rect">
-            <a:avLst/>
-          </a:prstGeom>
-        </p:spPr>
-        <p:txBody>
-          <a:bodyPr vert="horz" lIns="91440" tIns="45720" rIns="91440" bIns="45720" rtlCol="0">
-            <a:noAutofit/>
-          </a:bodyPr>
-          <a:lstStyle>
-            <a:lvl1pPr marL="228600" indent="-228600" algn="l" defTabSz="914400" rtl="0" eaLnBrk="1" latinLnBrk="0" hangingPunct="1">
-              <a:lnSpc>
-                <a:spcPct val="90000"/>
-              </a:lnSpc>
-              <a:spcBef>
-                <a:spcPts val="1000"/>
-              </a:spcBef>
-              <a:buFont typeface="Arial" panose="020B0604020202020204" pitchFamily="34" charset="0"/>
-              <a:buChar char="•"/>
-              <a:defRPr sz="2800" kern="1200">
-                <a:solidFill>
-                  <a:schemeClr val="tx1"/>
-                </a:solidFill>
-                <a:latin typeface="+mn-lt"/>
-                <a:ea typeface="+mn-ea"/>
-                <a:cs typeface="+mn-cs"/>
-              </a:defRPr>
-            </a:lvl1pPr>
-            <a:lvl2pPr marL="685800" indent="-228600" algn="l" defTabSz="914400" rtl="0" eaLnBrk="1" latinLnBrk="0" hangingPunct="1">
-              <a:lnSpc>
-                <a:spcPct val="90000"/>
-              </a:lnSpc>
-              <a:spcBef>
-                <a:spcPts val="500"/>
-              </a:spcBef>
-              <a:buFont typeface="Arial" panose="020B0604020202020204" pitchFamily="34" charset="0"/>
-              <a:buChar char="•"/>
-              <a:defRPr sz="2400" kern="1200">
-                <a:solidFill>
-                  <a:schemeClr val="tx1"/>
-                </a:solidFill>
-                <a:latin typeface="+mn-lt"/>
-                <a:ea typeface="+mn-ea"/>
-                <a:cs typeface="+mn-cs"/>
-              </a:defRPr>
-            </a:lvl2pPr>
-            <a:lvl3pPr marL="1143000" indent="-228600" algn="l" defTabSz="914400" rtl="0" eaLnBrk="1" latinLnBrk="0" hangingPunct="1">
-              <a:lnSpc>
-                <a:spcPct val="90000"/>
-              </a:lnSpc>
-              <a:spcBef>
-                <a:spcPts val="500"/>
-              </a:spcBef>
-              <a:buFont typeface="Arial" panose="020B0604020202020204" pitchFamily="34" charset="0"/>
-              <a:buChar char="•"/>
-              <a:defRPr sz="2000" kern="1200">
-                <a:solidFill>
-                  <a:schemeClr val="tx1"/>
-                </a:solidFill>
-                <a:latin typeface="+mn-lt"/>
-                <a:ea typeface="+mn-ea"/>
-                <a:cs typeface="+mn-cs"/>
-              </a:defRPr>
-            </a:lvl3pPr>
-            <a:lvl4pPr marL="1600200" indent="-228600" algn="l" defTabSz="914400" rtl="0" eaLnBrk="1" latinLnBrk="0" hangingPunct="1">
-              <a:lnSpc>
-                <a:spcPct val="90000"/>
-              </a:lnSpc>
-              <a:spcBef>
-                <a:spcPts val="500"/>
-              </a:spcBef>
-              <a:buFont typeface="Arial" panose="020B0604020202020204" pitchFamily="34" charset="0"/>
-              <a:buChar char="•"/>
-              <a:defRPr sz="1800" kern="1200">
-                <a:solidFill>
-                  <a:schemeClr val="tx1"/>
-                </a:solidFill>
-                <a:latin typeface="+mn-lt"/>
-                <a:ea typeface="+mn-ea"/>
-                <a:cs typeface="+mn-cs"/>
-              </a:defRPr>
-            </a:lvl4pPr>
-            <a:lvl5pPr marL="2057400" indent="-228600" algn="l" defTabSz="914400" rtl="0" eaLnBrk="1" latinLnBrk="0" hangingPunct="1">
-              <a:lnSpc>
-                <a:spcPct val="90000"/>
-              </a:lnSpc>
-              <a:spcBef>
-                <a:spcPts val="500"/>
-              </a:spcBef>
-              <a:buFont typeface="Arial" panose="020B0604020202020204" pitchFamily="34" charset="0"/>
-              <a:buChar char="•"/>
-              <a:defRPr sz="1800" kern="1200">
-                <a:solidFill>
-                  <a:schemeClr val="tx1"/>
-                </a:solidFill>
-                <a:latin typeface="+mn-lt"/>
-                <a:ea typeface="+mn-ea"/>
-                <a:cs typeface="+mn-cs"/>
-              </a:defRPr>
-            </a:lvl5pPr>
-            <a:lvl6pPr marL="2514600" indent="-228600" algn="l" defTabSz="914400" rtl="0" eaLnBrk="1" latinLnBrk="0" hangingPunct="1">
-              <a:lnSpc>
-                <a:spcPct val="90000"/>
-              </a:lnSpc>
-              <a:spcBef>
-                <a:spcPts val="500"/>
-              </a:spcBef>
-              <a:buFont typeface="Arial" panose="020B0604020202020204" pitchFamily="34" charset="0"/>
-              <a:buChar char="•"/>
-              <a:defRPr sz="1800" kern="1200">
-                <a:solidFill>
-                  <a:schemeClr val="tx1"/>
-                </a:solidFill>
-                <a:latin typeface="+mn-lt"/>
-                <a:ea typeface="+mn-ea"/>
-                <a:cs typeface="+mn-cs"/>
-              </a:defRPr>
-            </a:lvl6pPr>
-            <a:lvl7pPr marL="2971800" indent="-228600" algn="l" defTabSz="914400" rtl="0" eaLnBrk="1" latinLnBrk="0" hangingPunct="1">
-              <a:lnSpc>
-                <a:spcPct val="90000"/>
-              </a:lnSpc>
-              <a:spcBef>
-                <a:spcPts val="500"/>
-              </a:spcBef>
-              <a:buFont typeface="Arial" panose="020B0604020202020204" pitchFamily="34" charset="0"/>
-              <a:buChar char="•"/>
-              <a:defRPr sz="1800" kern="1200">
-                <a:solidFill>
-                  <a:schemeClr val="tx1"/>
-                </a:solidFill>
-                <a:latin typeface="+mn-lt"/>
-                <a:ea typeface="+mn-ea"/>
-                <a:cs typeface="+mn-cs"/>
-              </a:defRPr>
-            </a:lvl7pPr>
-            <a:lvl8pPr marL="3429000" indent="-228600" algn="l" defTabSz="914400" rtl="0" eaLnBrk="1" latinLnBrk="0" hangingPunct="1">
-              <a:lnSpc>
-                <a:spcPct val="90000"/>
-              </a:lnSpc>
-              <a:spcBef>
-                <a:spcPts val="500"/>
-              </a:spcBef>
-              <a:buFont typeface="Arial" panose="020B0604020202020204" pitchFamily="34" charset="0"/>
-              <a:buChar char="•"/>
-              <a:defRPr sz="1800" kern="1200">
-                <a:solidFill>
-                  <a:schemeClr val="tx1"/>
-                </a:solidFill>
-                <a:latin typeface="+mn-lt"/>
-                <a:ea typeface="+mn-ea"/>
-                <a:cs typeface="+mn-cs"/>
-              </a:defRPr>
-            </a:lvl8pPr>
-            <a:lvl9pPr marL="3886200" indent="-228600" algn="l" defTabSz="914400" rtl="0" eaLnBrk="1" latinLnBrk="0" hangingPunct="1">
-              <a:lnSpc>
-                <a:spcPct val="90000"/>
-              </a:lnSpc>
-              <a:spcBef>
-                <a:spcPts val="500"/>
-              </a:spcBef>
-              <a:buFont typeface="Arial" panose="020B0604020202020204" pitchFamily="34" charset="0"/>
-              <a:buChar char="•"/>
-              <a:defRPr sz="1800" kern="1200">
-                <a:solidFill>
-                  <a:schemeClr val="tx1"/>
-                </a:solidFill>
-                <a:latin typeface="+mn-lt"/>
-                <a:ea typeface="+mn-ea"/>
-                <a:cs typeface="+mn-cs"/>
-              </a:defRPr>
-            </a:lvl9pPr>
-          </a:lstStyle>
-          <a:p>
-            <a:pPr marL="0" marR="0" lvl="0" indent="0" algn="l" defTabSz="914400" rtl="0" eaLnBrk="1" fontAlgn="auto" latinLnBrk="0" hangingPunct="1">
-              <a:lnSpc>
-                <a:spcPct val="100000"/>
-              </a:lnSpc>
-              <a:spcBef>
-                <a:spcPts val="1000"/>
-              </a:spcBef>
-              <a:spcAft>
-                <a:spcPts val="0"/>
-              </a:spcAft>
-              <a:buClrTx/>
-              <a:buSzTx/>
-              <a:buFont typeface="Arial" panose="020B0604020202020204" pitchFamily="34" charset="0"/>
-              <a:buNone/>
-              <a:tabLst/>
-              <a:defRPr/>
-            </a:pPr>
-            <a:endParaRPr kumimoji="0" lang="en-US" sz="1100" b="0" i="0" u="none" strike="noStrike" kern="1200" cap="none" spc="0" normalizeH="0" baseline="0" noProof="0" dirty="0">
-              <a:ln>
-                <a:noFill/>
-              </a:ln>
-              <a:solidFill>
-                <a:prstClr val="black"/>
-              </a:solidFill>
-              <a:effectLst/>
-              <a:highlight>
-                <a:srgbClr val="FFFF00"/>
-              </a:highlight>
-              <a:uLnTx/>
-              <a:uFillTx/>
-              <a:latin typeface="Calibri" panose="020F0502020204030204"/>
-              <a:ea typeface="+mn-ea"/>
-              <a:cs typeface="+mn-cs"/>
-            </a:endParaRPr>
-          </a:p>
-        </p:txBody>
-      </p:sp>
-      <p:sp>
-        <p:nvSpPr>
-          <p:cNvPr id="55" name="Content Placeholder 2">
-            <a:extLst>
-              <a:ext uri="{FF2B5EF4-FFF2-40B4-BE49-F238E27FC236}">
-                <a16:creationId xmlns:a16="http://schemas.microsoft.com/office/drawing/2014/main" id="{BB66856B-A197-3A8D-B103-13A109F2B826}"/>
-              </a:ext>
-            </a:extLst>
-          </p:cNvPr>
-          <p:cNvSpPr txBox="1">
-            <a:spLocks/>
-          </p:cNvSpPr>
-          <p:nvPr/>
-        </p:nvSpPr>
-        <p:spPr>
-          <a:xfrm>
-            <a:off x="8876696" y="6144674"/>
-            <a:ext cx="1760824" cy="251867"/>
-          </a:xfrm>
-          <a:prstGeom prst="rect">
-            <a:avLst/>
-          </a:prstGeom>
-        </p:spPr>
-        <p:txBody>
-          <a:bodyPr vert="horz" lIns="91440" tIns="45720" rIns="91440" bIns="45720" rtlCol="0">
-            <a:noAutofit/>
-          </a:bodyPr>
-          <a:lstStyle>
-            <a:lvl1pPr marL="228600" indent="-228600" algn="l" defTabSz="914400" rtl="0" eaLnBrk="1" latinLnBrk="0" hangingPunct="1">
-              <a:lnSpc>
-                <a:spcPct val="90000"/>
-              </a:lnSpc>
-              <a:spcBef>
-                <a:spcPts val="1000"/>
-              </a:spcBef>
-              <a:buFont typeface="Arial" panose="020B0604020202020204" pitchFamily="34" charset="0"/>
-              <a:buChar char="•"/>
-              <a:defRPr sz="2800" kern="1200">
-                <a:solidFill>
-                  <a:schemeClr val="tx1"/>
-                </a:solidFill>
-                <a:latin typeface="+mn-lt"/>
-                <a:ea typeface="+mn-ea"/>
-                <a:cs typeface="+mn-cs"/>
-              </a:defRPr>
-            </a:lvl1pPr>
-            <a:lvl2pPr marL="685800" indent="-228600" algn="l" defTabSz="914400" rtl="0" eaLnBrk="1" latinLnBrk="0" hangingPunct="1">
-              <a:lnSpc>
-                <a:spcPct val="90000"/>
-              </a:lnSpc>
-              <a:spcBef>
-                <a:spcPts val="500"/>
-              </a:spcBef>
-              <a:buFont typeface="Arial" panose="020B0604020202020204" pitchFamily="34" charset="0"/>
-              <a:buChar char="•"/>
-              <a:defRPr sz="2400" kern="1200">
-                <a:solidFill>
-                  <a:schemeClr val="tx1"/>
-                </a:solidFill>
-                <a:latin typeface="+mn-lt"/>
-                <a:ea typeface="+mn-ea"/>
-                <a:cs typeface="+mn-cs"/>
-              </a:defRPr>
-            </a:lvl2pPr>
-            <a:lvl3pPr marL="1143000" indent="-228600" algn="l" defTabSz="914400" rtl="0" eaLnBrk="1" latinLnBrk="0" hangingPunct="1">
-              <a:lnSpc>
-                <a:spcPct val="90000"/>
-              </a:lnSpc>
-              <a:spcBef>
-                <a:spcPts val="500"/>
-              </a:spcBef>
-              <a:buFont typeface="Arial" panose="020B0604020202020204" pitchFamily="34" charset="0"/>
-              <a:buChar char="•"/>
-              <a:defRPr sz="2000" kern="1200">
-                <a:solidFill>
-                  <a:schemeClr val="tx1"/>
-                </a:solidFill>
-                <a:latin typeface="+mn-lt"/>
-                <a:ea typeface="+mn-ea"/>
-                <a:cs typeface="+mn-cs"/>
-              </a:defRPr>
-            </a:lvl3pPr>
-            <a:lvl4pPr marL="1600200" indent="-228600" algn="l" defTabSz="914400" rtl="0" eaLnBrk="1" latinLnBrk="0" hangingPunct="1">
-              <a:lnSpc>
-                <a:spcPct val="90000"/>
-              </a:lnSpc>
-              <a:spcBef>
-                <a:spcPts val="500"/>
-              </a:spcBef>
-              <a:buFont typeface="Arial" panose="020B0604020202020204" pitchFamily="34" charset="0"/>
-              <a:buChar char="•"/>
-              <a:defRPr sz="1800" kern="1200">
-                <a:solidFill>
-                  <a:schemeClr val="tx1"/>
-                </a:solidFill>
-                <a:latin typeface="+mn-lt"/>
-                <a:ea typeface="+mn-ea"/>
-                <a:cs typeface="+mn-cs"/>
-              </a:defRPr>
-            </a:lvl4pPr>
-            <a:lvl5pPr marL="2057400" indent="-228600" algn="l" defTabSz="914400" rtl="0" eaLnBrk="1" latinLnBrk="0" hangingPunct="1">
-              <a:lnSpc>
-                <a:spcPct val="90000"/>
-              </a:lnSpc>
-              <a:spcBef>
-                <a:spcPts val="500"/>
-              </a:spcBef>
-              <a:buFont typeface="Arial" panose="020B0604020202020204" pitchFamily="34" charset="0"/>
-              <a:buChar char="•"/>
-              <a:defRPr sz="1800" kern="1200">
-                <a:solidFill>
-                  <a:schemeClr val="tx1"/>
-                </a:solidFill>
-                <a:latin typeface="+mn-lt"/>
-                <a:ea typeface="+mn-ea"/>
-                <a:cs typeface="+mn-cs"/>
-              </a:defRPr>
-            </a:lvl5pPr>
-            <a:lvl6pPr marL="2514600" indent="-228600" algn="l" defTabSz="914400" rtl="0" eaLnBrk="1" latinLnBrk="0" hangingPunct="1">
-              <a:lnSpc>
-                <a:spcPct val="90000"/>
-              </a:lnSpc>
-              <a:spcBef>
-                <a:spcPts val="500"/>
-              </a:spcBef>
-              <a:buFont typeface="Arial" panose="020B0604020202020204" pitchFamily="34" charset="0"/>
-              <a:buChar char="•"/>
-              <a:defRPr sz="1800" kern="1200">
-                <a:solidFill>
-                  <a:schemeClr val="tx1"/>
-                </a:solidFill>
-                <a:latin typeface="+mn-lt"/>
-                <a:ea typeface="+mn-ea"/>
-                <a:cs typeface="+mn-cs"/>
-              </a:defRPr>
-            </a:lvl6pPr>
-            <a:lvl7pPr marL="2971800" indent="-228600" algn="l" defTabSz="914400" rtl="0" eaLnBrk="1" latinLnBrk="0" hangingPunct="1">
-              <a:lnSpc>
-                <a:spcPct val="90000"/>
-              </a:lnSpc>
-              <a:spcBef>
-                <a:spcPts val="500"/>
-              </a:spcBef>
-              <a:buFont typeface="Arial" panose="020B0604020202020204" pitchFamily="34" charset="0"/>
-              <a:buChar char="•"/>
-              <a:defRPr sz="1800" kern="1200">
-                <a:solidFill>
-                  <a:schemeClr val="tx1"/>
-                </a:solidFill>
-                <a:latin typeface="+mn-lt"/>
-                <a:ea typeface="+mn-ea"/>
-                <a:cs typeface="+mn-cs"/>
-              </a:defRPr>
-            </a:lvl7pPr>
-            <a:lvl8pPr marL="3429000" indent="-228600" algn="l" defTabSz="914400" rtl="0" eaLnBrk="1" latinLnBrk="0" hangingPunct="1">
-              <a:lnSpc>
-                <a:spcPct val="90000"/>
-              </a:lnSpc>
-              <a:spcBef>
-                <a:spcPts val="500"/>
-              </a:spcBef>
-              <a:buFont typeface="Arial" panose="020B0604020202020204" pitchFamily="34" charset="0"/>
-              <a:buChar char="•"/>
-              <a:defRPr sz="1800" kern="1200">
-                <a:solidFill>
-                  <a:schemeClr val="tx1"/>
-                </a:solidFill>
-                <a:latin typeface="+mn-lt"/>
-                <a:ea typeface="+mn-ea"/>
-                <a:cs typeface="+mn-cs"/>
-              </a:defRPr>
-            </a:lvl8pPr>
-            <a:lvl9pPr marL="3886200" indent="-228600" algn="l" defTabSz="914400" rtl="0" eaLnBrk="1" latinLnBrk="0" hangingPunct="1">
-              <a:lnSpc>
-                <a:spcPct val="90000"/>
-              </a:lnSpc>
-              <a:spcBef>
-                <a:spcPts val="500"/>
-              </a:spcBef>
-              <a:buFont typeface="Arial" panose="020B0604020202020204" pitchFamily="34" charset="0"/>
-              <a:buChar char="•"/>
-              <a:defRPr sz="1800" kern="1200">
-                <a:solidFill>
-                  <a:schemeClr val="tx1"/>
-                </a:solidFill>
-                <a:latin typeface="+mn-lt"/>
-                <a:ea typeface="+mn-ea"/>
-                <a:cs typeface="+mn-cs"/>
-              </a:defRPr>
-            </a:lvl9pPr>
-          </a:lstStyle>
-          <a:p>
-            <a:pPr marL="0" marR="0" lvl="0" indent="0" algn="l" defTabSz="914400" rtl="0" eaLnBrk="1" fontAlgn="auto" latinLnBrk="0" hangingPunct="1">
-              <a:lnSpc>
-                <a:spcPct val="100000"/>
-              </a:lnSpc>
-              <a:spcBef>
-                <a:spcPts val="1000"/>
-              </a:spcBef>
-              <a:spcAft>
-                <a:spcPts val="0"/>
-              </a:spcAft>
-              <a:buClrTx/>
-              <a:buSzTx/>
-              <a:buFont typeface="Arial" panose="020B0604020202020204" pitchFamily="34" charset="0"/>
-              <a:buNone/>
-              <a:tabLst/>
-              <a:defRPr/>
-            </a:pPr>
-            <a:endParaRPr kumimoji="0" lang="en-US" sz="1100" b="0" i="0" u="none" strike="noStrike" kern="1200" cap="none" spc="0" normalizeH="0" baseline="0" noProof="0" dirty="0">
-              <a:ln>
-                <a:noFill/>
-              </a:ln>
-              <a:solidFill>
-                <a:prstClr val="black"/>
-              </a:solidFill>
-              <a:effectLst/>
-              <a:highlight>
-                <a:srgbClr val="FFFF00"/>
-              </a:highlight>
-              <a:uLnTx/>
-              <a:uFillTx/>
-              <a:latin typeface="Calibri" panose="020F0502020204030204"/>
-              <a:ea typeface="+mn-ea"/>
-              <a:cs typeface="+mn-cs"/>
-            </a:endParaRPr>
-          </a:p>
-        </p:txBody>
-      </p:sp>
-      <p:sp>
-        <p:nvSpPr>
-          <p:cNvPr id="56" name="Content Placeholder 2">
-            <a:extLst>
-              <a:ext uri="{FF2B5EF4-FFF2-40B4-BE49-F238E27FC236}">
-                <a16:creationId xmlns:a16="http://schemas.microsoft.com/office/drawing/2014/main" id="{6B37ED8F-95C2-063E-D72D-A64EF03CBD94}"/>
-              </a:ext>
-            </a:extLst>
-          </p:cNvPr>
-          <p:cNvSpPr txBox="1">
-            <a:spLocks/>
-          </p:cNvSpPr>
-          <p:nvPr/>
-        </p:nvSpPr>
-        <p:spPr>
-          <a:xfrm>
-            <a:off x="1546282" y="4876127"/>
-            <a:ext cx="1758271" cy="251867"/>
-          </a:xfrm>
-          <a:prstGeom prst="rect">
-            <a:avLst/>
-          </a:prstGeom>
-        </p:spPr>
-        <p:txBody>
-          <a:bodyPr vert="horz" lIns="91440" tIns="45720" rIns="91440" bIns="45720" rtlCol="0">
-            <a:noAutofit/>
-          </a:bodyPr>
-          <a:lstStyle>
-            <a:lvl1pPr marL="228600" indent="-228600" algn="l" defTabSz="914400" rtl="0" eaLnBrk="1" latinLnBrk="0" hangingPunct="1">
-              <a:lnSpc>
-                <a:spcPct val="90000"/>
-              </a:lnSpc>
-              <a:spcBef>
-                <a:spcPts val="1000"/>
-              </a:spcBef>
-              <a:buFont typeface="Arial" panose="020B0604020202020204" pitchFamily="34" charset="0"/>
-              <a:buChar char="•"/>
-              <a:defRPr sz="2800" kern="1200">
-                <a:solidFill>
-                  <a:schemeClr val="tx1"/>
-                </a:solidFill>
-                <a:latin typeface="+mn-lt"/>
-                <a:ea typeface="+mn-ea"/>
-                <a:cs typeface="+mn-cs"/>
-              </a:defRPr>
-            </a:lvl1pPr>
-            <a:lvl2pPr marL="685800" indent="-228600" algn="l" defTabSz="914400" rtl="0" eaLnBrk="1" latinLnBrk="0" hangingPunct="1">
-              <a:lnSpc>
-                <a:spcPct val="90000"/>
-              </a:lnSpc>
-              <a:spcBef>
-                <a:spcPts val="500"/>
-              </a:spcBef>
-              <a:buFont typeface="Arial" panose="020B0604020202020204" pitchFamily="34" charset="0"/>
-              <a:buChar char="•"/>
-              <a:defRPr sz="2400" kern="1200">
-                <a:solidFill>
-                  <a:schemeClr val="tx1"/>
-                </a:solidFill>
-                <a:latin typeface="+mn-lt"/>
-                <a:ea typeface="+mn-ea"/>
-                <a:cs typeface="+mn-cs"/>
-              </a:defRPr>
-            </a:lvl2pPr>
-            <a:lvl3pPr marL="1143000" indent="-228600" algn="l" defTabSz="914400" rtl="0" eaLnBrk="1" latinLnBrk="0" hangingPunct="1">
-              <a:lnSpc>
-                <a:spcPct val="90000"/>
-              </a:lnSpc>
-              <a:spcBef>
-                <a:spcPts val="500"/>
-              </a:spcBef>
-              <a:buFont typeface="Arial" panose="020B0604020202020204" pitchFamily="34" charset="0"/>
-              <a:buChar char="•"/>
-              <a:defRPr sz="2000" kern="1200">
-                <a:solidFill>
-                  <a:schemeClr val="tx1"/>
-                </a:solidFill>
-                <a:latin typeface="+mn-lt"/>
-                <a:ea typeface="+mn-ea"/>
-                <a:cs typeface="+mn-cs"/>
-              </a:defRPr>
-            </a:lvl3pPr>
-            <a:lvl4pPr marL="1600200" indent="-228600" algn="l" defTabSz="914400" rtl="0" eaLnBrk="1" latinLnBrk="0" hangingPunct="1">
-              <a:lnSpc>
-                <a:spcPct val="90000"/>
-              </a:lnSpc>
-              <a:spcBef>
-                <a:spcPts val="500"/>
-              </a:spcBef>
-              <a:buFont typeface="Arial" panose="020B0604020202020204" pitchFamily="34" charset="0"/>
-              <a:buChar char="•"/>
-              <a:defRPr sz="1800" kern="1200">
-                <a:solidFill>
-                  <a:schemeClr val="tx1"/>
-                </a:solidFill>
-                <a:latin typeface="+mn-lt"/>
-                <a:ea typeface="+mn-ea"/>
-                <a:cs typeface="+mn-cs"/>
-              </a:defRPr>
-            </a:lvl4pPr>
-            <a:lvl5pPr marL="2057400" indent="-228600" algn="l" defTabSz="914400" rtl="0" eaLnBrk="1" latinLnBrk="0" hangingPunct="1">
-              <a:lnSpc>
-                <a:spcPct val="90000"/>
-              </a:lnSpc>
-              <a:spcBef>
-                <a:spcPts val="500"/>
-              </a:spcBef>
-              <a:buFont typeface="Arial" panose="020B0604020202020204" pitchFamily="34" charset="0"/>
-              <a:buChar char="•"/>
-              <a:defRPr sz="1800" kern="1200">
-                <a:solidFill>
-                  <a:schemeClr val="tx1"/>
-                </a:solidFill>
-                <a:latin typeface="+mn-lt"/>
-                <a:ea typeface="+mn-ea"/>
-                <a:cs typeface="+mn-cs"/>
-              </a:defRPr>
-            </a:lvl5pPr>
-            <a:lvl6pPr marL="2514600" indent="-228600" algn="l" defTabSz="914400" rtl="0" eaLnBrk="1" latinLnBrk="0" hangingPunct="1">
-              <a:lnSpc>
-                <a:spcPct val="90000"/>
-              </a:lnSpc>
-              <a:spcBef>
-                <a:spcPts val="500"/>
-              </a:spcBef>
-              <a:buFont typeface="Arial" panose="020B0604020202020204" pitchFamily="34" charset="0"/>
-              <a:buChar char="•"/>
-              <a:defRPr sz="1800" kern="1200">
-                <a:solidFill>
-                  <a:schemeClr val="tx1"/>
-                </a:solidFill>
-                <a:latin typeface="+mn-lt"/>
-                <a:ea typeface="+mn-ea"/>
-                <a:cs typeface="+mn-cs"/>
-              </a:defRPr>
-            </a:lvl6pPr>
-            <a:lvl7pPr marL="2971800" indent="-228600" algn="l" defTabSz="914400" rtl="0" eaLnBrk="1" latinLnBrk="0" hangingPunct="1">
-              <a:lnSpc>
-                <a:spcPct val="90000"/>
-              </a:lnSpc>
-              <a:spcBef>
-                <a:spcPts val="500"/>
-              </a:spcBef>
-              <a:buFont typeface="Arial" panose="020B0604020202020204" pitchFamily="34" charset="0"/>
-              <a:buChar char="•"/>
-              <a:defRPr sz="1800" kern="1200">
-                <a:solidFill>
-                  <a:schemeClr val="tx1"/>
-                </a:solidFill>
-                <a:latin typeface="+mn-lt"/>
-                <a:ea typeface="+mn-ea"/>
-                <a:cs typeface="+mn-cs"/>
-              </a:defRPr>
-            </a:lvl7pPr>
-            <a:lvl8pPr marL="3429000" indent="-228600" algn="l" defTabSz="914400" rtl="0" eaLnBrk="1" latinLnBrk="0" hangingPunct="1">
-              <a:lnSpc>
-                <a:spcPct val="90000"/>
-              </a:lnSpc>
-              <a:spcBef>
-                <a:spcPts val="500"/>
-              </a:spcBef>
-              <a:buFont typeface="Arial" panose="020B0604020202020204" pitchFamily="34" charset="0"/>
-              <a:buChar char="•"/>
-              <a:defRPr sz="1800" kern="1200">
-                <a:solidFill>
-                  <a:schemeClr val="tx1"/>
-                </a:solidFill>
-                <a:latin typeface="+mn-lt"/>
-                <a:ea typeface="+mn-ea"/>
-                <a:cs typeface="+mn-cs"/>
-              </a:defRPr>
-            </a:lvl8pPr>
-            <a:lvl9pPr marL="3886200" indent="-228600" algn="l" defTabSz="914400" rtl="0" eaLnBrk="1" latinLnBrk="0" hangingPunct="1">
-              <a:lnSpc>
-                <a:spcPct val="90000"/>
-              </a:lnSpc>
-              <a:spcBef>
-                <a:spcPts val="500"/>
-              </a:spcBef>
-              <a:buFont typeface="Arial" panose="020B0604020202020204" pitchFamily="34" charset="0"/>
-              <a:buChar char="•"/>
-              <a:defRPr sz="1800" kern="1200">
-                <a:solidFill>
-                  <a:schemeClr val="tx1"/>
-                </a:solidFill>
-                <a:latin typeface="+mn-lt"/>
-                <a:ea typeface="+mn-ea"/>
-                <a:cs typeface="+mn-cs"/>
-              </a:defRPr>
-            </a:lvl9pPr>
-          </a:lstStyle>
-          <a:p>
-            <a:pPr marL="0" marR="0" lvl="0" indent="0" algn="l" defTabSz="914400" rtl="0" eaLnBrk="1" fontAlgn="auto" latinLnBrk="0" hangingPunct="1">
-              <a:lnSpc>
-                <a:spcPct val="100000"/>
-              </a:lnSpc>
-              <a:spcBef>
-                <a:spcPts val="1000"/>
-              </a:spcBef>
-              <a:spcAft>
-                <a:spcPts val="0"/>
-              </a:spcAft>
-              <a:buClrTx/>
-              <a:buSzTx/>
-              <a:buFont typeface="Arial" panose="020B0604020202020204" pitchFamily="34" charset="0"/>
-              <a:buNone/>
-              <a:tabLst/>
-              <a:defRPr/>
-            </a:pPr>
-            <a:endParaRPr kumimoji="0" lang="en-US" sz="1100" b="0" i="0" u="none" strike="noStrike" kern="1200" cap="none" spc="0" normalizeH="0" baseline="0" noProof="0" dirty="0">
-              <a:ln>
-                <a:noFill/>
-              </a:ln>
-              <a:solidFill>
-                <a:prstClr val="black"/>
-              </a:solidFill>
-              <a:effectLst/>
-              <a:highlight>
-                <a:srgbClr val="FFFF00"/>
-              </a:highlight>
-              <a:uLnTx/>
-              <a:uFillTx/>
-              <a:latin typeface="Calibri" panose="020F0502020204030204"/>
-              <a:ea typeface="+mn-ea"/>
-              <a:cs typeface="+mn-cs"/>
-            </a:endParaRPr>
-          </a:p>
-        </p:txBody>
-      </p:sp>
     </p:spTree>
     <p:extLst>
       <p:ext uri="{BB962C8B-B14F-4D97-AF65-F5344CB8AC3E}">
@@ -23637,13 +21484,19 @@
             </a:pPr>
             <a:r>
               <a:rPr sz="1100"/>
-              <a:t>This project implements automated acoustic-visual monitoring for the Fairy Pitta on AMD PYNQ-Z2 (XC7Z020).</a:t>
+              <a:t>This project implements automated acoustic-visual monitoring for the Fairy Pitta on AMD PYNQ-Z2.</a:t>
             </a:r>
           </a:p>
           <a:p>
             <a:r>
               <a:rPr sz="1100"/>
-              <a:t>PL-side I2S acquires mic data with HLS GEMM acceleration; PS runs bird call detection and YOLOv8n, achieving call-trigger-visual-confirm-auto-record loop.</a:t>
+              <a:t/>
+            </a:r>
+          </a:p>
+          <a:p>
+            <a:r>
+              <a:rPr sz="1100"/>
+              <a:t>PL-side I2S acquires mic data with HLS GEMM; PS runs bird call detection and YOLOv8n, achieving call-trigger-visual-confirm-auto-record loop.</a:t>
             </a:r>
           </a:p>
           <a:p>
@@ -23782,106 +21635,8 @@
               <a:defRPr/>
             </a:pPr>
             <a:r>
-              <a:rPr kumimoji="0" lang="en-US" sz="2400" b="1" i="0" u="none" strike="noStrike" kern="1200" cap="none" spc="0" normalizeH="0" baseline="0" noProof="0" dirty="0">
-                <a:ln>
-                  <a:noFill/>
-                </a:ln>
-                <a:solidFill>
-                  <a:prstClr val="black"/>
-                </a:solidFill>
-                <a:effectLst/>
-                <a:uLnTx/>
-                <a:uFillTx/>
-                <a:latin typeface="Times New Roman" panose="02020603050405020304" pitchFamily="18" charset="0"/>
-                <a:ea typeface="+mn-ea"/>
-                <a:cs typeface="Times New Roman" panose="02020603050405020304" pitchFamily="18" charset="0"/>
-                <a:sym typeface="+mn-ea"/>
-              </a:rPr>
-              <a:t>Acoustic-Visual Collaborative Monitoring for Fairy Pitta</a:t>
-            </a:r>
-            <a:r>
-              <a:rPr kumimoji="0" lang="zh-CN" altLang="en-US" sz="2400" b="1" i="0" u="none" strike="noStrike" kern="1200" cap="none" spc="0" normalizeH="0" baseline="0" noProof="0" dirty="0">
-                <a:ln>
-                  <a:noFill/>
-                </a:ln>
-                <a:solidFill>
-                  <a:prstClr val="black"/>
-                </a:solidFill>
-                <a:effectLst/>
-                <a:highlight>
-                  <a:srgbClr val="FFFF00"/>
-                </a:highlight>
-                <a:uLnTx/>
-                <a:uFillTx/>
-                <a:latin typeface="Times New Roman" panose="02020603050405020304" pitchFamily="18" charset="0"/>
-                <a:ea typeface="等线" panose="02010600030101010101" pitchFamily="2" charset="-122"/>
-                <a:cs typeface="Times New Roman" panose="02020603050405020304" pitchFamily="18" charset="0"/>
-                <a:sym typeface="+mn-ea"/>
-              </a:rPr>
-              <a:t>Acoustic-Visual Collaborative Monitoring for Fairy Pitta</a:t>
-            </a:r>
-            <a:r>
-              <a:rPr kumimoji="0" lang="en-US" altLang="zh-CN" sz="2400" b="1" i="0" u="none" strike="noStrike" kern="1200" cap="none" spc="0" normalizeH="0" baseline="0" noProof="0" dirty="0">
-                <a:ln>
-                  <a:noFill/>
-                </a:ln>
-                <a:solidFill>
-                  <a:prstClr val="black"/>
-                </a:solidFill>
-                <a:effectLst/>
-                <a:highlight>
-                  <a:srgbClr val="FFFF00"/>
-                </a:highlight>
-                <a:uLnTx/>
-                <a:uFillTx/>
-                <a:latin typeface="Times New Roman" panose="02020603050405020304" pitchFamily="18" charset="0"/>
-                <a:ea typeface="等线" panose="02010600030101010101" pitchFamily="2" charset="-122"/>
-                <a:cs typeface="Times New Roman" panose="02020603050405020304" pitchFamily="18" charset="0"/>
-                <a:sym typeface="+mn-ea"/>
-              </a:rPr>
-              <a:t>Acoustic-Visual Collaborative Monitoring for Fairy Pitta</a:t>
-            </a:r>
-            <a:r>
-              <a:rPr kumimoji="0" lang="zh-CN" altLang="en-US" sz="2400" b="1" i="0" u="none" strike="noStrike" kern="1200" cap="none" spc="0" normalizeH="0" baseline="0" noProof="0" dirty="0">
-                <a:ln>
-                  <a:noFill/>
-                </a:ln>
-                <a:solidFill>
-                  <a:prstClr val="black"/>
-                </a:solidFill>
-                <a:effectLst/>
-                <a:highlight>
-                  <a:srgbClr val="FFFF00"/>
-                </a:highlight>
-                <a:uLnTx/>
-                <a:uFillTx/>
-                <a:latin typeface="Times New Roman" panose="02020603050405020304" pitchFamily="18" charset="0"/>
-                <a:ea typeface="等线" panose="02010600030101010101" pitchFamily="2" charset="-122"/>
-                <a:cs typeface="Times New Roman" panose="02020603050405020304" pitchFamily="18" charset="0"/>
-                <a:sym typeface="+mn-ea"/>
-              </a:rPr>
-              <a:t>Acoustic-Visual Collaborative Monitoring for Fairy Pitta</a:t>
-            </a:r>
-            <a:r>
-              <a:rPr kumimoji="0" lang="en-US" altLang="zh-CN" sz="2400" b="1" i="0" u="none" strike="noStrike" kern="1200" cap="none" spc="0" normalizeH="0" baseline="0" noProof="0" dirty="0">
-                <a:ln>
-                  <a:noFill/>
-                </a:ln>
-                <a:solidFill>
-                  <a:prstClr val="black"/>
-                </a:solidFill>
-                <a:effectLst/>
-                <a:highlight>
-                  <a:srgbClr val="FFFF00"/>
-                </a:highlight>
-                <a:uLnTx/>
-                <a:uFillTx/>
-                <a:latin typeface="Times New Roman" panose="02020603050405020304" pitchFamily="18" charset="0"/>
-                <a:ea typeface="等线" panose="02010600030101010101" pitchFamily="2" charset="-122"/>
-                <a:cs typeface="Times New Roman" panose="02020603050405020304" pitchFamily="18" charset="0"/>
-                <a:sym typeface="+mn-ea"/>
-              </a:rPr>
-              <a:t>Acoustic-Visual Collaborative Monitoring for Fairy Pitta</a:t>
+              <a:rPr sz="2400" b="1"/>
+              <a:t>Acoustic-Visual Monitoring for Fairy Pitta</a:t>
             </a:r>
             <a:endParaRPr kumimoji="0" lang="en-US" sz="2400" b="1" i="0" u="none" strike="noStrike" kern="1200" cap="none" spc="0" normalizeH="0" baseline="0" noProof="0" dirty="0">
               <a:ln>
@@ -24140,7 +21895,7 @@
                 <a:cs typeface="Times New Roman" panose="02020603050405020304" pitchFamily="18" charset="0"/>
                 <a:sym typeface="+mn-ea"/>
               </a:rPr>
-              <a:t>Application</a:t>
+              <a:t>Application: forest field monitoring</a:t>
             </a:r>
           </a:p>
         </p:txBody>
@@ -25398,7 +23153,7 @@
               <a:defRPr/>
             </a:pPr>
             <a:r>
-              <a:rPr kumimoji="0" lang="en-US" altLang="zh-CN" sz="1100" b="1" i="1" u="none" strike="noStrike" kern="1200" cap="none" spc="0" normalizeH="0" baseline="0" noProof="0" dirty="0">
+              <a:rPr kumimoji="0" lang="en-US" altLang="zh-CN" sz="1000" b="1" i="1" u="none" strike="noStrike" kern="1200" cap="none" spc="0" normalizeH="0" baseline="0" noProof="0" dirty="0">
                 <a:ln>
                   <a:noFill/>
                 </a:ln>
@@ -25464,7 +23219,7 @@
             </a:pPr>
             <a:r>
               <a:rPr sz="1200" b="1"/>
-              <a:t>Wuhan University,</a:t>
+              <a:t>Wuhan University</a:t>
             </a:r>
           </a:p>
           <a:p>
@@ -26799,2067 +24554,6 @@
           </a:prstGeom>
         </p:spPr>
       </p:pic>
-      <p:sp>
-        <p:nvSpPr>
-          <p:cNvPr id="48" name="Content Placeholder 2">
-            <a:extLst>
-              <a:ext uri="{FF2B5EF4-FFF2-40B4-BE49-F238E27FC236}">
-                <a16:creationId xmlns:a16="http://schemas.microsoft.com/office/drawing/2014/main" id="{7E1E88F6-BAF0-0A44-5F1D-0F6693085835}"/>
-              </a:ext>
-            </a:extLst>
-          </p:cNvPr>
-          <p:cNvSpPr txBox="1">
-            <a:spLocks/>
-          </p:cNvSpPr>
-          <p:nvPr/>
-        </p:nvSpPr>
-        <p:spPr>
-          <a:xfrm>
-            <a:off x="1036793" y="1576933"/>
-            <a:ext cx="2221767" cy="251867"/>
-          </a:xfrm>
-          <a:prstGeom prst="rect">
-            <a:avLst/>
-          </a:prstGeom>
-        </p:spPr>
-        <p:txBody>
-          <a:bodyPr vert="horz" lIns="91440" tIns="45720" rIns="91440" bIns="45720" rtlCol="0">
-            <a:noAutofit/>
-          </a:bodyPr>
-          <a:lstStyle>
-            <a:lvl1pPr marL="228600" indent="-228600" algn="l" defTabSz="914400" rtl="0" eaLnBrk="1" latinLnBrk="0" hangingPunct="1">
-              <a:lnSpc>
-                <a:spcPct val="90000"/>
-              </a:lnSpc>
-              <a:spcBef>
-                <a:spcPts val="1000"/>
-              </a:spcBef>
-              <a:buFont typeface="Arial" panose="020B0604020202020204" pitchFamily="34" charset="0"/>
-              <a:buChar char="•"/>
-              <a:defRPr sz="2800" kern="1200">
-                <a:solidFill>
-                  <a:schemeClr val="tx1"/>
-                </a:solidFill>
-                <a:latin typeface="+mn-lt"/>
-                <a:ea typeface="+mn-ea"/>
-                <a:cs typeface="+mn-cs"/>
-              </a:defRPr>
-            </a:lvl1pPr>
-            <a:lvl2pPr marL="685800" indent="-228600" algn="l" defTabSz="914400" rtl="0" eaLnBrk="1" latinLnBrk="0" hangingPunct="1">
-              <a:lnSpc>
-                <a:spcPct val="90000"/>
-              </a:lnSpc>
-              <a:spcBef>
-                <a:spcPts val="500"/>
-              </a:spcBef>
-              <a:buFont typeface="Arial" panose="020B0604020202020204" pitchFamily="34" charset="0"/>
-              <a:buChar char="•"/>
-              <a:defRPr sz="2400" kern="1200">
-                <a:solidFill>
-                  <a:schemeClr val="tx1"/>
-                </a:solidFill>
-                <a:latin typeface="+mn-lt"/>
-                <a:ea typeface="+mn-ea"/>
-                <a:cs typeface="+mn-cs"/>
-              </a:defRPr>
-            </a:lvl2pPr>
-            <a:lvl3pPr marL="1143000" indent="-228600" algn="l" defTabSz="914400" rtl="0" eaLnBrk="1" latinLnBrk="0" hangingPunct="1">
-              <a:lnSpc>
-                <a:spcPct val="90000"/>
-              </a:lnSpc>
-              <a:spcBef>
-                <a:spcPts val="500"/>
-              </a:spcBef>
-              <a:buFont typeface="Arial" panose="020B0604020202020204" pitchFamily="34" charset="0"/>
-              <a:buChar char="•"/>
-              <a:defRPr sz="2000" kern="1200">
-                <a:solidFill>
-                  <a:schemeClr val="tx1"/>
-                </a:solidFill>
-                <a:latin typeface="+mn-lt"/>
-                <a:ea typeface="+mn-ea"/>
-                <a:cs typeface="+mn-cs"/>
-              </a:defRPr>
-            </a:lvl3pPr>
-            <a:lvl4pPr marL="1600200" indent="-228600" algn="l" defTabSz="914400" rtl="0" eaLnBrk="1" latinLnBrk="0" hangingPunct="1">
-              <a:lnSpc>
-                <a:spcPct val="90000"/>
-              </a:lnSpc>
-              <a:spcBef>
-                <a:spcPts val="500"/>
-              </a:spcBef>
-              <a:buFont typeface="Arial" panose="020B0604020202020204" pitchFamily="34" charset="0"/>
-              <a:buChar char="•"/>
-              <a:defRPr sz="1800" kern="1200">
-                <a:solidFill>
-                  <a:schemeClr val="tx1"/>
-                </a:solidFill>
-                <a:latin typeface="+mn-lt"/>
-                <a:ea typeface="+mn-ea"/>
-                <a:cs typeface="+mn-cs"/>
-              </a:defRPr>
-            </a:lvl4pPr>
-            <a:lvl5pPr marL="2057400" indent="-228600" algn="l" defTabSz="914400" rtl="0" eaLnBrk="1" latinLnBrk="0" hangingPunct="1">
-              <a:lnSpc>
-                <a:spcPct val="90000"/>
-              </a:lnSpc>
-              <a:spcBef>
-                <a:spcPts val="500"/>
-              </a:spcBef>
-              <a:buFont typeface="Arial" panose="020B0604020202020204" pitchFamily="34" charset="0"/>
-              <a:buChar char="•"/>
-              <a:defRPr sz="1800" kern="1200">
-                <a:solidFill>
-                  <a:schemeClr val="tx1"/>
-                </a:solidFill>
-                <a:latin typeface="+mn-lt"/>
-                <a:ea typeface="+mn-ea"/>
-                <a:cs typeface="+mn-cs"/>
-              </a:defRPr>
-            </a:lvl5pPr>
-            <a:lvl6pPr marL="2514600" indent="-228600" algn="l" defTabSz="914400" rtl="0" eaLnBrk="1" latinLnBrk="0" hangingPunct="1">
-              <a:lnSpc>
-                <a:spcPct val="90000"/>
-              </a:lnSpc>
-              <a:spcBef>
-                <a:spcPts val="500"/>
-              </a:spcBef>
-              <a:buFont typeface="Arial" panose="020B0604020202020204" pitchFamily="34" charset="0"/>
-              <a:buChar char="•"/>
-              <a:defRPr sz="1800" kern="1200">
-                <a:solidFill>
-                  <a:schemeClr val="tx1"/>
-                </a:solidFill>
-                <a:latin typeface="+mn-lt"/>
-                <a:ea typeface="+mn-ea"/>
-                <a:cs typeface="+mn-cs"/>
-              </a:defRPr>
-            </a:lvl6pPr>
-            <a:lvl7pPr marL="2971800" indent="-228600" algn="l" defTabSz="914400" rtl="0" eaLnBrk="1" latinLnBrk="0" hangingPunct="1">
-              <a:lnSpc>
-                <a:spcPct val="90000"/>
-              </a:lnSpc>
-              <a:spcBef>
-                <a:spcPts val="500"/>
-              </a:spcBef>
-              <a:buFont typeface="Arial" panose="020B0604020202020204" pitchFamily="34" charset="0"/>
-              <a:buChar char="•"/>
-              <a:defRPr sz="1800" kern="1200">
-                <a:solidFill>
-                  <a:schemeClr val="tx1"/>
-                </a:solidFill>
-                <a:latin typeface="+mn-lt"/>
-                <a:ea typeface="+mn-ea"/>
-                <a:cs typeface="+mn-cs"/>
-              </a:defRPr>
-            </a:lvl7pPr>
-            <a:lvl8pPr marL="3429000" indent="-228600" algn="l" defTabSz="914400" rtl="0" eaLnBrk="1" latinLnBrk="0" hangingPunct="1">
-              <a:lnSpc>
-                <a:spcPct val="90000"/>
-              </a:lnSpc>
-              <a:spcBef>
-                <a:spcPts val="500"/>
-              </a:spcBef>
-              <a:buFont typeface="Arial" panose="020B0604020202020204" pitchFamily="34" charset="0"/>
-              <a:buChar char="•"/>
-              <a:defRPr sz="1800" kern="1200">
-                <a:solidFill>
-                  <a:schemeClr val="tx1"/>
-                </a:solidFill>
-                <a:latin typeface="+mn-lt"/>
-                <a:ea typeface="+mn-ea"/>
-                <a:cs typeface="+mn-cs"/>
-              </a:defRPr>
-            </a:lvl8pPr>
-            <a:lvl9pPr marL="3886200" indent="-228600" algn="l" defTabSz="914400" rtl="0" eaLnBrk="1" latinLnBrk="0" hangingPunct="1">
-              <a:lnSpc>
-                <a:spcPct val="90000"/>
-              </a:lnSpc>
-              <a:spcBef>
-                <a:spcPts val="500"/>
-              </a:spcBef>
-              <a:buFont typeface="Arial" panose="020B0604020202020204" pitchFamily="34" charset="0"/>
-              <a:buChar char="•"/>
-              <a:defRPr sz="1800" kern="1200">
-                <a:solidFill>
-                  <a:schemeClr val="tx1"/>
-                </a:solidFill>
-                <a:latin typeface="+mn-lt"/>
-                <a:ea typeface="+mn-ea"/>
-                <a:cs typeface="+mn-cs"/>
-              </a:defRPr>
-            </a:lvl9pPr>
-          </a:lstStyle>
-          <a:p>
-            <a:pPr marL="0" marR="0" lvl="0" indent="0" algn="l" defTabSz="914400" rtl="0" eaLnBrk="1" fontAlgn="auto" latinLnBrk="0" hangingPunct="1">
-              <a:lnSpc>
-                <a:spcPct val="100000"/>
-              </a:lnSpc>
-              <a:spcBef>
-                <a:spcPts val="1000"/>
-              </a:spcBef>
-              <a:spcAft>
-                <a:spcPts val="0"/>
-              </a:spcAft>
-              <a:buClrTx/>
-              <a:buSzTx/>
-              <a:buFont typeface="Arial" panose="020B0604020202020204" pitchFamily="34" charset="0"/>
-              <a:buNone/>
-              <a:tabLst/>
-              <a:defRPr/>
-            </a:pPr>
-            <a:endParaRPr kumimoji="0" lang="en-US" sz="1100" b="0" i="0" u="none" strike="noStrike" kern="1200" cap="none" spc="0" normalizeH="0" baseline="0" noProof="0" dirty="0">
-              <a:ln>
-                <a:noFill/>
-              </a:ln>
-              <a:solidFill>
-                <a:prstClr val="black"/>
-              </a:solidFill>
-              <a:effectLst/>
-              <a:highlight>
-                <a:srgbClr val="FFFF00"/>
-              </a:highlight>
-              <a:uLnTx/>
-              <a:uFillTx/>
-              <a:latin typeface="Calibri" panose="020F0502020204030204"/>
-              <a:ea typeface="+mn-ea"/>
-              <a:cs typeface="+mn-cs"/>
-            </a:endParaRPr>
-          </a:p>
-        </p:txBody>
-      </p:sp>
-      <p:sp>
-        <p:nvSpPr>
-          <p:cNvPr id="49" name="Content Placeholder 2">
-            <a:extLst>
-              <a:ext uri="{FF2B5EF4-FFF2-40B4-BE49-F238E27FC236}">
-                <a16:creationId xmlns:a16="http://schemas.microsoft.com/office/drawing/2014/main" id="{1993D883-5FD0-5FA9-2211-42E39F416E95}"/>
-              </a:ext>
-            </a:extLst>
-          </p:cNvPr>
-          <p:cNvSpPr txBox="1">
-            <a:spLocks/>
-          </p:cNvSpPr>
-          <p:nvPr/>
-        </p:nvSpPr>
-        <p:spPr>
-          <a:xfrm>
-            <a:off x="7037169" y="-1643"/>
-            <a:ext cx="3436277" cy="251867"/>
-          </a:xfrm>
-          <a:prstGeom prst="rect">
-            <a:avLst/>
-          </a:prstGeom>
-        </p:spPr>
-        <p:txBody>
-          <a:bodyPr vert="horz" lIns="91440" tIns="45720" rIns="91440" bIns="45720" rtlCol="0">
-            <a:noAutofit/>
-          </a:bodyPr>
-          <a:lstStyle>
-            <a:lvl1pPr marL="228600" indent="-228600" algn="l" defTabSz="914400" rtl="0" eaLnBrk="1" latinLnBrk="0" hangingPunct="1">
-              <a:lnSpc>
-                <a:spcPct val="90000"/>
-              </a:lnSpc>
-              <a:spcBef>
-                <a:spcPts val="1000"/>
-              </a:spcBef>
-              <a:buFont typeface="Arial" panose="020B0604020202020204" pitchFamily="34" charset="0"/>
-              <a:buChar char="•"/>
-              <a:defRPr sz="2800" kern="1200">
-                <a:solidFill>
-                  <a:schemeClr val="tx1"/>
-                </a:solidFill>
-                <a:latin typeface="+mn-lt"/>
-                <a:ea typeface="+mn-ea"/>
-                <a:cs typeface="+mn-cs"/>
-              </a:defRPr>
-            </a:lvl1pPr>
-            <a:lvl2pPr marL="685800" indent="-228600" algn="l" defTabSz="914400" rtl="0" eaLnBrk="1" latinLnBrk="0" hangingPunct="1">
-              <a:lnSpc>
-                <a:spcPct val="90000"/>
-              </a:lnSpc>
-              <a:spcBef>
-                <a:spcPts val="500"/>
-              </a:spcBef>
-              <a:buFont typeface="Arial" panose="020B0604020202020204" pitchFamily="34" charset="0"/>
-              <a:buChar char="•"/>
-              <a:defRPr sz="2400" kern="1200">
-                <a:solidFill>
-                  <a:schemeClr val="tx1"/>
-                </a:solidFill>
-                <a:latin typeface="+mn-lt"/>
-                <a:ea typeface="+mn-ea"/>
-                <a:cs typeface="+mn-cs"/>
-              </a:defRPr>
-            </a:lvl2pPr>
-            <a:lvl3pPr marL="1143000" indent="-228600" algn="l" defTabSz="914400" rtl="0" eaLnBrk="1" latinLnBrk="0" hangingPunct="1">
-              <a:lnSpc>
-                <a:spcPct val="90000"/>
-              </a:lnSpc>
-              <a:spcBef>
-                <a:spcPts val="500"/>
-              </a:spcBef>
-              <a:buFont typeface="Arial" panose="020B0604020202020204" pitchFamily="34" charset="0"/>
-              <a:buChar char="•"/>
-              <a:defRPr sz="2000" kern="1200">
-                <a:solidFill>
-                  <a:schemeClr val="tx1"/>
-                </a:solidFill>
-                <a:latin typeface="+mn-lt"/>
-                <a:ea typeface="+mn-ea"/>
-                <a:cs typeface="+mn-cs"/>
-              </a:defRPr>
-            </a:lvl3pPr>
-            <a:lvl4pPr marL="1600200" indent="-228600" algn="l" defTabSz="914400" rtl="0" eaLnBrk="1" latinLnBrk="0" hangingPunct="1">
-              <a:lnSpc>
-                <a:spcPct val="90000"/>
-              </a:lnSpc>
-              <a:spcBef>
-                <a:spcPts val="500"/>
-              </a:spcBef>
-              <a:buFont typeface="Arial" panose="020B0604020202020204" pitchFamily="34" charset="0"/>
-              <a:buChar char="•"/>
-              <a:defRPr sz="1800" kern="1200">
-                <a:solidFill>
-                  <a:schemeClr val="tx1"/>
-                </a:solidFill>
-                <a:latin typeface="+mn-lt"/>
-                <a:ea typeface="+mn-ea"/>
-                <a:cs typeface="+mn-cs"/>
-              </a:defRPr>
-            </a:lvl4pPr>
-            <a:lvl5pPr marL="2057400" indent="-228600" algn="l" defTabSz="914400" rtl="0" eaLnBrk="1" latinLnBrk="0" hangingPunct="1">
-              <a:lnSpc>
-                <a:spcPct val="90000"/>
-              </a:lnSpc>
-              <a:spcBef>
-                <a:spcPts val="500"/>
-              </a:spcBef>
-              <a:buFont typeface="Arial" panose="020B0604020202020204" pitchFamily="34" charset="0"/>
-              <a:buChar char="•"/>
-              <a:defRPr sz="1800" kern="1200">
-                <a:solidFill>
-                  <a:schemeClr val="tx1"/>
-                </a:solidFill>
-                <a:latin typeface="+mn-lt"/>
-                <a:ea typeface="+mn-ea"/>
-                <a:cs typeface="+mn-cs"/>
-              </a:defRPr>
-            </a:lvl5pPr>
-            <a:lvl6pPr marL="2514600" indent="-228600" algn="l" defTabSz="914400" rtl="0" eaLnBrk="1" latinLnBrk="0" hangingPunct="1">
-              <a:lnSpc>
-                <a:spcPct val="90000"/>
-              </a:lnSpc>
-              <a:spcBef>
-                <a:spcPts val="500"/>
-              </a:spcBef>
-              <a:buFont typeface="Arial" panose="020B0604020202020204" pitchFamily="34" charset="0"/>
-              <a:buChar char="•"/>
-              <a:defRPr sz="1800" kern="1200">
-                <a:solidFill>
-                  <a:schemeClr val="tx1"/>
-                </a:solidFill>
-                <a:latin typeface="+mn-lt"/>
-                <a:ea typeface="+mn-ea"/>
-                <a:cs typeface="+mn-cs"/>
-              </a:defRPr>
-            </a:lvl6pPr>
-            <a:lvl7pPr marL="2971800" indent="-228600" algn="l" defTabSz="914400" rtl="0" eaLnBrk="1" latinLnBrk="0" hangingPunct="1">
-              <a:lnSpc>
-                <a:spcPct val="90000"/>
-              </a:lnSpc>
-              <a:spcBef>
-                <a:spcPts val="500"/>
-              </a:spcBef>
-              <a:buFont typeface="Arial" panose="020B0604020202020204" pitchFamily="34" charset="0"/>
-              <a:buChar char="•"/>
-              <a:defRPr sz="1800" kern="1200">
-                <a:solidFill>
-                  <a:schemeClr val="tx1"/>
-                </a:solidFill>
-                <a:latin typeface="+mn-lt"/>
-                <a:ea typeface="+mn-ea"/>
-                <a:cs typeface="+mn-cs"/>
-              </a:defRPr>
-            </a:lvl7pPr>
-            <a:lvl8pPr marL="3429000" indent="-228600" algn="l" defTabSz="914400" rtl="0" eaLnBrk="1" latinLnBrk="0" hangingPunct="1">
-              <a:lnSpc>
-                <a:spcPct val="90000"/>
-              </a:lnSpc>
-              <a:spcBef>
-                <a:spcPts val="500"/>
-              </a:spcBef>
-              <a:buFont typeface="Arial" panose="020B0604020202020204" pitchFamily="34" charset="0"/>
-              <a:buChar char="•"/>
-              <a:defRPr sz="1800" kern="1200">
-                <a:solidFill>
-                  <a:schemeClr val="tx1"/>
-                </a:solidFill>
-                <a:latin typeface="+mn-lt"/>
-                <a:ea typeface="+mn-ea"/>
-                <a:cs typeface="+mn-cs"/>
-              </a:defRPr>
-            </a:lvl8pPr>
-            <a:lvl9pPr marL="3886200" indent="-228600" algn="l" defTabSz="914400" rtl="0" eaLnBrk="1" latinLnBrk="0" hangingPunct="1">
-              <a:lnSpc>
-                <a:spcPct val="90000"/>
-              </a:lnSpc>
-              <a:spcBef>
-                <a:spcPts val="500"/>
-              </a:spcBef>
-              <a:buFont typeface="Arial" panose="020B0604020202020204" pitchFamily="34" charset="0"/>
-              <a:buChar char="•"/>
-              <a:defRPr sz="1800" kern="1200">
-                <a:solidFill>
-                  <a:schemeClr val="tx1"/>
-                </a:solidFill>
-                <a:latin typeface="+mn-lt"/>
-                <a:ea typeface="+mn-ea"/>
-                <a:cs typeface="+mn-cs"/>
-              </a:defRPr>
-            </a:lvl9pPr>
-          </a:lstStyle>
-          <a:p>
-            <a:pPr marL="0" marR="0" lvl="0" indent="0" algn="l" defTabSz="914400" rtl="0" eaLnBrk="1" fontAlgn="auto" latinLnBrk="0" hangingPunct="1">
-              <a:lnSpc>
-                <a:spcPct val="100000"/>
-              </a:lnSpc>
-              <a:spcBef>
-                <a:spcPts val="1000"/>
-              </a:spcBef>
-              <a:spcAft>
-                <a:spcPts val="0"/>
-              </a:spcAft>
-              <a:buClrTx/>
-              <a:buSzTx/>
-              <a:buFont typeface="Arial" panose="020B0604020202020204" pitchFamily="34" charset="0"/>
-              <a:buNone/>
-              <a:tabLst/>
-              <a:defRPr/>
-            </a:pPr>
-            <a:endParaRPr kumimoji="0" lang="en-US" sz="1100" b="0" i="0" u="none" strike="noStrike" kern="1200" cap="none" spc="0" normalizeH="0" baseline="0" noProof="0" dirty="0">
-              <a:ln>
-                <a:noFill/>
-              </a:ln>
-              <a:solidFill>
-                <a:prstClr val="black"/>
-              </a:solidFill>
-              <a:effectLst/>
-              <a:highlight>
-                <a:srgbClr val="FFFF00"/>
-              </a:highlight>
-              <a:uLnTx/>
-              <a:uFillTx/>
-              <a:latin typeface="Calibri" panose="020F0502020204030204"/>
-              <a:ea typeface="+mn-ea"/>
-              <a:cs typeface="+mn-cs"/>
-            </a:endParaRPr>
-          </a:p>
-        </p:txBody>
-      </p:sp>
-      <p:sp>
-        <p:nvSpPr>
-          <p:cNvPr id="50" name="Content Placeholder 2">
-            <a:extLst>
-              <a:ext uri="{FF2B5EF4-FFF2-40B4-BE49-F238E27FC236}">
-                <a16:creationId xmlns:a16="http://schemas.microsoft.com/office/drawing/2014/main" id="{897393DB-7396-E381-825C-5E441FE5FB47}"/>
-              </a:ext>
-            </a:extLst>
-          </p:cNvPr>
-          <p:cNvSpPr txBox="1">
-            <a:spLocks/>
-          </p:cNvSpPr>
-          <p:nvPr/>
-        </p:nvSpPr>
-        <p:spPr>
-          <a:xfrm>
-            <a:off x="10360536" y="1393972"/>
-            <a:ext cx="1313365" cy="251867"/>
-          </a:xfrm>
-          <a:prstGeom prst="rect">
-            <a:avLst/>
-          </a:prstGeom>
-        </p:spPr>
-        <p:txBody>
-          <a:bodyPr vert="horz" lIns="91440" tIns="45720" rIns="91440" bIns="45720" rtlCol="0">
-            <a:noAutofit/>
-          </a:bodyPr>
-          <a:lstStyle>
-            <a:lvl1pPr marL="228600" indent="-228600" algn="l" defTabSz="914400" rtl="0" eaLnBrk="1" latinLnBrk="0" hangingPunct="1">
-              <a:lnSpc>
-                <a:spcPct val="90000"/>
-              </a:lnSpc>
-              <a:spcBef>
-                <a:spcPts val="1000"/>
-              </a:spcBef>
-              <a:buFont typeface="Arial" panose="020B0604020202020204" pitchFamily="34" charset="0"/>
-              <a:buChar char="•"/>
-              <a:defRPr sz="2800" kern="1200">
-                <a:solidFill>
-                  <a:schemeClr val="tx1"/>
-                </a:solidFill>
-                <a:latin typeface="+mn-lt"/>
-                <a:ea typeface="+mn-ea"/>
-                <a:cs typeface="+mn-cs"/>
-              </a:defRPr>
-            </a:lvl1pPr>
-            <a:lvl2pPr marL="685800" indent="-228600" algn="l" defTabSz="914400" rtl="0" eaLnBrk="1" latinLnBrk="0" hangingPunct="1">
-              <a:lnSpc>
-                <a:spcPct val="90000"/>
-              </a:lnSpc>
-              <a:spcBef>
-                <a:spcPts val="500"/>
-              </a:spcBef>
-              <a:buFont typeface="Arial" panose="020B0604020202020204" pitchFamily="34" charset="0"/>
-              <a:buChar char="•"/>
-              <a:defRPr sz="2400" kern="1200">
-                <a:solidFill>
-                  <a:schemeClr val="tx1"/>
-                </a:solidFill>
-                <a:latin typeface="+mn-lt"/>
-                <a:ea typeface="+mn-ea"/>
-                <a:cs typeface="+mn-cs"/>
-              </a:defRPr>
-            </a:lvl2pPr>
-            <a:lvl3pPr marL="1143000" indent="-228600" algn="l" defTabSz="914400" rtl="0" eaLnBrk="1" latinLnBrk="0" hangingPunct="1">
-              <a:lnSpc>
-                <a:spcPct val="90000"/>
-              </a:lnSpc>
-              <a:spcBef>
-                <a:spcPts val="500"/>
-              </a:spcBef>
-              <a:buFont typeface="Arial" panose="020B0604020202020204" pitchFamily="34" charset="0"/>
-              <a:buChar char="•"/>
-              <a:defRPr sz="2000" kern="1200">
-                <a:solidFill>
-                  <a:schemeClr val="tx1"/>
-                </a:solidFill>
-                <a:latin typeface="+mn-lt"/>
-                <a:ea typeface="+mn-ea"/>
-                <a:cs typeface="+mn-cs"/>
-              </a:defRPr>
-            </a:lvl3pPr>
-            <a:lvl4pPr marL="1600200" indent="-228600" algn="l" defTabSz="914400" rtl="0" eaLnBrk="1" latinLnBrk="0" hangingPunct="1">
-              <a:lnSpc>
-                <a:spcPct val="90000"/>
-              </a:lnSpc>
-              <a:spcBef>
-                <a:spcPts val="500"/>
-              </a:spcBef>
-              <a:buFont typeface="Arial" panose="020B0604020202020204" pitchFamily="34" charset="0"/>
-              <a:buChar char="•"/>
-              <a:defRPr sz="1800" kern="1200">
-                <a:solidFill>
-                  <a:schemeClr val="tx1"/>
-                </a:solidFill>
-                <a:latin typeface="+mn-lt"/>
-                <a:ea typeface="+mn-ea"/>
-                <a:cs typeface="+mn-cs"/>
-              </a:defRPr>
-            </a:lvl4pPr>
-            <a:lvl5pPr marL="2057400" indent="-228600" algn="l" defTabSz="914400" rtl="0" eaLnBrk="1" latinLnBrk="0" hangingPunct="1">
-              <a:lnSpc>
-                <a:spcPct val="90000"/>
-              </a:lnSpc>
-              <a:spcBef>
-                <a:spcPts val="500"/>
-              </a:spcBef>
-              <a:buFont typeface="Arial" panose="020B0604020202020204" pitchFamily="34" charset="0"/>
-              <a:buChar char="•"/>
-              <a:defRPr sz="1800" kern="1200">
-                <a:solidFill>
-                  <a:schemeClr val="tx1"/>
-                </a:solidFill>
-                <a:latin typeface="+mn-lt"/>
-                <a:ea typeface="+mn-ea"/>
-                <a:cs typeface="+mn-cs"/>
-              </a:defRPr>
-            </a:lvl5pPr>
-            <a:lvl6pPr marL="2514600" indent="-228600" algn="l" defTabSz="914400" rtl="0" eaLnBrk="1" latinLnBrk="0" hangingPunct="1">
-              <a:lnSpc>
-                <a:spcPct val="90000"/>
-              </a:lnSpc>
-              <a:spcBef>
-                <a:spcPts val="500"/>
-              </a:spcBef>
-              <a:buFont typeface="Arial" panose="020B0604020202020204" pitchFamily="34" charset="0"/>
-              <a:buChar char="•"/>
-              <a:defRPr sz="1800" kern="1200">
-                <a:solidFill>
-                  <a:schemeClr val="tx1"/>
-                </a:solidFill>
-                <a:latin typeface="+mn-lt"/>
-                <a:ea typeface="+mn-ea"/>
-                <a:cs typeface="+mn-cs"/>
-              </a:defRPr>
-            </a:lvl6pPr>
-            <a:lvl7pPr marL="2971800" indent="-228600" algn="l" defTabSz="914400" rtl="0" eaLnBrk="1" latinLnBrk="0" hangingPunct="1">
-              <a:lnSpc>
-                <a:spcPct val="90000"/>
-              </a:lnSpc>
-              <a:spcBef>
-                <a:spcPts val="500"/>
-              </a:spcBef>
-              <a:buFont typeface="Arial" panose="020B0604020202020204" pitchFamily="34" charset="0"/>
-              <a:buChar char="•"/>
-              <a:defRPr sz="1800" kern="1200">
-                <a:solidFill>
-                  <a:schemeClr val="tx1"/>
-                </a:solidFill>
-                <a:latin typeface="+mn-lt"/>
-                <a:ea typeface="+mn-ea"/>
-                <a:cs typeface="+mn-cs"/>
-              </a:defRPr>
-            </a:lvl7pPr>
-            <a:lvl8pPr marL="3429000" indent="-228600" algn="l" defTabSz="914400" rtl="0" eaLnBrk="1" latinLnBrk="0" hangingPunct="1">
-              <a:lnSpc>
-                <a:spcPct val="90000"/>
-              </a:lnSpc>
-              <a:spcBef>
-                <a:spcPts val="500"/>
-              </a:spcBef>
-              <a:buFont typeface="Arial" panose="020B0604020202020204" pitchFamily="34" charset="0"/>
-              <a:buChar char="•"/>
-              <a:defRPr sz="1800" kern="1200">
-                <a:solidFill>
-                  <a:schemeClr val="tx1"/>
-                </a:solidFill>
-                <a:latin typeface="+mn-lt"/>
-                <a:ea typeface="+mn-ea"/>
-                <a:cs typeface="+mn-cs"/>
-              </a:defRPr>
-            </a:lvl8pPr>
-            <a:lvl9pPr marL="3886200" indent="-228600" algn="l" defTabSz="914400" rtl="0" eaLnBrk="1" latinLnBrk="0" hangingPunct="1">
-              <a:lnSpc>
-                <a:spcPct val="90000"/>
-              </a:lnSpc>
-              <a:spcBef>
-                <a:spcPts val="500"/>
-              </a:spcBef>
-              <a:buFont typeface="Arial" panose="020B0604020202020204" pitchFamily="34" charset="0"/>
-              <a:buChar char="•"/>
-              <a:defRPr sz="1800" kern="1200">
-                <a:solidFill>
-                  <a:schemeClr val="tx1"/>
-                </a:solidFill>
-                <a:latin typeface="+mn-lt"/>
-                <a:ea typeface="+mn-ea"/>
-                <a:cs typeface="+mn-cs"/>
-              </a:defRPr>
-            </a:lvl9pPr>
-          </a:lstStyle>
-          <a:p>
-            <a:pPr marL="0" marR="0" lvl="0" indent="0" algn="l" defTabSz="914400" rtl="0" eaLnBrk="1" fontAlgn="auto" latinLnBrk="0" hangingPunct="1">
-              <a:lnSpc>
-                <a:spcPct val="100000"/>
-              </a:lnSpc>
-              <a:spcBef>
-                <a:spcPts val="1000"/>
-              </a:spcBef>
-              <a:spcAft>
-                <a:spcPts val="0"/>
-              </a:spcAft>
-              <a:buClrTx/>
-              <a:buSzTx/>
-              <a:buFont typeface="Arial" panose="020B0604020202020204" pitchFamily="34" charset="0"/>
-              <a:buNone/>
-              <a:tabLst/>
-              <a:defRPr/>
-            </a:pPr>
-            <a:endParaRPr kumimoji="0" lang="en-US" sz="1100" b="0" i="0" u="none" strike="noStrike" kern="1200" cap="none" spc="0" normalizeH="0" baseline="0" noProof="0" dirty="0">
-              <a:ln>
-                <a:noFill/>
-              </a:ln>
-              <a:solidFill>
-                <a:prstClr val="black"/>
-              </a:solidFill>
-              <a:effectLst/>
-              <a:highlight>
-                <a:srgbClr val="FFFF00"/>
-              </a:highlight>
-              <a:uLnTx/>
-              <a:uFillTx/>
-              <a:latin typeface="Calibri" panose="020F0502020204030204"/>
-              <a:ea typeface="+mn-ea"/>
-              <a:cs typeface="+mn-cs"/>
-            </a:endParaRPr>
-          </a:p>
-        </p:txBody>
-      </p:sp>
-      <p:sp>
-        <p:nvSpPr>
-          <p:cNvPr id="51" name="Content Placeholder 2">
-            <a:extLst>
-              <a:ext uri="{FF2B5EF4-FFF2-40B4-BE49-F238E27FC236}">
-                <a16:creationId xmlns:a16="http://schemas.microsoft.com/office/drawing/2014/main" id="{CC1BE607-126E-7592-8B85-CB85B5A2433F}"/>
-              </a:ext>
-            </a:extLst>
-          </p:cNvPr>
-          <p:cNvSpPr txBox="1">
-            <a:spLocks/>
-          </p:cNvSpPr>
-          <p:nvPr/>
-        </p:nvSpPr>
-        <p:spPr>
-          <a:xfrm>
-            <a:off x="10375403" y="1791718"/>
-            <a:ext cx="1829165" cy="251867"/>
-          </a:xfrm>
-          <a:prstGeom prst="rect">
-            <a:avLst/>
-          </a:prstGeom>
-        </p:spPr>
-        <p:txBody>
-          <a:bodyPr vert="horz" lIns="91440" tIns="45720" rIns="91440" bIns="45720" rtlCol="0">
-            <a:noAutofit/>
-          </a:bodyPr>
-          <a:lstStyle>
-            <a:lvl1pPr marL="228600" indent="-228600" algn="l" defTabSz="914400" rtl="0" eaLnBrk="1" latinLnBrk="0" hangingPunct="1">
-              <a:lnSpc>
-                <a:spcPct val="90000"/>
-              </a:lnSpc>
-              <a:spcBef>
-                <a:spcPts val="1000"/>
-              </a:spcBef>
-              <a:buFont typeface="Arial" panose="020B0604020202020204" pitchFamily="34" charset="0"/>
-              <a:buChar char="•"/>
-              <a:defRPr sz="2800" kern="1200">
-                <a:solidFill>
-                  <a:schemeClr val="tx1"/>
-                </a:solidFill>
-                <a:latin typeface="+mn-lt"/>
-                <a:ea typeface="+mn-ea"/>
-                <a:cs typeface="+mn-cs"/>
-              </a:defRPr>
-            </a:lvl1pPr>
-            <a:lvl2pPr marL="685800" indent="-228600" algn="l" defTabSz="914400" rtl="0" eaLnBrk="1" latinLnBrk="0" hangingPunct="1">
-              <a:lnSpc>
-                <a:spcPct val="90000"/>
-              </a:lnSpc>
-              <a:spcBef>
-                <a:spcPts val="500"/>
-              </a:spcBef>
-              <a:buFont typeface="Arial" panose="020B0604020202020204" pitchFamily="34" charset="0"/>
-              <a:buChar char="•"/>
-              <a:defRPr sz="2400" kern="1200">
-                <a:solidFill>
-                  <a:schemeClr val="tx1"/>
-                </a:solidFill>
-                <a:latin typeface="+mn-lt"/>
-                <a:ea typeface="+mn-ea"/>
-                <a:cs typeface="+mn-cs"/>
-              </a:defRPr>
-            </a:lvl2pPr>
-            <a:lvl3pPr marL="1143000" indent="-228600" algn="l" defTabSz="914400" rtl="0" eaLnBrk="1" latinLnBrk="0" hangingPunct="1">
-              <a:lnSpc>
-                <a:spcPct val="90000"/>
-              </a:lnSpc>
-              <a:spcBef>
-                <a:spcPts val="500"/>
-              </a:spcBef>
-              <a:buFont typeface="Arial" panose="020B0604020202020204" pitchFamily="34" charset="0"/>
-              <a:buChar char="•"/>
-              <a:defRPr sz="2000" kern="1200">
-                <a:solidFill>
-                  <a:schemeClr val="tx1"/>
-                </a:solidFill>
-                <a:latin typeface="+mn-lt"/>
-                <a:ea typeface="+mn-ea"/>
-                <a:cs typeface="+mn-cs"/>
-              </a:defRPr>
-            </a:lvl3pPr>
-            <a:lvl4pPr marL="1600200" indent="-228600" algn="l" defTabSz="914400" rtl="0" eaLnBrk="1" latinLnBrk="0" hangingPunct="1">
-              <a:lnSpc>
-                <a:spcPct val="90000"/>
-              </a:lnSpc>
-              <a:spcBef>
-                <a:spcPts val="500"/>
-              </a:spcBef>
-              <a:buFont typeface="Arial" panose="020B0604020202020204" pitchFamily="34" charset="0"/>
-              <a:buChar char="•"/>
-              <a:defRPr sz="1800" kern="1200">
-                <a:solidFill>
-                  <a:schemeClr val="tx1"/>
-                </a:solidFill>
-                <a:latin typeface="+mn-lt"/>
-                <a:ea typeface="+mn-ea"/>
-                <a:cs typeface="+mn-cs"/>
-              </a:defRPr>
-            </a:lvl4pPr>
-            <a:lvl5pPr marL="2057400" indent="-228600" algn="l" defTabSz="914400" rtl="0" eaLnBrk="1" latinLnBrk="0" hangingPunct="1">
-              <a:lnSpc>
-                <a:spcPct val="90000"/>
-              </a:lnSpc>
-              <a:spcBef>
-                <a:spcPts val="500"/>
-              </a:spcBef>
-              <a:buFont typeface="Arial" panose="020B0604020202020204" pitchFamily="34" charset="0"/>
-              <a:buChar char="•"/>
-              <a:defRPr sz="1800" kern="1200">
-                <a:solidFill>
-                  <a:schemeClr val="tx1"/>
-                </a:solidFill>
-                <a:latin typeface="+mn-lt"/>
-                <a:ea typeface="+mn-ea"/>
-                <a:cs typeface="+mn-cs"/>
-              </a:defRPr>
-            </a:lvl5pPr>
-            <a:lvl6pPr marL="2514600" indent="-228600" algn="l" defTabSz="914400" rtl="0" eaLnBrk="1" latinLnBrk="0" hangingPunct="1">
-              <a:lnSpc>
-                <a:spcPct val="90000"/>
-              </a:lnSpc>
-              <a:spcBef>
-                <a:spcPts val="500"/>
-              </a:spcBef>
-              <a:buFont typeface="Arial" panose="020B0604020202020204" pitchFamily="34" charset="0"/>
-              <a:buChar char="•"/>
-              <a:defRPr sz="1800" kern="1200">
-                <a:solidFill>
-                  <a:schemeClr val="tx1"/>
-                </a:solidFill>
-                <a:latin typeface="+mn-lt"/>
-                <a:ea typeface="+mn-ea"/>
-                <a:cs typeface="+mn-cs"/>
-              </a:defRPr>
-            </a:lvl6pPr>
-            <a:lvl7pPr marL="2971800" indent="-228600" algn="l" defTabSz="914400" rtl="0" eaLnBrk="1" latinLnBrk="0" hangingPunct="1">
-              <a:lnSpc>
-                <a:spcPct val="90000"/>
-              </a:lnSpc>
-              <a:spcBef>
-                <a:spcPts val="500"/>
-              </a:spcBef>
-              <a:buFont typeface="Arial" panose="020B0604020202020204" pitchFamily="34" charset="0"/>
-              <a:buChar char="•"/>
-              <a:defRPr sz="1800" kern="1200">
-                <a:solidFill>
-                  <a:schemeClr val="tx1"/>
-                </a:solidFill>
-                <a:latin typeface="+mn-lt"/>
-                <a:ea typeface="+mn-ea"/>
-                <a:cs typeface="+mn-cs"/>
-              </a:defRPr>
-            </a:lvl7pPr>
-            <a:lvl8pPr marL="3429000" indent="-228600" algn="l" defTabSz="914400" rtl="0" eaLnBrk="1" latinLnBrk="0" hangingPunct="1">
-              <a:lnSpc>
-                <a:spcPct val="90000"/>
-              </a:lnSpc>
-              <a:spcBef>
-                <a:spcPts val="500"/>
-              </a:spcBef>
-              <a:buFont typeface="Arial" panose="020B0604020202020204" pitchFamily="34" charset="0"/>
-              <a:buChar char="•"/>
-              <a:defRPr sz="1800" kern="1200">
-                <a:solidFill>
-                  <a:schemeClr val="tx1"/>
-                </a:solidFill>
-                <a:latin typeface="+mn-lt"/>
-                <a:ea typeface="+mn-ea"/>
-                <a:cs typeface="+mn-cs"/>
-              </a:defRPr>
-            </a:lvl8pPr>
-            <a:lvl9pPr marL="3886200" indent="-228600" algn="l" defTabSz="914400" rtl="0" eaLnBrk="1" latinLnBrk="0" hangingPunct="1">
-              <a:lnSpc>
-                <a:spcPct val="90000"/>
-              </a:lnSpc>
-              <a:spcBef>
-                <a:spcPts val="500"/>
-              </a:spcBef>
-              <a:buFont typeface="Arial" panose="020B0604020202020204" pitchFamily="34" charset="0"/>
-              <a:buChar char="•"/>
-              <a:defRPr sz="1800" kern="1200">
-                <a:solidFill>
-                  <a:schemeClr val="tx1"/>
-                </a:solidFill>
-                <a:latin typeface="+mn-lt"/>
-                <a:ea typeface="+mn-ea"/>
-                <a:cs typeface="+mn-cs"/>
-              </a:defRPr>
-            </a:lvl9pPr>
-          </a:lstStyle>
-          <a:p>
-            <a:pPr marL="0" marR="0" lvl="0" indent="0" algn="l" defTabSz="914400" rtl="0" eaLnBrk="1" fontAlgn="auto" latinLnBrk="0" hangingPunct="1">
-              <a:lnSpc>
-                <a:spcPct val="100000"/>
-              </a:lnSpc>
-              <a:spcBef>
-                <a:spcPts val="1000"/>
-              </a:spcBef>
-              <a:spcAft>
-                <a:spcPts val="0"/>
-              </a:spcAft>
-              <a:buClrTx/>
-              <a:buSzTx/>
-              <a:buFont typeface="Arial" panose="020B0604020202020204" pitchFamily="34" charset="0"/>
-              <a:buNone/>
-              <a:tabLst/>
-              <a:defRPr/>
-            </a:pPr>
-            <a:endParaRPr kumimoji="0" lang="en-US" sz="1100" b="0" i="0" u="none" strike="noStrike" kern="1200" cap="none" spc="0" normalizeH="0" baseline="0" noProof="0" dirty="0">
-              <a:ln>
-                <a:noFill/>
-              </a:ln>
-              <a:solidFill>
-                <a:prstClr val="black"/>
-              </a:solidFill>
-              <a:effectLst/>
-              <a:highlight>
-                <a:srgbClr val="FFFF00"/>
-              </a:highlight>
-              <a:uLnTx/>
-              <a:uFillTx/>
-              <a:latin typeface="Calibri" panose="020F0502020204030204"/>
-              <a:ea typeface="+mn-ea"/>
-              <a:cs typeface="+mn-cs"/>
-            </a:endParaRPr>
-          </a:p>
-        </p:txBody>
-      </p:sp>
-      <p:sp>
-        <p:nvSpPr>
-          <p:cNvPr id="52" name="Content Placeholder 2">
-            <a:extLst>
-              <a:ext uri="{FF2B5EF4-FFF2-40B4-BE49-F238E27FC236}">
-                <a16:creationId xmlns:a16="http://schemas.microsoft.com/office/drawing/2014/main" id="{9146613C-4A56-CAA4-7C28-55FE52F8BF13}"/>
-              </a:ext>
-            </a:extLst>
-          </p:cNvPr>
-          <p:cNvSpPr txBox="1">
-            <a:spLocks/>
-          </p:cNvSpPr>
-          <p:nvPr/>
-        </p:nvSpPr>
-        <p:spPr>
-          <a:xfrm>
-            <a:off x="9379171" y="796970"/>
-            <a:ext cx="556124" cy="251867"/>
-          </a:xfrm>
-          <a:prstGeom prst="rect">
-            <a:avLst/>
-          </a:prstGeom>
-        </p:spPr>
-        <p:txBody>
-          <a:bodyPr vert="horz" lIns="91440" tIns="45720" rIns="91440" bIns="45720" rtlCol="0">
-            <a:noAutofit/>
-          </a:bodyPr>
-          <a:lstStyle>
-            <a:lvl1pPr marL="228600" indent="-228600" algn="l" defTabSz="914400" rtl="0" eaLnBrk="1" latinLnBrk="0" hangingPunct="1">
-              <a:lnSpc>
-                <a:spcPct val="90000"/>
-              </a:lnSpc>
-              <a:spcBef>
-                <a:spcPts val="1000"/>
-              </a:spcBef>
-              <a:buFont typeface="Arial" panose="020B0604020202020204" pitchFamily="34" charset="0"/>
-              <a:buChar char="•"/>
-              <a:defRPr sz="2800" kern="1200">
-                <a:solidFill>
-                  <a:schemeClr val="tx1"/>
-                </a:solidFill>
-                <a:latin typeface="+mn-lt"/>
-                <a:ea typeface="+mn-ea"/>
-                <a:cs typeface="+mn-cs"/>
-              </a:defRPr>
-            </a:lvl1pPr>
-            <a:lvl2pPr marL="685800" indent="-228600" algn="l" defTabSz="914400" rtl="0" eaLnBrk="1" latinLnBrk="0" hangingPunct="1">
-              <a:lnSpc>
-                <a:spcPct val="90000"/>
-              </a:lnSpc>
-              <a:spcBef>
-                <a:spcPts val="500"/>
-              </a:spcBef>
-              <a:buFont typeface="Arial" panose="020B0604020202020204" pitchFamily="34" charset="0"/>
-              <a:buChar char="•"/>
-              <a:defRPr sz="2400" kern="1200">
-                <a:solidFill>
-                  <a:schemeClr val="tx1"/>
-                </a:solidFill>
-                <a:latin typeface="+mn-lt"/>
-                <a:ea typeface="+mn-ea"/>
-                <a:cs typeface="+mn-cs"/>
-              </a:defRPr>
-            </a:lvl2pPr>
-            <a:lvl3pPr marL="1143000" indent="-228600" algn="l" defTabSz="914400" rtl="0" eaLnBrk="1" latinLnBrk="0" hangingPunct="1">
-              <a:lnSpc>
-                <a:spcPct val="90000"/>
-              </a:lnSpc>
-              <a:spcBef>
-                <a:spcPts val="500"/>
-              </a:spcBef>
-              <a:buFont typeface="Arial" panose="020B0604020202020204" pitchFamily="34" charset="0"/>
-              <a:buChar char="•"/>
-              <a:defRPr sz="2000" kern="1200">
-                <a:solidFill>
-                  <a:schemeClr val="tx1"/>
-                </a:solidFill>
-                <a:latin typeface="+mn-lt"/>
-                <a:ea typeface="+mn-ea"/>
-                <a:cs typeface="+mn-cs"/>
-              </a:defRPr>
-            </a:lvl3pPr>
-            <a:lvl4pPr marL="1600200" indent="-228600" algn="l" defTabSz="914400" rtl="0" eaLnBrk="1" latinLnBrk="0" hangingPunct="1">
-              <a:lnSpc>
-                <a:spcPct val="90000"/>
-              </a:lnSpc>
-              <a:spcBef>
-                <a:spcPts val="500"/>
-              </a:spcBef>
-              <a:buFont typeface="Arial" panose="020B0604020202020204" pitchFamily="34" charset="0"/>
-              <a:buChar char="•"/>
-              <a:defRPr sz="1800" kern="1200">
-                <a:solidFill>
-                  <a:schemeClr val="tx1"/>
-                </a:solidFill>
-                <a:latin typeface="+mn-lt"/>
-                <a:ea typeface="+mn-ea"/>
-                <a:cs typeface="+mn-cs"/>
-              </a:defRPr>
-            </a:lvl4pPr>
-            <a:lvl5pPr marL="2057400" indent="-228600" algn="l" defTabSz="914400" rtl="0" eaLnBrk="1" latinLnBrk="0" hangingPunct="1">
-              <a:lnSpc>
-                <a:spcPct val="90000"/>
-              </a:lnSpc>
-              <a:spcBef>
-                <a:spcPts val="500"/>
-              </a:spcBef>
-              <a:buFont typeface="Arial" panose="020B0604020202020204" pitchFamily="34" charset="0"/>
-              <a:buChar char="•"/>
-              <a:defRPr sz="1800" kern="1200">
-                <a:solidFill>
-                  <a:schemeClr val="tx1"/>
-                </a:solidFill>
-                <a:latin typeface="+mn-lt"/>
-                <a:ea typeface="+mn-ea"/>
-                <a:cs typeface="+mn-cs"/>
-              </a:defRPr>
-            </a:lvl5pPr>
-            <a:lvl6pPr marL="2514600" indent="-228600" algn="l" defTabSz="914400" rtl="0" eaLnBrk="1" latinLnBrk="0" hangingPunct="1">
-              <a:lnSpc>
-                <a:spcPct val="90000"/>
-              </a:lnSpc>
-              <a:spcBef>
-                <a:spcPts val="500"/>
-              </a:spcBef>
-              <a:buFont typeface="Arial" panose="020B0604020202020204" pitchFamily="34" charset="0"/>
-              <a:buChar char="•"/>
-              <a:defRPr sz="1800" kern="1200">
-                <a:solidFill>
-                  <a:schemeClr val="tx1"/>
-                </a:solidFill>
-                <a:latin typeface="+mn-lt"/>
-                <a:ea typeface="+mn-ea"/>
-                <a:cs typeface="+mn-cs"/>
-              </a:defRPr>
-            </a:lvl6pPr>
-            <a:lvl7pPr marL="2971800" indent="-228600" algn="l" defTabSz="914400" rtl="0" eaLnBrk="1" latinLnBrk="0" hangingPunct="1">
-              <a:lnSpc>
-                <a:spcPct val="90000"/>
-              </a:lnSpc>
-              <a:spcBef>
-                <a:spcPts val="500"/>
-              </a:spcBef>
-              <a:buFont typeface="Arial" panose="020B0604020202020204" pitchFamily="34" charset="0"/>
-              <a:buChar char="•"/>
-              <a:defRPr sz="1800" kern="1200">
-                <a:solidFill>
-                  <a:schemeClr val="tx1"/>
-                </a:solidFill>
-                <a:latin typeface="+mn-lt"/>
-                <a:ea typeface="+mn-ea"/>
-                <a:cs typeface="+mn-cs"/>
-              </a:defRPr>
-            </a:lvl7pPr>
-            <a:lvl8pPr marL="3429000" indent="-228600" algn="l" defTabSz="914400" rtl="0" eaLnBrk="1" latinLnBrk="0" hangingPunct="1">
-              <a:lnSpc>
-                <a:spcPct val="90000"/>
-              </a:lnSpc>
-              <a:spcBef>
-                <a:spcPts val="500"/>
-              </a:spcBef>
-              <a:buFont typeface="Arial" panose="020B0604020202020204" pitchFamily="34" charset="0"/>
-              <a:buChar char="•"/>
-              <a:defRPr sz="1800" kern="1200">
-                <a:solidFill>
-                  <a:schemeClr val="tx1"/>
-                </a:solidFill>
-                <a:latin typeface="+mn-lt"/>
-                <a:ea typeface="+mn-ea"/>
-                <a:cs typeface="+mn-cs"/>
-              </a:defRPr>
-            </a:lvl8pPr>
-            <a:lvl9pPr marL="3886200" indent="-228600" algn="l" defTabSz="914400" rtl="0" eaLnBrk="1" latinLnBrk="0" hangingPunct="1">
-              <a:lnSpc>
-                <a:spcPct val="90000"/>
-              </a:lnSpc>
-              <a:spcBef>
-                <a:spcPts val="500"/>
-              </a:spcBef>
-              <a:buFont typeface="Arial" panose="020B0604020202020204" pitchFamily="34" charset="0"/>
-              <a:buChar char="•"/>
-              <a:defRPr sz="1800" kern="1200">
-                <a:solidFill>
-                  <a:schemeClr val="tx1"/>
-                </a:solidFill>
-                <a:latin typeface="+mn-lt"/>
-                <a:ea typeface="+mn-ea"/>
-                <a:cs typeface="+mn-cs"/>
-              </a:defRPr>
-            </a:lvl9pPr>
-          </a:lstStyle>
-          <a:p>
-            <a:pPr marL="0" marR="0" lvl="0" indent="0" algn="l" defTabSz="914400" rtl="0" eaLnBrk="1" fontAlgn="auto" latinLnBrk="0" hangingPunct="1">
-              <a:lnSpc>
-                <a:spcPct val="100000"/>
-              </a:lnSpc>
-              <a:spcBef>
-                <a:spcPts val="1000"/>
-              </a:spcBef>
-              <a:spcAft>
-                <a:spcPts val="0"/>
-              </a:spcAft>
-              <a:buClrTx/>
-              <a:buSzTx/>
-              <a:buFont typeface="Arial" panose="020B0604020202020204" pitchFamily="34" charset="0"/>
-              <a:buNone/>
-              <a:tabLst/>
-              <a:defRPr/>
-            </a:pPr>
-            <a:endParaRPr kumimoji="0" lang="en-US" sz="1100" b="0" i="0" u="none" strike="noStrike" kern="1200" cap="none" spc="0" normalizeH="0" baseline="0" noProof="0" dirty="0">
-              <a:ln>
-                <a:noFill/>
-              </a:ln>
-              <a:solidFill>
-                <a:prstClr val="black"/>
-              </a:solidFill>
-              <a:effectLst/>
-              <a:highlight>
-                <a:srgbClr val="FFFF00"/>
-              </a:highlight>
-              <a:uLnTx/>
-              <a:uFillTx/>
-              <a:latin typeface="Calibri" panose="020F0502020204030204"/>
-              <a:ea typeface="+mn-ea"/>
-              <a:cs typeface="+mn-cs"/>
-            </a:endParaRPr>
-          </a:p>
-        </p:txBody>
-      </p:sp>
-      <p:sp>
-        <p:nvSpPr>
-          <p:cNvPr id="53" name="Content Placeholder 2">
-            <a:extLst>
-              <a:ext uri="{FF2B5EF4-FFF2-40B4-BE49-F238E27FC236}">
-                <a16:creationId xmlns:a16="http://schemas.microsoft.com/office/drawing/2014/main" id="{85C6D8F8-15C3-DAC0-77D1-A24D8082D348}"/>
-              </a:ext>
-            </a:extLst>
-          </p:cNvPr>
-          <p:cNvSpPr txBox="1">
-            <a:spLocks/>
-          </p:cNvSpPr>
-          <p:nvPr/>
-        </p:nvSpPr>
-        <p:spPr>
-          <a:xfrm>
-            <a:off x="7580960" y="905778"/>
-            <a:ext cx="556124" cy="251867"/>
-          </a:xfrm>
-          <a:prstGeom prst="rect">
-            <a:avLst/>
-          </a:prstGeom>
-        </p:spPr>
-        <p:txBody>
-          <a:bodyPr vert="horz" lIns="91440" tIns="45720" rIns="91440" bIns="45720" rtlCol="0">
-            <a:noAutofit/>
-          </a:bodyPr>
-          <a:lstStyle>
-            <a:lvl1pPr marL="228600" indent="-228600" algn="l" defTabSz="914400" rtl="0" eaLnBrk="1" latinLnBrk="0" hangingPunct="1">
-              <a:lnSpc>
-                <a:spcPct val="90000"/>
-              </a:lnSpc>
-              <a:spcBef>
-                <a:spcPts val="1000"/>
-              </a:spcBef>
-              <a:buFont typeface="Arial" panose="020B0604020202020204" pitchFamily="34" charset="0"/>
-              <a:buChar char="•"/>
-              <a:defRPr sz="2800" kern="1200">
-                <a:solidFill>
-                  <a:schemeClr val="tx1"/>
-                </a:solidFill>
-                <a:latin typeface="+mn-lt"/>
-                <a:ea typeface="+mn-ea"/>
-                <a:cs typeface="+mn-cs"/>
-              </a:defRPr>
-            </a:lvl1pPr>
-            <a:lvl2pPr marL="685800" indent="-228600" algn="l" defTabSz="914400" rtl="0" eaLnBrk="1" latinLnBrk="0" hangingPunct="1">
-              <a:lnSpc>
-                <a:spcPct val="90000"/>
-              </a:lnSpc>
-              <a:spcBef>
-                <a:spcPts val="500"/>
-              </a:spcBef>
-              <a:buFont typeface="Arial" panose="020B0604020202020204" pitchFamily="34" charset="0"/>
-              <a:buChar char="•"/>
-              <a:defRPr sz="2400" kern="1200">
-                <a:solidFill>
-                  <a:schemeClr val="tx1"/>
-                </a:solidFill>
-                <a:latin typeface="+mn-lt"/>
-                <a:ea typeface="+mn-ea"/>
-                <a:cs typeface="+mn-cs"/>
-              </a:defRPr>
-            </a:lvl2pPr>
-            <a:lvl3pPr marL="1143000" indent="-228600" algn="l" defTabSz="914400" rtl="0" eaLnBrk="1" latinLnBrk="0" hangingPunct="1">
-              <a:lnSpc>
-                <a:spcPct val="90000"/>
-              </a:lnSpc>
-              <a:spcBef>
-                <a:spcPts val="500"/>
-              </a:spcBef>
-              <a:buFont typeface="Arial" panose="020B0604020202020204" pitchFamily="34" charset="0"/>
-              <a:buChar char="•"/>
-              <a:defRPr sz="2000" kern="1200">
-                <a:solidFill>
-                  <a:schemeClr val="tx1"/>
-                </a:solidFill>
-                <a:latin typeface="+mn-lt"/>
-                <a:ea typeface="+mn-ea"/>
-                <a:cs typeface="+mn-cs"/>
-              </a:defRPr>
-            </a:lvl3pPr>
-            <a:lvl4pPr marL="1600200" indent="-228600" algn="l" defTabSz="914400" rtl="0" eaLnBrk="1" latinLnBrk="0" hangingPunct="1">
-              <a:lnSpc>
-                <a:spcPct val="90000"/>
-              </a:lnSpc>
-              <a:spcBef>
-                <a:spcPts val="500"/>
-              </a:spcBef>
-              <a:buFont typeface="Arial" panose="020B0604020202020204" pitchFamily="34" charset="0"/>
-              <a:buChar char="•"/>
-              <a:defRPr sz="1800" kern="1200">
-                <a:solidFill>
-                  <a:schemeClr val="tx1"/>
-                </a:solidFill>
-                <a:latin typeface="+mn-lt"/>
-                <a:ea typeface="+mn-ea"/>
-                <a:cs typeface="+mn-cs"/>
-              </a:defRPr>
-            </a:lvl4pPr>
-            <a:lvl5pPr marL="2057400" indent="-228600" algn="l" defTabSz="914400" rtl="0" eaLnBrk="1" latinLnBrk="0" hangingPunct="1">
-              <a:lnSpc>
-                <a:spcPct val="90000"/>
-              </a:lnSpc>
-              <a:spcBef>
-                <a:spcPts val="500"/>
-              </a:spcBef>
-              <a:buFont typeface="Arial" panose="020B0604020202020204" pitchFamily="34" charset="0"/>
-              <a:buChar char="•"/>
-              <a:defRPr sz="1800" kern="1200">
-                <a:solidFill>
-                  <a:schemeClr val="tx1"/>
-                </a:solidFill>
-                <a:latin typeface="+mn-lt"/>
-                <a:ea typeface="+mn-ea"/>
-                <a:cs typeface="+mn-cs"/>
-              </a:defRPr>
-            </a:lvl5pPr>
-            <a:lvl6pPr marL="2514600" indent="-228600" algn="l" defTabSz="914400" rtl="0" eaLnBrk="1" latinLnBrk="0" hangingPunct="1">
-              <a:lnSpc>
-                <a:spcPct val="90000"/>
-              </a:lnSpc>
-              <a:spcBef>
-                <a:spcPts val="500"/>
-              </a:spcBef>
-              <a:buFont typeface="Arial" panose="020B0604020202020204" pitchFamily="34" charset="0"/>
-              <a:buChar char="•"/>
-              <a:defRPr sz="1800" kern="1200">
-                <a:solidFill>
-                  <a:schemeClr val="tx1"/>
-                </a:solidFill>
-                <a:latin typeface="+mn-lt"/>
-                <a:ea typeface="+mn-ea"/>
-                <a:cs typeface="+mn-cs"/>
-              </a:defRPr>
-            </a:lvl6pPr>
-            <a:lvl7pPr marL="2971800" indent="-228600" algn="l" defTabSz="914400" rtl="0" eaLnBrk="1" latinLnBrk="0" hangingPunct="1">
-              <a:lnSpc>
-                <a:spcPct val="90000"/>
-              </a:lnSpc>
-              <a:spcBef>
-                <a:spcPts val="500"/>
-              </a:spcBef>
-              <a:buFont typeface="Arial" panose="020B0604020202020204" pitchFamily="34" charset="0"/>
-              <a:buChar char="•"/>
-              <a:defRPr sz="1800" kern="1200">
-                <a:solidFill>
-                  <a:schemeClr val="tx1"/>
-                </a:solidFill>
-                <a:latin typeface="+mn-lt"/>
-                <a:ea typeface="+mn-ea"/>
-                <a:cs typeface="+mn-cs"/>
-              </a:defRPr>
-            </a:lvl7pPr>
-            <a:lvl8pPr marL="3429000" indent="-228600" algn="l" defTabSz="914400" rtl="0" eaLnBrk="1" latinLnBrk="0" hangingPunct="1">
-              <a:lnSpc>
-                <a:spcPct val="90000"/>
-              </a:lnSpc>
-              <a:spcBef>
-                <a:spcPts val="500"/>
-              </a:spcBef>
-              <a:buFont typeface="Arial" panose="020B0604020202020204" pitchFamily="34" charset="0"/>
-              <a:buChar char="•"/>
-              <a:defRPr sz="1800" kern="1200">
-                <a:solidFill>
-                  <a:schemeClr val="tx1"/>
-                </a:solidFill>
-                <a:latin typeface="+mn-lt"/>
-                <a:ea typeface="+mn-ea"/>
-                <a:cs typeface="+mn-cs"/>
-              </a:defRPr>
-            </a:lvl8pPr>
-            <a:lvl9pPr marL="3886200" indent="-228600" algn="l" defTabSz="914400" rtl="0" eaLnBrk="1" latinLnBrk="0" hangingPunct="1">
-              <a:lnSpc>
-                <a:spcPct val="90000"/>
-              </a:lnSpc>
-              <a:spcBef>
-                <a:spcPts val="500"/>
-              </a:spcBef>
-              <a:buFont typeface="Arial" panose="020B0604020202020204" pitchFamily="34" charset="0"/>
-              <a:buChar char="•"/>
-              <a:defRPr sz="1800" kern="1200">
-                <a:solidFill>
-                  <a:schemeClr val="tx1"/>
-                </a:solidFill>
-                <a:latin typeface="+mn-lt"/>
-                <a:ea typeface="+mn-ea"/>
-                <a:cs typeface="+mn-cs"/>
-              </a:defRPr>
-            </a:lvl9pPr>
-          </a:lstStyle>
-          <a:p>
-            <a:pPr marL="0" marR="0" lvl="0" indent="0" algn="l" defTabSz="914400" rtl="0" eaLnBrk="1" fontAlgn="auto" latinLnBrk="0" hangingPunct="1">
-              <a:lnSpc>
-                <a:spcPct val="100000"/>
-              </a:lnSpc>
-              <a:spcBef>
-                <a:spcPts val="1000"/>
-              </a:spcBef>
-              <a:spcAft>
-                <a:spcPts val="0"/>
-              </a:spcAft>
-              <a:buClrTx/>
-              <a:buSzTx/>
-              <a:buFont typeface="Arial" panose="020B0604020202020204" pitchFamily="34" charset="0"/>
-              <a:buNone/>
-              <a:tabLst/>
-              <a:defRPr/>
-            </a:pPr>
-            <a:endParaRPr kumimoji="0" lang="en-US" sz="1100" b="0" i="0" u="none" strike="noStrike" kern="1200" cap="none" spc="0" normalizeH="0" baseline="0" noProof="0" dirty="0">
-              <a:ln>
-                <a:noFill/>
-              </a:ln>
-              <a:solidFill>
-                <a:prstClr val="black"/>
-              </a:solidFill>
-              <a:effectLst/>
-              <a:highlight>
-                <a:srgbClr val="FFFF00"/>
-              </a:highlight>
-              <a:uLnTx/>
-              <a:uFillTx/>
-              <a:latin typeface="Calibri" panose="020F0502020204030204"/>
-              <a:ea typeface="+mn-ea"/>
-              <a:cs typeface="+mn-cs"/>
-            </a:endParaRPr>
-          </a:p>
-        </p:txBody>
-      </p:sp>
-      <p:sp>
-        <p:nvSpPr>
-          <p:cNvPr id="54" name="Content Placeholder 2">
-            <a:extLst>
-              <a:ext uri="{FF2B5EF4-FFF2-40B4-BE49-F238E27FC236}">
-                <a16:creationId xmlns:a16="http://schemas.microsoft.com/office/drawing/2014/main" id="{58960BED-4C88-4AA4-8F7B-F67A2FC46A15}"/>
-              </a:ext>
-            </a:extLst>
-          </p:cNvPr>
-          <p:cNvSpPr txBox="1">
-            <a:spLocks/>
-          </p:cNvSpPr>
-          <p:nvPr/>
-        </p:nvSpPr>
-        <p:spPr>
-          <a:xfrm>
-            <a:off x="4649501" y="3331017"/>
-            <a:ext cx="2132356" cy="251867"/>
-          </a:xfrm>
-          <a:prstGeom prst="rect">
-            <a:avLst/>
-          </a:prstGeom>
-        </p:spPr>
-        <p:txBody>
-          <a:bodyPr vert="horz" lIns="91440" tIns="45720" rIns="91440" bIns="45720" rtlCol="0">
-            <a:noAutofit/>
-          </a:bodyPr>
-          <a:lstStyle>
-            <a:lvl1pPr marL="228600" indent="-228600" algn="l" defTabSz="914400" rtl="0" eaLnBrk="1" latinLnBrk="0" hangingPunct="1">
-              <a:lnSpc>
-                <a:spcPct val="90000"/>
-              </a:lnSpc>
-              <a:spcBef>
-                <a:spcPts val="1000"/>
-              </a:spcBef>
-              <a:buFont typeface="Arial" panose="020B0604020202020204" pitchFamily="34" charset="0"/>
-              <a:buChar char="•"/>
-              <a:defRPr sz="2800" kern="1200">
-                <a:solidFill>
-                  <a:schemeClr val="tx1"/>
-                </a:solidFill>
-                <a:latin typeface="+mn-lt"/>
-                <a:ea typeface="+mn-ea"/>
-                <a:cs typeface="+mn-cs"/>
-              </a:defRPr>
-            </a:lvl1pPr>
-            <a:lvl2pPr marL="685800" indent="-228600" algn="l" defTabSz="914400" rtl="0" eaLnBrk="1" latinLnBrk="0" hangingPunct="1">
-              <a:lnSpc>
-                <a:spcPct val="90000"/>
-              </a:lnSpc>
-              <a:spcBef>
-                <a:spcPts val="500"/>
-              </a:spcBef>
-              <a:buFont typeface="Arial" panose="020B0604020202020204" pitchFamily="34" charset="0"/>
-              <a:buChar char="•"/>
-              <a:defRPr sz="2400" kern="1200">
-                <a:solidFill>
-                  <a:schemeClr val="tx1"/>
-                </a:solidFill>
-                <a:latin typeface="+mn-lt"/>
-                <a:ea typeface="+mn-ea"/>
-                <a:cs typeface="+mn-cs"/>
-              </a:defRPr>
-            </a:lvl2pPr>
-            <a:lvl3pPr marL="1143000" indent="-228600" algn="l" defTabSz="914400" rtl="0" eaLnBrk="1" latinLnBrk="0" hangingPunct="1">
-              <a:lnSpc>
-                <a:spcPct val="90000"/>
-              </a:lnSpc>
-              <a:spcBef>
-                <a:spcPts val="500"/>
-              </a:spcBef>
-              <a:buFont typeface="Arial" panose="020B0604020202020204" pitchFamily="34" charset="0"/>
-              <a:buChar char="•"/>
-              <a:defRPr sz="2000" kern="1200">
-                <a:solidFill>
-                  <a:schemeClr val="tx1"/>
-                </a:solidFill>
-                <a:latin typeface="+mn-lt"/>
-                <a:ea typeface="+mn-ea"/>
-                <a:cs typeface="+mn-cs"/>
-              </a:defRPr>
-            </a:lvl3pPr>
-            <a:lvl4pPr marL="1600200" indent="-228600" algn="l" defTabSz="914400" rtl="0" eaLnBrk="1" latinLnBrk="0" hangingPunct="1">
-              <a:lnSpc>
-                <a:spcPct val="90000"/>
-              </a:lnSpc>
-              <a:spcBef>
-                <a:spcPts val="500"/>
-              </a:spcBef>
-              <a:buFont typeface="Arial" panose="020B0604020202020204" pitchFamily="34" charset="0"/>
-              <a:buChar char="•"/>
-              <a:defRPr sz="1800" kern="1200">
-                <a:solidFill>
-                  <a:schemeClr val="tx1"/>
-                </a:solidFill>
-                <a:latin typeface="+mn-lt"/>
-                <a:ea typeface="+mn-ea"/>
-                <a:cs typeface="+mn-cs"/>
-              </a:defRPr>
-            </a:lvl4pPr>
-            <a:lvl5pPr marL="2057400" indent="-228600" algn="l" defTabSz="914400" rtl="0" eaLnBrk="1" latinLnBrk="0" hangingPunct="1">
-              <a:lnSpc>
-                <a:spcPct val="90000"/>
-              </a:lnSpc>
-              <a:spcBef>
-                <a:spcPts val="500"/>
-              </a:spcBef>
-              <a:buFont typeface="Arial" panose="020B0604020202020204" pitchFamily="34" charset="0"/>
-              <a:buChar char="•"/>
-              <a:defRPr sz="1800" kern="1200">
-                <a:solidFill>
-                  <a:schemeClr val="tx1"/>
-                </a:solidFill>
-                <a:latin typeface="+mn-lt"/>
-                <a:ea typeface="+mn-ea"/>
-                <a:cs typeface="+mn-cs"/>
-              </a:defRPr>
-            </a:lvl5pPr>
-            <a:lvl6pPr marL="2514600" indent="-228600" algn="l" defTabSz="914400" rtl="0" eaLnBrk="1" latinLnBrk="0" hangingPunct="1">
-              <a:lnSpc>
-                <a:spcPct val="90000"/>
-              </a:lnSpc>
-              <a:spcBef>
-                <a:spcPts val="500"/>
-              </a:spcBef>
-              <a:buFont typeface="Arial" panose="020B0604020202020204" pitchFamily="34" charset="0"/>
-              <a:buChar char="•"/>
-              <a:defRPr sz="1800" kern="1200">
-                <a:solidFill>
-                  <a:schemeClr val="tx1"/>
-                </a:solidFill>
-                <a:latin typeface="+mn-lt"/>
-                <a:ea typeface="+mn-ea"/>
-                <a:cs typeface="+mn-cs"/>
-              </a:defRPr>
-            </a:lvl6pPr>
-            <a:lvl7pPr marL="2971800" indent="-228600" algn="l" defTabSz="914400" rtl="0" eaLnBrk="1" latinLnBrk="0" hangingPunct="1">
-              <a:lnSpc>
-                <a:spcPct val="90000"/>
-              </a:lnSpc>
-              <a:spcBef>
-                <a:spcPts val="500"/>
-              </a:spcBef>
-              <a:buFont typeface="Arial" panose="020B0604020202020204" pitchFamily="34" charset="0"/>
-              <a:buChar char="•"/>
-              <a:defRPr sz="1800" kern="1200">
-                <a:solidFill>
-                  <a:schemeClr val="tx1"/>
-                </a:solidFill>
-                <a:latin typeface="+mn-lt"/>
-                <a:ea typeface="+mn-ea"/>
-                <a:cs typeface="+mn-cs"/>
-              </a:defRPr>
-            </a:lvl7pPr>
-            <a:lvl8pPr marL="3429000" indent="-228600" algn="l" defTabSz="914400" rtl="0" eaLnBrk="1" latinLnBrk="0" hangingPunct="1">
-              <a:lnSpc>
-                <a:spcPct val="90000"/>
-              </a:lnSpc>
-              <a:spcBef>
-                <a:spcPts val="500"/>
-              </a:spcBef>
-              <a:buFont typeface="Arial" panose="020B0604020202020204" pitchFamily="34" charset="0"/>
-              <a:buChar char="•"/>
-              <a:defRPr sz="1800" kern="1200">
-                <a:solidFill>
-                  <a:schemeClr val="tx1"/>
-                </a:solidFill>
-                <a:latin typeface="+mn-lt"/>
-                <a:ea typeface="+mn-ea"/>
-                <a:cs typeface="+mn-cs"/>
-              </a:defRPr>
-            </a:lvl8pPr>
-            <a:lvl9pPr marL="3886200" indent="-228600" algn="l" defTabSz="914400" rtl="0" eaLnBrk="1" latinLnBrk="0" hangingPunct="1">
-              <a:lnSpc>
-                <a:spcPct val="90000"/>
-              </a:lnSpc>
-              <a:spcBef>
-                <a:spcPts val="500"/>
-              </a:spcBef>
-              <a:buFont typeface="Arial" panose="020B0604020202020204" pitchFamily="34" charset="0"/>
-              <a:buChar char="•"/>
-              <a:defRPr sz="1800" kern="1200">
-                <a:solidFill>
-                  <a:schemeClr val="tx1"/>
-                </a:solidFill>
-                <a:latin typeface="+mn-lt"/>
-                <a:ea typeface="+mn-ea"/>
-                <a:cs typeface="+mn-cs"/>
-              </a:defRPr>
-            </a:lvl9pPr>
-          </a:lstStyle>
-          <a:p>
-            <a:pPr marL="0" marR="0" lvl="0" indent="0" algn="l" defTabSz="914400" rtl="0" eaLnBrk="1" fontAlgn="auto" latinLnBrk="0" hangingPunct="1">
-              <a:lnSpc>
-                <a:spcPct val="100000"/>
-              </a:lnSpc>
-              <a:spcBef>
-                <a:spcPts val="1000"/>
-              </a:spcBef>
-              <a:spcAft>
-                <a:spcPts val="0"/>
-              </a:spcAft>
-              <a:buClrTx/>
-              <a:buSzTx/>
-              <a:buFont typeface="Arial" panose="020B0604020202020204" pitchFamily="34" charset="0"/>
-              <a:buNone/>
-              <a:tabLst/>
-              <a:defRPr/>
-            </a:pPr>
-            <a:endParaRPr kumimoji="0" lang="en-US" sz="1100" b="0" i="0" u="none" strike="noStrike" kern="1200" cap="none" spc="0" normalizeH="0" baseline="0" noProof="0" dirty="0">
-              <a:ln>
-                <a:noFill/>
-              </a:ln>
-              <a:solidFill>
-                <a:prstClr val="black"/>
-              </a:solidFill>
-              <a:effectLst/>
-              <a:highlight>
-                <a:srgbClr val="FFFF00"/>
-              </a:highlight>
-              <a:uLnTx/>
-              <a:uFillTx/>
-              <a:latin typeface="Calibri" panose="020F0502020204030204"/>
-              <a:ea typeface="+mn-ea"/>
-              <a:cs typeface="+mn-cs"/>
-            </a:endParaRPr>
-          </a:p>
-        </p:txBody>
-      </p:sp>
-      <p:sp>
-        <p:nvSpPr>
-          <p:cNvPr id="55" name="Content Placeholder 2">
-            <a:extLst>
-              <a:ext uri="{FF2B5EF4-FFF2-40B4-BE49-F238E27FC236}">
-                <a16:creationId xmlns:a16="http://schemas.microsoft.com/office/drawing/2014/main" id="{BB66856B-A197-3A8D-B103-13A109F2B826}"/>
-              </a:ext>
-            </a:extLst>
-          </p:cNvPr>
-          <p:cNvSpPr txBox="1">
-            <a:spLocks/>
-          </p:cNvSpPr>
-          <p:nvPr/>
-        </p:nvSpPr>
-        <p:spPr>
-          <a:xfrm>
-            <a:off x="8876696" y="6144674"/>
-            <a:ext cx="1760824" cy="251867"/>
-          </a:xfrm>
-          <a:prstGeom prst="rect">
-            <a:avLst/>
-          </a:prstGeom>
-        </p:spPr>
-        <p:txBody>
-          <a:bodyPr vert="horz" lIns="91440" tIns="45720" rIns="91440" bIns="45720" rtlCol="0">
-            <a:noAutofit/>
-          </a:bodyPr>
-          <a:lstStyle>
-            <a:lvl1pPr marL="228600" indent="-228600" algn="l" defTabSz="914400" rtl="0" eaLnBrk="1" latinLnBrk="0" hangingPunct="1">
-              <a:lnSpc>
-                <a:spcPct val="90000"/>
-              </a:lnSpc>
-              <a:spcBef>
-                <a:spcPts val="1000"/>
-              </a:spcBef>
-              <a:buFont typeface="Arial" panose="020B0604020202020204" pitchFamily="34" charset="0"/>
-              <a:buChar char="•"/>
-              <a:defRPr sz="2800" kern="1200">
-                <a:solidFill>
-                  <a:schemeClr val="tx1"/>
-                </a:solidFill>
-                <a:latin typeface="+mn-lt"/>
-                <a:ea typeface="+mn-ea"/>
-                <a:cs typeface="+mn-cs"/>
-              </a:defRPr>
-            </a:lvl1pPr>
-            <a:lvl2pPr marL="685800" indent="-228600" algn="l" defTabSz="914400" rtl="0" eaLnBrk="1" latinLnBrk="0" hangingPunct="1">
-              <a:lnSpc>
-                <a:spcPct val="90000"/>
-              </a:lnSpc>
-              <a:spcBef>
-                <a:spcPts val="500"/>
-              </a:spcBef>
-              <a:buFont typeface="Arial" panose="020B0604020202020204" pitchFamily="34" charset="0"/>
-              <a:buChar char="•"/>
-              <a:defRPr sz="2400" kern="1200">
-                <a:solidFill>
-                  <a:schemeClr val="tx1"/>
-                </a:solidFill>
-                <a:latin typeface="+mn-lt"/>
-                <a:ea typeface="+mn-ea"/>
-                <a:cs typeface="+mn-cs"/>
-              </a:defRPr>
-            </a:lvl2pPr>
-            <a:lvl3pPr marL="1143000" indent="-228600" algn="l" defTabSz="914400" rtl="0" eaLnBrk="1" latinLnBrk="0" hangingPunct="1">
-              <a:lnSpc>
-                <a:spcPct val="90000"/>
-              </a:lnSpc>
-              <a:spcBef>
-                <a:spcPts val="500"/>
-              </a:spcBef>
-              <a:buFont typeface="Arial" panose="020B0604020202020204" pitchFamily="34" charset="0"/>
-              <a:buChar char="•"/>
-              <a:defRPr sz="2000" kern="1200">
-                <a:solidFill>
-                  <a:schemeClr val="tx1"/>
-                </a:solidFill>
-                <a:latin typeface="+mn-lt"/>
-                <a:ea typeface="+mn-ea"/>
-                <a:cs typeface="+mn-cs"/>
-              </a:defRPr>
-            </a:lvl3pPr>
-            <a:lvl4pPr marL="1600200" indent="-228600" algn="l" defTabSz="914400" rtl="0" eaLnBrk="1" latinLnBrk="0" hangingPunct="1">
-              <a:lnSpc>
-                <a:spcPct val="90000"/>
-              </a:lnSpc>
-              <a:spcBef>
-                <a:spcPts val="500"/>
-              </a:spcBef>
-              <a:buFont typeface="Arial" panose="020B0604020202020204" pitchFamily="34" charset="0"/>
-              <a:buChar char="•"/>
-              <a:defRPr sz="1800" kern="1200">
-                <a:solidFill>
-                  <a:schemeClr val="tx1"/>
-                </a:solidFill>
-                <a:latin typeface="+mn-lt"/>
-                <a:ea typeface="+mn-ea"/>
-                <a:cs typeface="+mn-cs"/>
-              </a:defRPr>
-            </a:lvl4pPr>
-            <a:lvl5pPr marL="2057400" indent="-228600" algn="l" defTabSz="914400" rtl="0" eaLnBrk="1" latinLnBrk="0" hangingPunct="1">
-              <a:lnSpc>
-                <a:spcPct val="90000"/>
-              </a:lnSpc>
-              <a:spcBef>
-                <a:spcPts val="500"/>
-              </a:spcBef>
-              <a:buFont typeface="Arial" panose="020B0604020202020204" pitchFamily="34" charset="0"/>
-              <a:buChar char="•"/>
-              <a:defRPr sz="1800" kern="1200">
-                <a:solidFill>
-                  <a:schemeClr val="tx1"/>
-                </a:solidFill>
-                <a:latin typeface="+mn-lt"/>
-                <a:ea typeface="+mn-ea"/>
-                <a:cs typeface="+mn-cs"/>
-              </a:defRPr>
-            </a:lvl5pPr>
-            <a:lvl6pPr marL="2514600" indent="-228600" algn="l" defTabSz="914400" rtl="0" eaLnBrk="1" latinLnBrk="0" hangingPunct="1">
-              <a:lnSpc>
-                <a:spcPct val="90000"/>
-              </a:lnSpc>
-              <a:spcBef>
-                <a:spcPts val="500"/>
-              </a:spcBef>
-              <a:buFont typeface="Arial" panose="020B0604020202020204" pitchFamily="34" charset="0"/>
-              <a:buChar char="•"/>
-              <a:defRPr sz="1800" kern="1200">
-                <a:solidFill>
-                  <a:schemeClr val="tx1"/>
-                </a:solidFill>
-                <a:latin typeface="+mn-lt"/>
-                <a:ea typeface="+mn-ea"/>
-                <a:cs typeface="+mn-cs"/>
-              </a:defRPr>
-            </a:lvl6pPr>
-            <a:lvl7pPr marL="2971800" indent="-228600" algn="l" defTabSz="914400" rtl="0" eaLnBrk="1" latinLnBrk="0" hangingPunct="1">
-              <a:lnSpc>
-                <a:spcPct val="90000"/>
-              </a:lnSpc>
-              <a:spcBef>
-                <a:spcPts val="500"/>
-              </a:spcBef>
-              <a:buFont typeface="Arial" panose="020B0604020202020204" pitchFamily="34" charset="0"/>
-              <a:buChar char="•"/>
-              <a:defRPr sz="1800" kern="1200">
-                <a:solidFill>
-                  <a:schemeClr val="tx1"/>
-                </a:solidFill>
-                <a:latin typeface="+mn-lt"/>
-                <a:ea typeface="+mn-ea"/>
-                <a:cs typeface="+mn-cs"/>
-              </a:defRPr>
-            </a:lvl7pPr>
-            <a:lvl8pPr marL="3429000" indent="-228600" algn="l" defTabSz="914400" rtl="0" eaLnBrk="1" latinLnBrk="0" hangingPunct="1">
-              <a:lnSpc>
-                <a:spcPct val="90000"/>
-              </a:lnSpc>
-              <a:spcBef>
-                <a:spcPts val="500"/>
-              </a:spcBef>
-              <a:buFont typeface="Arial" panose="020B0604020202020204" pitchFamily="34" charset="0"/>
-              <a:buChar char="•"/>
-              <a:defRPr sz="1800" kern="1200">
-                <a:solidFill>
-                  <a:schemeClr val="tx1"/>
-                </a:solidFill>
-                <a:latin typeface="+mn-lt"/>
-                <a:ea typeface="+mn-ea"/>
-                <a:cs typeface="+mn-cs"/>
-              </a:defRPr>
-            </a:lvl8pPr>
-            <a:lvl9pPr marL="3886200" indent="-228600" algn="l" defTabSz="914400" rtl="0" eaLnBrk="1" latinLnBrk="0" hangingPunct="1">
-              <a:lnSpc>
-                <a:spcPct val="90000"/>
-              </a:lnSpc>
-              <a:spcBef>
-                <a:spcPts val="500"/>
-              </a:spcBef>
-              <a:buFont typeface="Arial" panose="020B0604020202020204" pitchFamily="34" charset="0"/>
-              <a:buChar char="•"/>
-              <a:defRPr sz="1800" kern="1200">
-                <a:solidFill>
-                  <a:schemeClr val="tx1"/>
-                </a:solidFill>
-                <a:latin typeface="+mn-lt"/>
-                <a:ea typeface="+mn-ea"/>
-                <a:cs typeface="+mn-cs"/>
-              </a:defRPr>
-            </a:lvl9pPr>
-          </a:lstStyle>
-          <a:p>
-            <a:pPr marL="0" marR="0" lvl="0" indent="0" algn="l" defTabSz="914400" rtl="0" eaLnBrk="1" fontAlgn="auto" latinLnBrk="0" hangingPunct="1">
-              <a:lnSpc>
-                <a:spcPct val="100000"/>
-              </a:lnSpc>
-              <a:spcBef>
-                <a:spcPts val="1000"/>
-              </a:spcBef>
-              <a:spcAft>
-                <a:spcPts val="0"/>
-              </a:spcAft>
-              <a:buClrTx/>
-              <a:buSzTx/>
-              <a:buFont typeface="Arial" panose="020B0604020202020204" pitchFamily="34" charset="0"/>
-              <a:buNone/>
-              <a:tabLst/>
-              <a:defRPr/>
-            </a:pPr>
-            <a:endParaRPr kumimoji="0" lang="en-US" sz="1100" b="0" i="0" u="none" strike="noStrike" kern="1200" cap="none" spc="0" normalizeH="0" baseline="0" noProof="0" dirty="0">
-              <a:ln>
-                <a:noFill/>
-              </a:ln>
-              <a:solidFill>
-                <a:prstClr val="black"/>
-              </a:solidFill>
-              <a:effectLst/>
-              <a:highlight>
-                <a:srgbClr val="FFFF00"/>
-              </a:highlight>
-              <a:uLnTx/>
-              <a:uFillTx/>
-              <a:latin typeface="Calibri" panose="020F0502020204030204"/>
-              <a:ea typeface="+mn-ea"/>
-              <a:cs typeface="+mn-cs"/>
-            </a:endParaRPr>
-          </a:p>
-        </p:txBody>
-      </p:sp>
-      <p:sp>
-        <p:nvSpPr>
-          <p:cNvPr id="56" name="Content Placeholder 2">
-            <a:extLst>
-              <a:ext uri="{FF2B5EF4-FFF2-40B4-BE49-F238E27FC236}">
-                <a16:creationId xmlns:a16="http://schemas.microsoft.com/office/drawing/2014/main" id="{6B37ED8F-95C2-063E-D72D-A64EF03CBD94}"/>
-              </a:ext>
-            </a:extLst>
-          </p:cNvPr>
-          <p:cNvSpPr txBox="1">
-            <a:spLocks/>
-          </p:cNvSpPr>
-          <p:nvPr/>
-        </p:nvSpPr>
-        <p:spPr>
-          <a:xfrm>
-            <a:off x="1546282" y="4876127"/>
-            <a:ext cx="1758271" cy="251867"/>
-          </a:xfrm>
-          <a:prstGeom prst="rect">
-            <a:avLst/>
-          </a:prstGeom>
-        </p:spPr>
-        <p:txBody>
-          <a:bodyPr vert="horz" lIns="91440" tIns="45720" rIns="91440" bIns="45720" rtlCol="0">
-            <a:noAutofit/>
-          </a:bodyPr>
-          <a:lstStyle>
-            <a:lvl1pPr marL="228600" indent="-228600" algn="l" defTabSz="914400" rtl="0" eaLnBrk="1" latinLnBrk="0" hangingPunct="1">
-              <a:lnSpc>
-                <a:spcPct val="90000"/>
-              </a:lnSpc>
-              <a:spcBef>
-                <a:spcPts val="1000"/>
-              </a:spcBef>
-              <a:buFont typeface="Arial" panose="020B0604020202020204" pitchFamily="34" charset="0"/>
-              <a:buChar char="•"/>
-              <a:defRPr sz="2800" kern="1200">
-                <a:solidFill>
-                  <a:schemeClr val="tx1"/>
-                </a:solidFill>
-                <a:latin typeface="+mn-lt"/>
-                <a:ea typeface="+mn-ea"/>
-                <a:cs typeface="+mn-cs"/>
-              </a:defRPr>
-            </a:lvl1pPr>
-            <a:lvl2pPr marL="685800" indent="-228600" algn="l" defTabSz="914400" rtl="0" eaLnBrk="1" latinLnBrk="0" hangingPunct="1">
-              <a:lnSpc>
-                <a:spcPct val="90000"/>
-              </a:lnSpc>
-              <a:spcBef>
-                <a:spcPts val="500"/>
-              </a:spcBef>
-              <a:buFont typeface="Arial" panose="020B0604020202020204" pitchFamily="34" charset="0"/>
-              <a:buChar char="•"/>
-              <a:defRPr sz="2400" kern="1200">
-                <a:solidFill>
-                  <a:schemeClr val="tx1"/>
-                </a:solidFill>
-                <a:latin typeface="+mn-lt"/>
-                <a:ea typeface="+mn-ea"/>
-                <a:cs typeface="+mn-cs"/>
-              </a:defRPr>
-            </a:lvl2pPr>
-            <a:lvl3pPr marL="1143000" indent="-228600" algn="l" defTabSz="914400" rtl="0" eaLnBrk="1" latinLnBrk="0" hangingPunct="1">
-              <a:lnSpc>
-                <a:spcPct val="90000"/>
-              </a:lnSpc>
-              <a:spcBef>
-                <a:spcPts val="500"/>
-              </a:spcBef>
-              <a:buFont typeface="Arial" panose="020B0604020202020204" pitchFamily="34" charset="0"/>
-              <a:buChar char="•"/>
-              <a:defRPr sz="2000" kern="1200">
-                <a:solidFill>
-                  <a:schemeClr val="tx1"/>
-                </a:solidFill>
-                <a:latin typeface="+mn-lt"/>
-                <a:ea typeface="+mn-ea"/>
-                <a:cs typeface="+mn-cs"/>
-              </a:defRPr>
-            </a:lvl3pPr>
-            <a:lvl4pPr marL="1600200" indent="-228600" algn="l" defTabSz="914400" rtl="0" eaLnBrk="1" latinLnBrk="0" hangingPunct="1">
-              <a:lnSpc>
-                <a:spcPct val="90000"/>
-              </a:lnSpc>
-              <a:spcBef>
-                <a:spcPts val="500"/>
-              </a:spcBef>
-              <a:buFont typeface="Arial" panose="020B0604020202020204" pitchFamily="34" charset="0"/>
-              <a:buChar char="•"/>
-              <a:defRPr sz="1800" kern="1200">
-                <a:solidFill>
-                  <a:schemeClr val="tx1"/>
-                </a:solidFill>
-                <a:latin typeface="+mn-lt"/>
-                <a:ea typeface="+mn-ea"/>
-                <a:cs typeface="+mn-cs"/>
-              </a:defRPr>
-            </a:lvl4pPr>
-            <a:lvl5pPr marL="2057400" indent="-228600" algn="l" defTabSz="914400" rtl="0" eaLnBrk="1" latinLnBrk="0" hangingPunct="1">
-              <a:lnSpc>
-                <a:spcPct val="90000"/>
-              </a:lnSpc>
-              <a:spcBef>
-                <a:spcPts val="500"/>
-              </a:spcBef>
-              <a:buFont typeface="Arial" panose="020B0604020202020204" pitchFamily="34" charset="0"/>
-              <a:buChar char="•"/>
-              <a:defRPr sz="1800" kern="1200">
-                <a:solidFill>
-                  <a:schemeClr val="tx1"/>
-                </a:solidFill>
-                <a:latin typeface="+mn-lt"/>
-                <a:ea typeface="+mn-ea"/>
-                <a:cs typeface="+mn-cs"/>
-              </a:defRPr>
-            </a:lvl5pPr>
-            <a:lvl6pPr marL="2514600" indent="-228600" algn="l" defTabSz="914400" rtl="0" eaLnBrk="1" latinLnBrk="0" hangingPunct="1">
-              <a:lnSpc>
-                <a:spcPct val="90000"/>
-              </a:lnSpc>
-              <a:spcBef>
-                <a:spcPts val="500"/>
-              </a:spcBef>
-              <a:buFont typeface="Arial" panose="020B0604020202020204" pitchFamily="34" charset="0"/>
-              <a:buChar char="•"/>
-              <a:defRPr sz="1800" kern="1200">
-                <a:solidFill>
-                  <a:schemeClr val="tx1"/>
-                </a:solidFill>
-                <a:latin typeface="+mn-lt"/>
-                <a:ea typeface="+mn-ea"/>
-                <a:cs typeface="+mn-cs"/>
-              </a:defRPr>
-            </a:lvl6pPr>
-            <a:lvl7pPr marL="2971800" indent="-228600" algn="l" defTabSz="914400" rtl="0" eaLnBrk="1" latinLnBrk="0" hangingPunct="1">
-              <a:lnSpc>
-                <a:spcPct val="90000"/>
-              </a:lnSpc>
-              <a:spcBef>
-                <a:spcPts val="500"/>
-              </a:spcBef>
-              <a:buFont typeface="Arial" panose="020B0604020202020204" pitchFamily="34" charset="0"/>
-              <a:buChar char="•"/>
-              <a:defRPr sz="1800" kern="1200">
-                <a:solidFill>
-                  <a:schemeClr val="tx1"/>
-                </a:solidFill>
-                <a:latin typeface="+mn-lt"/>
-                <a:ea typeface="+mn-ea"/>
-                <a:cs typeface="+mn-cs"/>
-              </a:defRPr>
-            </a:lvl7pPr>
-            <a:lvl8pPr marL="3429000" indent="-228600" algn="l" defTabSz="914400" rtl="0" eaLnBrk="1" latinLnBrk="0" hangingPunct="1">
-              <a:lnSpc>
-                <a:spcPct val="90000"/>
-              </a:lnSpc>
-              <a:spcBef>
-                <a:spcPts val="500"/>
-              </a:spcBef>
-              <a:buFont typeface="Arial" panose="020B0604020202020204" pitchFamily="34" charset="0"/>
-              <a:buChar char="•"/>
-              <a:defRPr sz="1800" kern="1200">
-                <a:solidFill>
-                  <a:schemeClr val="tx1"/>
-                </a:solidFill>
-                <a:latin typeface="+mn-lt"/>
-                <a:ea typeface="+mn-ea"/>
-                <a:cs typeface="+mn-cs"/>
-              </a:defRPr>
-            </a:lvl8pPr>
-            <a:lvl9pPr marL="3886200" indent="-228600" algn="l" defTabSz="914400" rtl="0" eaLnBrk="1" latinLnBrk="0" hangingPunct="1">
-              <a:lnSpc>
-                <a:spcPct val="90000"/>
-              </a:lnSpc>
-              <a:spcBef>
-                <a:spcPts val="500"/>
-              </a:spcBef>
-              <a:buFont typeface="Arial" panose="020B0604020202020204" pitchFamily="34" charset="0"/>
-              <a:buChar char="•"/>
-              <a:defRPr sz="1800" kern="1200">
-                <a:solidFill>
-                  <a:schemeClr val="tx1"/>
-                </a:solidFill>
-                <a:latin typeface="+mn-lt"/>
-                <a:ea typeface="+mn-ea"/>
-                <a:cs typeface="+mn-cs"/>
-              </a:defRPr>
-            </a:lvl9pPr>
-          </a:lstStyle>
-          <a:p>
-            <a:pPr marL="0" marR="0" lvl="0" indent="0" algn="l" defTabSz="914400" rtl="0" eaLnBrk="1" fontAlgn="auto" latinLnBrk="0" hangingPunct="1">
-              <a:lnSpc>
-                <a:spcPct val="100000"/>
-              </a:lnSpc>
-              <a:spcBef>
-                <a:spcPts val="1000"/>
-              </a:spcBef>
-              <a:spcAft>
-                <a:spcPts val="0"/>
-              </a:spcAft>
-              <a:buClrTx/>
-              <a:buSzTx/>
-              <a:buFont typeface="Arial" panose="020B0604020202020204" pitchFamily="34" charset="0"/>
-              <a:buNone/>
-              <a:tabLst/>
-              <a:defRPr/>
-            </a:pPr>
-            <a:endParaRPr kumimoji="0" lang="en-US" sz="1100" b="0" i="0" u="none" strike="noStrike" kern="1200" cap="none" spc="0" normalizeH="0" baseline="0" noProof="0" dirty="0">
-              <a:ln>
-                <a:noFill/>
-              </a:ln>
-              <a:solidFill>
-                <a:prstClr val="black"/>
-              </a:solidFill>
-              <a:effectLst/>
-              <a:highlight>
-                <a:srgbClr val="FFFF00"/>
-              </a:highlight>
-              <a:uLnTx/>
-              <a:uFillTx/>
-              <a:latin typeface="Calibri" panose="020F0502020204030204"/>
-              <a:ea typeface="+mn-ea"/>
-              <a:cs typeface="+mn-cs"/>
-            </a:endParaRPr>
-          </a:p>
-        </p:txBody>
-      </p:sp>
     </p:spTree>
   </p:cSld>
   <p:clrMapOvr>

</xml_diff>